<commit_message>
finished day 1 and index render
Finished the quarto content for day 1 and modified the index so all the quarto materials will render
</commit_message>
<xml_diff>
--- a/day1_material/slides/day1.pptx
+++ b/day1_material/slides/day1.pptx
@@ -5,17 +5,24 @@
     <p:sldMasterId id="2147483648" r:id="rId1"/>
   </p:sldMasterIdLst>
   <p:notesMasterIdLst>
-    <p:notesMasterId r:id="rId10"/>
+    <p:notesMasterId r:id="rId17"/>
   </p:notesMasterIdLst>
   <p:sldIdLst>
     <p:sldId id="256" r:id="rId2"/>
-    <p:sldId id="257" r:id="rId3"/>
-    <p:sldId id="259" r:id="rId4"/>
-    <p:sldId id="258" r:id="rId5"/>
-    <p:sldId id="260" r:id="rId6"/>
-    <p:sldId id="271" r:id="rId7"/>
-    <p:sldId id="270" r:id="rId8"/>
-    <p:sldId id="272" r:id="rId9"/>
+    <p:sldId id="273" r:id="rId3"/>
+    <p:sldId id="274" r:id="rId4"/>
+    <p:sldId id="257" r:id="rId5"/>
+    <p:sldId id="259" r:id="rId6"/>
+    <p:sldId id="258" r:id="rId7"/>
+    <p:sldId id="260" r:id="rId8"/>
+    <p:sldId id="271" r:id="rId9"/>
+    <p:sldId id="270" r:id="rId10"/>
+    <p:sldId id="272" r:id="rId11"/>
+    <p:sldId id="276" r:id="rId12"/>
+    <p:sldId id="282" r:id="rId13"/>
+    <p:sldId id="275" r:id="rId14"/>
+    <p:sldId id="281" r:id="rId15"/>
+    <p:sldId id="277" r:id="rId16"/>
   </p:sldIdLst>
   <p:sldSz cx="12192000" cy="6858000"/>
   <p:notesSz cx="6858000" cy="9144000"/>
@@ -204,7 +211,7 @@
           <a:p>
             <a:fld id="{09C84A49-CA76-E84D-B4CB-59BA5B0597A2}" type="datetimeFigureOut">
               <a:rPr lang="en-US" smtClean="0"/>
-              <a:t>8/20/26</a:t>
+              <a:t>8/21/26</a:t>
             </a:fld>
             <a:endParaRPr lang="en-US"/>
           </a:p>
@@ -536,7 +543,7 @@
           <a:p>
             <a:fld id="{F57EA08E-C47D-AB46-A93F-BAC6507A654E}" type="slidenum">
               <a:rPr lang="en-US" smtClean="0"/>
-              <a:t>2</a:t>
+              <a:t>4</a:t>
             </a:fld>
             <a:endParaRPr lang="en-US"/>
           </a:p>
@@ -702,7 +709,7 @@
           <a:p>
             <a:fld id="{EC483935-07C3-DB40-BDCF-E55515B19C93}" type="datetimeFigureOut">
               <a:rPr lang="en-US" smtClean="0"/>
-              <a:t>8/20/26</a:t>
+              <a:t>8/21/26</a:t>
             </a:fld>
             <a:endParaRPr lang="en-US"/>
           </a:p>
@@ -900,7 +907,7 @@
           <a:p>
             <a:fld id="{EC483935-07C3-DB40-BDCF-E55515B19C93}" type="datetimeFigureOut">
               <a:rPr lang="en-US" smtClean="0"/>
-              <a:t>8/20/26</a:t>
+              <a:t>8/21/26</a:t>
             </a:fld>
             <a:endParaRPr lang="en-US"/>
           </a:p>
@@ -1108,7 +1115,7 @@
           <a:p>
             <a:fld id="{EC483935-07C3-DB40-BDCF-E55515B19C93}" type="datetimeFigureOut">
               <a:rPr lang="en-US" smtClean="0"/>
-              <a:t>8/20/26</a:t>
+              <a:t>8/21/26</a:t>
             </a:fld>
             <a:endParaRPr lang="en-US"/>
           </a:p>
@@ -1306,7 +1313,7 @@
           <a:p>
             <a:fld id="{EC483935-07C3-DB40-BDCF-E55515B19C93}" type="datetimeFigureOut">
               <a:rPr lang="en-US" smtClean="0"/>
-              <a:t>8/20/26</a:t>
+              <a:t>8/21/26</a:t>
             </a:fld>
             <a:endParaRPr lang="en-US"/>
           </a:p>
@@ -1581,7 +1588,7 @@
           <a:p>
             <a:fld id="{EC483935-07C3-DB40-BDCF-E55515B19C93}" type="datetimeFigureOut">
               <a:rPr lang="en-US" smtClean="0"/>
-              <a:t>8/20/26</a:t>
+              <a:t>8/21/26</a:t>
             </a:fld>
             <a:endParaRPr lang="en-US"/>
           </a:p>
@@ -1846,7 +1853,7 @@
           <a:p>
             <a:fld id="{EC483935-07C3-DB40-BDCF-E55515B19C93}" type="datetimeFigureOut">
               <a:rPr lang="en-US" smtClean="0"/>
-              <a:t>8/20/26</a:t>
+              <a:t>8/21/26</a:t>
             </a:fld>
             <a:endParaRPr lang="en-US"/>
           </a:p>
@@ -2258,7 +2265,7 @@
           <a:p>
             <a:fld id="{EC483935-07C3-DB40-BDCF-E55515B19C93}" type="datetimeFigureOut">
               <a:rPr lang="en-US" smtClean="0"/>
-              <a:t>8/20/26</a:t>
+              <a:t>8/21/26</a:t>
             </a:fld>
             <a:endParaRPr lang="en-US"/>
           </a:p>
@@ -2399,7 +2406,7 @@
           <a:p>
             <a:fld id="{EC483935-07C3-DB40-BDCF-E55515B19C93}" type="datetimeFigureOut">
               <a:rPr lang="en-US" smtClean="0"/>
-              <a:t>8/20/26</a:t>
+              <a:t>8/21/26</a:t>
             </a:fld>
             <a:endParaRPr lang="en-US"/>
           </a:p>
@@ -2512,7 +2519,7 @@
           <a:p>
             <a:fld id="{EC483935-07C3-DB40-BDCF-E55515B19C93}" type="datetimeFigureOut">
               <a:rPr lang="en-US" smtClean="0"/>
-              <a:t>8/20/26</a:t>
+              <a:t>8/21/26</a:t>
             </a:fld>
             <a:endParaRPr lang="en-US"/>
           </a:p>
@@ -2823,7 +2830,7 @@
           <a:p>
             <a:fld id="{EC483935-07C3-DB40-BDCF-E55515B19C93}" type="datetimeFigureOut">
               <a:rPr lang="en-US" smtClean="0"/>
-              <a:t>8/20/26</a:t>
+              <a:t>8/21/26</a:t>
             </a:fld>
             <a:endParaRPr lang="en-US"/>
           </a:p>
@@ -3111,7 +3118,7 @@
           <a:p>
             <a:fld id="{EC483935-07C3-DB40-BDCF-E55515B19C93}" type="datetimeFigureOut">
               <a:rPr lang="en-US" smtClean="0"/>
-              <a:t>8/20/26</a:t>
+              <a:t>8/21/26</a:t>
             </a:fld>
             <a:endParaRPr lang="en-US"/>
           </a:p>
@@ -3352,7 +3359,7 @@
           <a:p>
             <a:fld id="{EC483935-07C3-DB40-BDCF-E55515B19C93}" type="datetimeFigureOut">
               <a:rPr lang="en-US" smtClean="0"/>
-              <a:t>8/20/26</a:t>
+              <a:t>8/21/26</a:t>
             </a:fld>
             <a:endParaRPr lang="en-US"/>
           </a:p>
@@ -3771,54 +3778,93 @@
       </p:grpSpPr>
       <p:sp>
         <p:nvSpPr>
-          <p:cNvPr id="2" name="Title 1">
-            <a:extLst>
-              <a:ext uri="{FF2B5EF4-FFF2-40B4-BE49-F238E27FC236}">
-                <a16:creationId xmlns:a16="http://schemas.microsoft.com/office/drawing/2014/main" id="{D78D28C2-B82D-878A-1EC0-D2E3452AA6E1}"/>
-              </a:ext>
-            </a:extLst>
-          </p:cNvPr>
-          <p:cNvSpPr>
-            <a:spLocks noGrp="1"/>
-          </p:cNvSpPr>
-          <p:nvPr>
-            <p:ph type="ctrTitle"/>
-          </p:nvPr>
-        </p:nvSpPr>
-        <p:spPr/>
-        <p:txBody>
-          <a:bodyPr/>
-          <a:lstStyle/>
-          <a:p>
-            <a:endParaRPr lang="en-US"/>
-          </a:p>
-        </p:txBody>
-      </p:sp>
-      <p:sp>
-        <p:nvSpPr>
-          <p:cNvPr id="3" name="Subtitle 2">
-            <a:extLst>
-              <a:ext uri="{FF2B5EF4-FFF2-40B4-BE49-F238E27FC236}">
-                <a16:creationId xmlns:a16="http://schemas.microsoft.com/office/drawing/2014/main" id="{FFF0FEA8-67A3-23A3-4DB5-2B1AF6BA04CF}"/>
-              </a:ext>
-            </a:extLst>
-          </p:cNvPr>
-          <p:cNvSpPr>
-            <a:spLocks noGrp="1"/>
-          </p:cNvSpPr>
-          <p:nvPr>
-            <p:ph type="subTitle" idx="1"/>
-          </p:nvPr>
-        </p:nvSpPr>
-        <p:spPr/>
-        <p:txBody>
-          <a:bodyPr/>
-          <a:lstStyle/>
-          <a:p>
-            <a:endParaRPr lang="en-US"/>
-          </a:p>
-        </p:txBody>
-      </p:sp>
+          <p:cNvPr id="5" name="TextBox 4">
+            <a:extLst>
+              <a:ext uri="{FF2B5EF4-FFF2-40B4-BE49-F238E27FC236}">
+                <a16:creationId xmlns:a16="http://schemas.microsoft.com/office/drawing/2014/main" id="{CDF3AD32-1F0F-9CEC-3E2C-06972B53A20D}"/>
+              </a:ext>
+            </a:extLst>
+          </p:cNvPr>
+          <p:cNvSpPr txBox="1"/>
+          <p:nvPr/>
+        </p:nvSpPr>
+        <p:spPr>
+          <a:xfrm>
+            <a:off x="1497795" y="1862666"/>
+            <a:ext cx="5704575" cy="4524315"/>
+          </a:xfrm>
+          <a:prstGeom prst="rect">
+            <a:avLst/>
+          </a:prstGeom>
+          <a:noFill/>
+        </p:spPr>
+        <p:txBody>
+          <a:bodyPr wrap="none" rtlCol="0">
+            <a:spAutoFit/>
+          </a:bodyPr>
+          <a:lstStyle/>
+          <a:p>
+            <a:r>
+              <a:rPr lang="en-US" sz="9600" dirty="0">
+                <a:solidFill>
+                  <a:srgbClr val="C00000"/>
+                </a:solidFill>
+                <a:latin typeface="Helvetica" pitchFamily="2" charset="0"/>
+              </a:rPr>
+              <a:t>BRC’s</a:t>
+            </a:r>
+          </a:p>
+          <a:p>
+            <a:r>
+              <a:rPr lang="en-US" sz="9600" dirty="0" err="1">
+                <a:latin typeface="Helvetica" pitchFamily="2" charset="0"/>
+              </a:rPr>
+              <a:t>Nextflow</a:t>
+            </a:r>
+            <a:endParaRPr lang="en-US" sz="9600" dirty="0">
+              <a:latin typeface="Helvetica" pitchFamily="2" charset="0"/>
+            </a:endParaRPr>
+          </a:p>
+          <a:p>
+            <a:r>
+              <a:rPr lang="en-US" sz="9600" dirty="0">
+                <a:latin typeface="Helvetica" pitchFamily="2" charset="0"/>
+              </a:rPr>
+              <a:t>Workshop</a:t>
+            </a:r>
+          </a:p>
+        </p:txBody>
+      </p:sp>
+      <p:pic>
+        <p:nvPicPr>
+          <p:cNvPr id="7" name="Picture 6" descr="GitHub - nextflow-io/nextflow: A DSL for data-driven computational  pipelines · GitHub">
+            <a:extLst>
+              <a:ext uri="{FF2B5EF4-FFF2-40B4-BE49-F238E27FC236}">
+                <a16:creationId xmlns:a16="http://schemas.microsoft.com/office/drawing/2014/main" id="{DA94C7D1-5142-F524-0DC3-F8532D5DEF55}"/>
+              </a:ext>
+            </a:extLst>
+          </p:cNvPr>
+          <p:cNvPicPr>
+            <a:picLocks noChangeAspect="1"/>
+          </p:cNvPicPr>
+          <p:nvPr/>
+        </p:nvPicPr>
+        <p:blipFill>
+          <a:blip r:embed="rId2"/>
+          <a:stretch>
+            <a:fillRect/>
+          </a:stretch>
+        </p:blipFill>
+        <p:spPr>
+          <a:xfrm>
+            <a:off x="6563341" y="-938043"/>
+            <a:ext cx="6570132" cy="6570132"/>
+          </a:xfrm>
+          <a:prstGeom prst="rect">
+            <a:avLst/>
+          </a:prstGeom>
+        </p:spPr>
+      </p:pic>
     </p:spTree>
     <p:extLst>
       <p:ext uri="{BB962C8B-B14F-4D97-AF65-F5344CB8AC3E}">
@@ -3832,7 +3878,3551 @@
 </p:sld>
 </file>
 
+<file path=ppt/slides/slide10.xml><?xml version="1.0" encoding="utf-8"?>
+<p:sld xmlns:a="http://schemas.openxmlformats.org/drawingml/2006/main" xmlns:r="http://schemas.openxmlformats.org/officeDocument/2006/relationships" xmlns:p="http://schemas.openxmlformats.org/presentationml/2006/main">
+  <p:cSld>
+    <p:spTree>
+      <p:nvGrpSpPr>
+        <p:cNvPr id="1" name="">
+          <a:extLst>
+            <a:ext uri="{FF2B5EF4-FFF2-40B4-BE49-F238E27FC236}">
+              <a16:creationId xmlns:a16="http://schemas.microsoft.com/office/drawing/2014/main" id="{E3AD97CB-B8A2-C139-67D1-19D621A2F549}"/>
+            </a:ext>
+          </a:extLst>
+        </p:cNvPr>
+        <p:cNvGrpSpPr/>
+        <p:nvPr/>
+      </p:nvGrpSpPr>
+      <p:grpSpPr>
+        <a:xfrm>
+          <a:off x="0" y="0"/>
+          <a:ext cx="0" cy="0"/>
+          <a:chOff x="0" y="0"/>
+          <a:chExt cx="0" cy="0"/>
+        </a:xfrm>
+      </p:grpSpPr>
+      <p:sp>
+        <p:nvSpPr>
+          <p:cNvPr id="8" name="Title 1">
+            <a:extLst>
+              <a:ext uri="{FF2B5EF4-FFF2-40B4-BE49-F238E27FC236}">
+                <a16:creationId xmlns:a16="http://schemas.microsoft.com/office/drawing/2014/main" id="{7336D5C8-7018-6AAC-AA60-DC2E2C108243}"/>
+              </a:ext>
+            </a:extLst>
+          </p:cNvPr>
+          <p:cNvSpPr>
+            <a:spLocks noGrp="1"/>
+          </p:cNvSpPr>
+          <p:nvPr>
+            <p:ph type="title"/>
+          </p:nvPr>
+        </p:nvSpPr>
+        <p:spPr>
+          <a:xfrm>
+            <a:off x="838200" y="365125"/>
+            <a:ext cx="10515600" cy="1325563"/>
+          </a:xfrm>
+        </p:spPr>
+        <p:txBody>
+          <a:bodyPr/>
+          <a:lstStyle/>
+          <a:p>
+            <a:r>
+              <a:rPr lang="en-US" dirty="0"/>
+              <a:t>Processes</a:t>
+            </a:r>
+          </a:p>
+        </p:txBody>
+      </p:sp>
+      <p:sp>
+        <p:nvSpPr>
+          <p:cNvPr id="10" name="Rectangle 9">
+            <a:extLst>
+              <a:ext uri="{FF2B5EF4-FFF2-40B4-BE49-F238E27FC236}">
+                <a16:creationId xmlns:a16="http://schemas.microsoft.com/office/drawing/2014/main" id="{74EBEBF9-FD16-4830-389A-C0EE85FF218B}"/>
+              </a:ext>
+            </a:extLst>
+          </p:cNvPr>
+          <p:cNvSpPr/>
+          <p:nvPr/>
+        </p:nvSpPr>
+        <p:spPr>
+          <a:xfrm>
+            <a:off x="662871" y="2841171"/>
+            <a:ext cx="1413164" cy="587829"/>
+          </a:xfrm>
+          <a:prstGeom prst="rect">
+            <a:avLst/>
+          </a:prstGeom>
+        </p:spPr>
+        <p:style>
+          <a:lnRef idx="2">
+            <a:schemeClr val="dk1"/>
+          </a:lnRef>
+          <a:fillRef idx="1">
+            <a:schemeClr val="lt1"/>
+          </a:fillRef>
+          <a:effectRef idx="0">
+            <a:schemeClr val="dk1"/>
+          </a:effectRef>
+          <a:fontRef idx="minor">
+            <a:schemeClr val="dk1"/>
+          </a:fontRef>
+        </p:style>
+        <p:txBody>
+          <a:bodyPr rtlCol="0" anchor="ctr"/>
+          <a:lstStyle/>
+          <a:p>
+            <a:pPr algn="ctr"/>
+            <a:r>
+              <a:rPr lang="en-US" dirty="0"/>
+              <a:t>Raw reads</a:t>
+            </a:r>
+          </a:p>
+        </p:txBody>
+      </p:sp>
+      <p:sp>
+        <p:nvSpPr>
+          <p:cNvPr id="11" name="Rectangle 10">
+            <a:extLst>
+              <a:ext uri="{FF2B5EF4-FFF2-40B4-BE49-F238E27FC236}">
+                <a16:creationId xmlns:a16="http://schemas.microsoft.com/office/drawing/2014/main" id="{EA32FA45-5CE0-546E-8507-1E41FF311C28}"/>
+              </a:ext>
+            </a:extLst>
+          </p:cNvPr>
+          <p:cNvSpPr/>
+          <p:nvPr/>
+        </p:nvSpPr>
+        <p:spPr>
+          <a:xfrm>
+            <a:off x="3410639" y="2323437"/>
+            <a:ext cx="1413164" cy="587829"/>
+          </a:xfrm>
+          <a:prstGeom prst="rect">
+            <a:avLst/>
+          </a:prstGeom>
+          <a:ln>
+            <a:noFill/>
+          </a:ln>
+        </p:spPr>
+        <p:style>
+          <a:lnRef idx="2">
+            <a:schemeClr val="accent2">
+              <a:shade val="15000"/>
+            </a:schemeClr>
+          </a:lnRef>
+          <a:fillRef idx="1">
+            <a:schemeClr val="accent2"/>
+          </a:fillRef>
+          <a:effectRef idx="0">
+            <a:schemeClr val="accent2"/>
+          </a:effectRef>
+          <a:fontRef idx="minor">
+            <a:schemeClr val="lt1"/>
+          </a:fontRef>
+        </p:style>
+        <p:txBody>
+          <a:bodyPr rtlCol="0" anchor="ctr"/>
+          <a:lstStyle/>
+          <a:p>
+            <a:pPr algn="ctr"/>
+            <a:r>
+              <a:rPr lang="en-US" dirty="0" err="1"/>
+              <a:t>FastQC</a:t>
+            </a:r>
+            <a:endParaRPr lang="en-US" dirty="0"/>
+          </a:p>
+        </p:txBody>
+      </p:sp>
+      <p:sp>
+        <p:nvSpPr>
+          <p:cNvPr id="12" name="Rectangle 11">
+            <a:extLst>
+              <a:ext uri="{FF2B5EF4-FFF2-40B4-BE49-F238E27FC236}">
+                <a16:creationId xmlns:a16="http://schemas.microsoft.com/office/drawing/2014/main" id="{B83C6B10-0A5B-D19F-2051-E7A46BA24C95}"/>
+              </a:ext>
+            </a:extLst>
+          </p:cNvPr>
+          <p:cNvSpPr/>
+          <p:nvPr/>
+        </p:nvSpPr>
+        <p:spPr>
+          <a:xfrm>
+            <a:off x="3410639" y="3411186"/>
+            <a:ext cx="1506186" cy="587829"/>
+          </a:xfrm>
+          <a:prstGeom prst="rect">
+            <a:avLst/>
+          </a:prstGeom>
+          <a:ln>
+            <a:noFill/>
+          </a:ln>
+        </p:spPr>
+        <p:style>
+          <a:lnRef idx="2">
+            <a:schemeClr val="accent2">
+              <a:shade val="15000"/>
+            </a:schemeClr>
+          </a:lnRef>
+          <a:fillRef idx="1">
+            <a:schemeClr val="accent2"/>
+          </a:fillRef>
+          <a:effectRef idx="0">
+            <a:schemeClr val="accent2"/>
+          </a:effectRef>
+          <a:fontRef idx="minor">
+            <a:schemeClr val="lt1"/>
+          </a:fontRef>
+        </p:style>
+        <p:txBody>
+          <a:bodyPr rtlCol="0" anchor="ctr"/>
+          <a:lstStyle/>
+          <a:p>
+            <a:pPr algn="ctr"/>
+            <a:r>
+              <a:rPr lang="en-US" dirty="0" err="1"/>
+              <a:t>Trimmomatic</a:t>
+            </a:r>
+            <a:endParaRPr lang="en-US" dirty="0"/>
+          </a:p>
+        </p:txBody>
+      </p:sp>
+      <p:sp>
+        <p:nvSpPr>
+          <p:cNvPr id="13" name="Rectangle 12">
+            <a:extLst>
+              <a:ext uri="{FF2B5EF4-FFF2-40B4-BE49-F238E27FC236}">
+                <a16:creationId xmlns:a16="http://schemas.microsoft.com/office/drawing/2014/main" id="{9D4239F9-1627-FE39-63B3-2B78B5B17BA1}"/>
+              </a:ext>
+            </a:extLst>
+          </p:cNvPr>
+          <p:cNvSpPr/>
+          <p:nvPr/>
+        </p:nvSpPr>
+        <p:spPr>
+          <a:xfrm>
+            <a:off x="8074780" y="3008199"/>
+            <a:ext cx="1413164" cy="587829"/>
+          </a:xfrm>
+          <a:prstGeom prst="rect">
+            <a:avLst/>
+          </a:prstGeom>
+          <a:ln>
+            <a:noFill/>
+          </a:ln>
+        </p:spPr>
+        <p:style>
+          <a:lnRef idx="2">
+            <a:schemeClr val="accent2">
+              <a:shade val="15000"/>
+            </a:schemeClr>
+          </a:lnRef>
+          <a:fillRef idx="1">
+            <a:schemeClr val="accent2"/>
+          </a:fillRef>
+          <a:effectRef idx="0">
+            <a:schemeClr val="accent2"/>
+          </a:effectRef>
+          <a:fontRef idx="minor">
+            <a:schemeClr val="lt1"/>
+          </a:fontRef>
+        </p:style>
+        <p:txBody>
+          <a:bodyPr rtlCol="0" anchor="ctr"/>
+          <a:lstStyle/>
+          <a:p>
+            <a:pPr algn="ctr"/>
+            <a:r>
+              <a:rPr lang="en-US" dirty="0" err="1"/>
+              <a:t>FastQC</a:t>
+            </a:r>
+            <a:endParaRPr lang="en-US" dirty="0"/>
+          </a:p>
+        </p:txBody>
+      </p:sp>
+      <p:sp>
+        <p:nvSpPr>
+          <p:cNvPr id="14" name="Rectangle 13">
+            <a:extLst>
+              <a:ext uri="{FF2B5EF4-FFF2-40B4-BE49-F238E27FC236}">
+                <a16:creationId xmlns:a16="http://schemas.microsoft.com/office/drawing/2014/main" id="{601C7A4E-08D3-7E28-8122-BCE11DC926B3}"/>
+              </a:ext>
+            </a:extLst>
+          </p:cNvPr>
+          <p:cNvSpPr/>
+          <p:nvPr/>
+        </p:nvSpPr>
+        <p:spPr>
+          <a:xfrm>
+            <a:off x="5703074" y="2323437"/>
+            <a:ext cx="1413164" cy="587829"/>
+          </a:xfrm>
+          <a:prstGeom prst="rect">
+            <a:avLst/>
+          </a:prstGeom>
+        </p:spPr>
+        <p:style>
+          <a:lnRef idx="2">
+            <a:schemeClr val="dk1"/>
+          </a:lnRef>
+          <a:fillRef idx="1">
+            <a:schemeClr val="lt1"/>
+          </a:fillRef>
+          <a:effectRef idx="0">
+            <a:schemeClr val="dk1"/>
+          </a:effectRef>
+          <a:fontRef idx="minor">
+            <a:schemeClr val="dk1"/>
+          </a:fontRef>
+        </p:style>
+        <p:txBody>
+          <a:bodyPr rtlCol="0" anchor="ctr"/>
+          <a:lstStyle/>
+          <a:p>
+            <a:pPr algn="ctr"/>
+            <a:r>
+              <a:rPr lang="en-US" dirty="0"/>
+              <a:t>Quality report</a:t>
+            </a:r>
+          </a:p>
+        </p:txBody>
+      </p:sp>
+      <p:sp>
+        <p:nvSpPr>
+          <p:cNvPr id="15" name="Rectangle 14">
+            <a:extLst>
+              <a:ext uri="{FF2B5EF4-FFF2-40B4-BE49-F238E27FC236}">
+                <a16:creationId xmlns:a16="http://schemas.microsoft.com/office/drawing/2014/main" id="{913B5712-BA3C-192F-AD9B-BF8DB8DBC49A}"/>
+              </a:ext>
+            </a:extLst>
+          </p:cNvPr>
+          <p:cNvSpPr/>
+          <p:nvPr/>
+        </p:nvSpPr>
+        <p:spPr>
+          <a:xfrm>
+            <a:off x="10208988" y="2989849"/>
+            <a:ext cx="1413164" cy="587829"/>
+          </a:xfrm>
+          <a:prstGeom prst="rect">
+            <a:avLst/>
+          </a:prstGeom>
+        </p:spPr>
+        <p:style>
+          <a:lnRef idx="2">
+            <a:schemeClr val="dk1"/>
+          </a:lnRef>
+          <a:fillRef idx="1">
+            <a:schemeClr val="lt1"/>
+          </a:fillRef>
+          <a:effectRef idx="0">
+            <a:schemeClr val="dk1"/>
+          </a:effectRef>
+          <a:fontRef idx="minor">
+            <a:schemeClr val="dk1"/>
+          </a:fontRef>
+        </p:style>
+        <p:txBody>
+          <a:bodyPr rtlCol="0" anchor="ctr"/>
+          <a:lstStyle/>
+          <a:p>
+            <a:pPr algn="ctr"/>
+            <a:r>
+              <a:rPr lang="en-US" dirty="0"/>
+              <a:t>Quality report</a:t>
+            </a:r>
+          </a:p>
+        </p:txBody>
+      </p:sp>
+      <p:sp>
+        <p:nvSpPr>
+          <p:cNvPr id="16" name="Rectangle 15">
+            <a:extLst>
+              <a:ext uri="{FF2B5EF4-FFF2-40B4-BE49-F238E27FC236}">
+                <a16:creationId xmlns:a16="http://schemas.microsoft.com/office/drawing/2014/main" id="{3D213401-9B8D-ADDA-CBFA-8FE8F9047E78}"/>
+              </a:ext>
+            </a:extLst>
+          </p:cNvPr>
+          <p:cNvSpPr/>
+          <p:nvPr/>
+        </p:nvSpPr>
+        <p:spPr>
+          <a:xfrm>
+            <a:off x="5730667" y="3403531"/>
+            <a:ext cx="1413164" cy="587829"/>
+          </a:xfrm>
+          <a:prstGeom prst="rect">
+            <a:avLst/>
+          </a:prstGeom>
+        </p:spPr>
+        <p:style>
+          <a:lnRef idx="2">
+            <a:schemeClr val="dk1"/>
+          </a:lnRef>
+          <a:fillRef idx="1">
+            <a:schemeClr val="lt1"/>
+          </a:fillRef>
+          <a:effectRef idx="0">
+            <a:schemeClr val="dk1"/>
+          </a:effectRef>
+          <a:fontRef idx="minor">
+            <a:schemeClr val="dk1"/>
+          </a:fontRef>
+        </p:style>
+        <p:txBody>
+          <a:bodyPr rtlCol="0" anchor="ctr"/>
+          <a:lstStyle/>
+          <a:p>
+            <a:pPr algn="ctr"/>
+            <a:r>
+              <a:rPr lang="en-US" dirty="0"/>
+              <a:t>Clean reads</a:t>
+            </a:r>
+          </a:p>
+        </p:txBody>
+      </p:sp>
+      <p:cxnSp>
+        <p:nvCxnSpPr>
+          <p:cNvPr id="18" name="Straight Arrow Connector 17">
+            <a:extLst>
+              <a:ext uri="{FF2B5EF4-FFF2-40B4-BE49-F238E27FC236}">
+                <a16:creationId xmlns:a16="http://schemas.microsoft.com/office/drawing/2014/main" id="{951783CE-1317-F7ED-B505-1B8527F88840}"/>
+              </a:ext>
+            </a:extLst>
+          </p:cNvPr>
+          <p:cNvCxnSpPr>
+            <a:cxnSpLocks/>
+          </p:cNvCxnSpPr>
+          <p:nvPr/>
+        </p:nvCxnSpPr>
+        <p:spPr>
+          <a:xfrm flipV="1">
+            <a:off x="2174566" y="2642260"/>
+            <a:ext cx="964708" cy="442617"/>
+          </a:xfrm>
+          <a:prstGeom prst="straightConnector1">
+            <a:avLst/>
+          </a:prstGeom>
+          <a:ln w="28575">
+            <a:solidFill>
+              <a:schemeClr val="bg1">
+                <a:lumMod val="50000"/>
+              </a:schemeClr>
+            </a:solidFill>
+            <a:tailEnd type="triangle"/>
+          </a:ln>
+        </p:spPr>
+        <p:style>
+          <a:lnRef idx="1">
+            <a:schemeClr val="accent1"/>
+          </a:lnRef>
+          <a:fillRef idx="0">
+            <a:schemeClr val="accent1"/>
+          </a:fillRef>
+          <a:effectRef idx="0">
+            <a:schemeClr val="accent1"/>
+          </a:effectRef>
+          <a:fontRef idx="minor">
+            <a:schemeClr val="tx1"/>
+          </a:fontRef>
+        </p:style>
+      </p:cxnSp>
+      <p:cxnSp>
+        <p:nvCxnSpPr>
+          <p:cNvPr id="21" name="Straight Arrow Connector 20">
+            <a:extLst>
+              <a:ext uri="{FF2B5EF4-FFF2-40B4-BE49-F238E27FC236}">
+                <a16:creationId xmlns:a16="http://schemas.microsoft.com/office/drawing/2014/main" id="{47695FAF-8D51-0A43-5988-FE4DD948F635}"/>
+              </a:ext>
+            </a:extLst>
+          </p:cNvPr>
+          <p:cNvCxnSpPr>
+            <a:cxnSpLocks/>
+          </p:cNvCxnSpPr>
+          <p:nvPr/>
+        </p:nvCxnSpPr>
+        <p:spPr>
+          <a:xfrm>
+            <a:off x="2174566" y="3160087"/>
+            <a:ext cx="918956" cy="479700"/>
+          </a:xfrm>
+          <a:prstGeom prst="straightConnector1">
+            <a:avLst/>
+          </a:prstGeom>
+          <a:ln w="28575">
+            <a:solidFill>
+              <a:schemeClr val="bg1">
+                <a:lumMod val="50000"/>
+              </a:schemeClr>
+            </a:solidFill>
+            <a:tailEnd type="triangle"/>
+          </a:ln>
+        </p:spPr>
+        <p:style>
+          <a:lnRef idx="1">
+            <a:schemeClr val="accent1"/>
+          </a:lnRef>
+          <a:fillRef idx="0">
+            <a:schemeClr val="accent1"/>
+          </a:fillRef>
+          <a:effectRef idx="0">
+            <a:schemeClr val="accent1"/>
+          </a:effectRef>
+          <a:fontRef idx="minor">
+            <a:schemeClr val="tx1"/>
+          </a:fontRef>
+        </p:style>
+      </p:cxnSp>
+      <p:sp>
+        <p:nvSpPr>
+          <p:cNvPr id="22" name="Rectangle 21">
+            <a:extLst>
+              <a:ext uri="{FF2B5EF4-FFF2-40B4-BE49-F238E27FC236}">
+                <a16:creationId xmlns:a16="http://schemas.microsoft.com/office/drawing/2014/main" id="{5F318C63-FBF8-1C16-0D1E-69F765233998}"/>
+              </a:ext>
+            </a:extLst>
+          </p:cNvPr>
+          <p:cNvSpPr/>
+          <p:nvPr/>
+        </p:nvSpPr>
+        <p:spPr>
+          <a:xfrm>
+            <a:off x="8074780" y="3850272"/>
+            <a:ext cx="1413164" cy="802617"/>
+          </a:xfrm>
+          <a:prstGeom prst="rect">
+            <a:avLst/>
+          </a:prstGeom>
+          <a:solidFill>
+            <a:schemeClr val="accent2">
+              <a:lumMod val="60000"/>
+              <a:lumOff val="40000"/>
+            </a:schemeClr>
+          </a:solidFill>
+          <a:ln>
+            <a:noFill/>
+          </a:ln>
+        </p:spPr>
+        <p:style>
+          <a:lnRef idx="2">
+            <a:schemeClr val="accent2">
+              <a:shade val="15000"/>
+            </a:schemeClr>
+          </a:lnRef>
+          <a:fillRef idx="1">
+            <a:schemeClr val="accent2"/>
+          </a:fillRef>
+          <a:effectRef idx="0">
+            <a:schemeClr val="accent2"/>
+          </a:effectRef>
+          <a:fontRef idx="minor">
+            <a:schemeClr val="lt1"/>
+          </a:fontRef>
+        </p:style>
+        <p:txBody>
+          <a:bodyPr rtlCol="0" anchor="ctr"/>
+          <a:lstStyle/>
+          <a:p>
+            <a:pPr algn="ctr"/>
+            <a:r>
+              <a:rPr lang="en-US" dirty="0"/>
+              <a:t>Assembly with MEGAHIT</a:t>
+            </a:r>
+          </a:p>
+        </p:txBody>
+      </p:sp>
+      <p:sp>
+        <p:nvSpPr>
+          <p:cNvPr id="23" name="Rectangle 22">
+            <a:extLst>
+              <a:ext uri="{FF2B5EF4-FFF2-40B4-BE49-F238E27FC236}">
+                <a16:creationId xmlns:a16="http://schemas.microsoft.com/office/drawing/2014/main" id="{3F1F81AC-7470-E110-D9DC-5BCBCE4B54D6}"/>
+              </a:ext>
+            </a:extLst>
+          </p:cNvPr>
+          <p:cNvSpPr/>
+          <p:nvPr/>
+        </p:nvSpPr>
+        <p:spPr>
+          <a:xfrm>
+            <a:off x="8074780" y="4913539"/>
+            <a:ext cx="1413164" cy="587829"/>
+          </a:xfrm>
+          <a:prstGeom prst="rect">
+            <a:avLst/>
+          </a:prstGeom>
+          <a:solidFill>
+            <a:schemeClr val="accent2">
+              <a:lumMod val="60000"/>
+              <a:lumOff val="40000"/>
+            </a:schemeClr>
+          </a:solidFill>
+          <a:ln>
+            <a:noFill/>
+          </a:ln>
+        </p:spPr>
+        <p:style>
+          <a:lnRef idx="2">
+            <a:schemeClr val="accent2">
+              <a:shade val="15000"/>
+            </a:schemeClr>
+          </a:lnRef>
+          <a:fillRef idx="1">
+            <a:schemeClr val="accent2"/>
+          </a:fillRef>
+          <a:effectRef idx="0">
+            <a:schemeClr val="accent2"/>
+          </a:effectRef>
+          <a:fontRef idx="minor">
+            <a:schemeClr val="lt1"/>
+          </a:fontRef>
+        </p:style>
+        <p:txBody>
+          <a:bodyPr rtlCol="0" anchor="ctr"/>
+          <a:lstStyle/>
+          <a:p>
+            <a:pPr algn="ctr"/>
+            <a:r>
+              <a:rPr lang="en-US" dirty="0"/>
+              <a:t>Kraken2 annotation</a:t>
+            </a:r>
+          </a:p>
+        </p:txBody>
+      </p:sp>
+      <p:cxnSp>
+        <p:nvCxnSpPr>
+          <p:cNvPr id="5" name="Straight Arrow Connector 4">
+            <a:extLst>
+              <a:ext uri="{FF2B5EF4-FFF2-40B4-BE49-F238E27FC236}">
+                <a16:creationId xmlns:a16="http://schemas.microsoft.com/office/drawing/2014/main" id="{A97F1F21-D721-A862-FE46-0460393EEC26}"/>
+              </a:ext>
+            </a:extLst>
+          </p:cNvPr>
+          <p:cNvCxnSpPr>
+            <a:cxnSpLocks/>
+          </p:cNvCxnSpPr>
+          <p:nvPr/>
+        </p:nvCxnSpPr>
+        <p:spPr>
+          <a:xfrm>
+            <a:off x="5010789" y="2617351"/>
+            <a:ext cx="505299" cy="0"/>
+          </a:xfrm>
+          <a:prstGeom prst="straightConnector1">
+            <a:avLst/>
+          </a:prstGeom>
+          <a:ln w="28575">
+            <a:solidFill>
+              <a:schemeClr val="bg1">
+                <a:lumMod val="50000"/>
+              </a:schemeClr>
+            </a:solidFill>
+            <a:tailEnd type="triangle"/>
+          </a:ln>
+        </p:spPr>
+        <p:style>
+          <a:lnRef idx="1">
+            <a:schemeClr val="accent1"/>
+          </a:lnRef>
+          <a:fillRef idx="0">
+            <a:schemeClr val="accent1"/>
+          </a:fillRef>
+          <a:effectRef idx="0">
+            <a:schemeClr val="accent1"/>
+          </a:effectRef>
+          <a:fontRef idx="minor">
+            <a:schemeClr val="tx1"/>
+          </a:fontRef>
+        </p:style>
+      </p:cxnSp>
+      <p:cxnSp>
+        <p:nvCxnSpPr>
+          <p:cNvPr id="7" name="Straight Arrow Connector 6">
+            <a:extLst>
+              <a:ext uri="{FF2B5EF4-FFF2-40B4-BE49-F238E27FC236}">
+                <a16:creationId xmlns:a16="http://schemas.microsoft.com/office/drawing/2014/main" id="{494EE73E-41EF-32E5-71EA-B3707C3BABFF}"/>
+              </a:ext>
+            </a:extLst>
+          </p:cNvPr>
+          <p:cNvCxnSpPr>
+            <a:cxnSpLocks/>
+          </p:cNvCxnSpPr>
+          <p:nvPr/>
+        </p:nvCxnSpPr>
+        <p:spPr>
+          <a:xfrm>
+            <a:off x="5070856" y="3639787"/>
+            <a:ext cx="505299" cy="0"/>
+          </a:xfrm>
+          <a:prstGeom prst="straightConnector1">
+            <a:avLst/>
+          </a:prstGeom>
+          <a:ln w="28575">
+            <a:solidFill>
+              <a:schemeClr val="bg1">
+                <a:lumMod val="50000"/>
+              </a:schemeClr>
+            </a:solidFill>
+            <a:tailEnd type="triangle"/>
+          </a:ln>
+        </p:spPr>
+        <p:style>
+          <a:lnRef idx="1">
+            <a:schemeClr val="accent1"/>
+          </a:lnRef>
+          <a:fillRef idx="0">
+            <a:schemeClr val="accent1"/>
+          </a:fillRef>
+          <a:effectRef idx="0">
+            <a:schemeClr val="accent1"/>
+          </a:effectRef>
+          <a:fontRef idx="minor">
+            <a:schemeClr val="tx1"/>
+          </a:fontRef>
+        </p:style>
+      </p:cxnSp>
+      <p:cxnSp>
+        <p:nvCxnSpPr>
+          <p:cNvPr id="9" name="Straight Arrow Connector 8">
+            <a:extLst>
+              <a:ext uri="{FF2B5EF4-FFF2-40B4-BE49-F238E27FC236}">
+                <a16:creationId xmlns:a16="http://schemas.microsoft.com/office/drawing/2014/main" id="{4310864F-799A-B103-2368-6064039DA5C0}"/>
+              </a:ext>
+            </a:extLst>
+          </p:cNvPr>
+          <p:cNvCxnSpPr>
+            <a:cxnSpLocks/>
+          </p:cNvCxnSpPr>
+          <p:nvPr/>
+        </p:nvCxnSpPr>
+        <p:spPr>
+          <a:xfrm flipV="1">
+            <a:off x="7247999" y="3302113"/>
+            <a:ext cx="625341" cy="337674"/>
+          </a:xfrm>
+          <a:prstGeom prst="straightConnector1">
+            <a:avLst/>
+          </a:prstGeom>
+          <a:ln w="28575">
+            <a:solidFill>
+              <a:schemeClr val="bg1">
+                <a:lumMod val="50000"/>
+              </a:schemeClr>
+            </a:solidFill>
+            <a:tailEnd type="triangle"/>
+          </a:ln>
+        </p:spPr>
+        <p:style>
+          <a:lnRef idx="1">
+            <a:schemeClr val="accent1"/>
+          </a:lnRef>
+          <a:fillRef idx="0">
+            <a:schemeClr val="accent1"/>
+          </a:fillRef>
+          <a:effectRef idx="0">
+            <a:schemeClr val="accent1"/>
+          </a:effectRef>
+          <a:fontRef idx="minor">
+            <a:schemeClr val="tx1"/>
+          </a:fontRef>
+        </p:style>
+      </p:cxnSp>
+      <p:cxnSp>
+        <p:nvCxnSpPr>
+          <p:cNvPr id="19" name="Straight Arrow Connector 18">
+            <a:extLst>
+              <a:ext uri="{FF2B5EF4-FFF2-40B4-BE49-F238E27FC236}">
+                <a16:creationId xmlns:a16="http://schemas.microsoft.com/office/drawing/2014/main" id="{A9D7B9D3-62D7-FB6F-B472-705F209A86AB}"/>
+              </a:ext>
+            </a:extLst>
+          </p:cNvPr>
+          <p:cNvCxnSpPr>
+            <a:cxnSpLocks/>
+          </p:cNvCxnSpPr>
+          <p:nvPr/>
+        </p:nvCxnSpPr>
+        <p:spPr>
+          <a:xfrm>
+            <a:off x="7296635" y="3760735"/>
+            <a:ext cx="576705" cy="437192"/>
+          </a:xfrm>
+          <a:prstGeom prst="straightConnector1">
+            <a:avLst/>
+          </a:prstGeom>
+          <a:ln w="28575">
+            <a:solidFill>
+              <a:schemeClr val="bg1">
+                <a:lumMod val="50000"/>
+              </a:schemeClr>
+            </a:solidFill>
+            <a:prstDash val="dash"/>
+            <a:tailEnd type="triangle"/>
+          </a:ln>
+        </p:spPr>
+        <p:style>
+          <a:lnRef idx="1">
+            <a:schemeClr val="accent1"/>
+          </a:lnRef>
+          <a:fillRef idx="0">
+            <a:schemeClr val="accent1"/>
+          </a:fillRef>
+          <a:effectRef idx="0">
+            <a:schemeClr val="accent1"/>
+          </a:effectRef>
+          <a:fontRef idx="minor">
+            <a:schemeClr val="tx1"/>
+          </a:fontRef>
+        </p:style>
+      </p:cxnSp>
+      <p:cxnSp>
+        <p:nvCxnSpPr>
+          <p:cNvPr id="24" name="Straight Arrow Connector 23">
+            <a:extLst>
+              <a:ext uri="{FF2B5EF4-FFF2-40B4-BE49-F238E27FC236}">
+                <a16:creationId xmlns:a16="http://schemas.microsoft.com/office/drawing/2014/main" id="{F31E96CF-3BF5-D004-0616-BA655DA25C05}"/>
+              </a:ext>
+            </a:extLst>
+          </p:cNvPr>
+          <p:cNvCxnSpPr>
+            <a:cxnSpLocks/>
+          </p:cNvCxnSpPr>
+          <p:nvPr/>
+        </p:nvCxnSpPr>
+        <p:spPr>
+          <a:xfrm>
+            <a:off x="7275177" y="3850272"/>
+            <a:ext cx="702331" cy="1315494"/>
+          </a:xfrm>
+          <a:prstGeom prst="straightConnector1">
+            <a:avLst/>
+          </a:prstGeom>
+          <a:ln w="28575">
+            <a:solidFill>
+              <a:schemeClr val="bg1">
+                <a:lumMod val="50000"/>
+              </a:schemeClr>
+            </a:solidFill>
+            <a:prstDash val="dash"/>
+            <a:tailEnd type="triangle"/>
+          </a:ln>
+        </p:spPr>
+        <p:style>
+          <a:lnRef idx="1">
+            <a:schemeClr val="accent1"/>
+          </a:lnRef>
+          <a:fillRef idx="0">
+            <a:schemeClr val="accent1"/>
+          </a:fillRef>
+          <a:effectRef idx="0">
+            <a:schemeClr val="accent1"/>
+          </a:effectRef>
+          <a:fontRef idx="minor">
+            <a:schemeClr val="tx1"/>
+          </a:fontRef>
+        </p:style>
+      </p:cxnSp>
+      <p:cxnSp>
+        <p:nvCxnSpPr>
+          <p:cNvPr id="27" name="Straight Arrow Connector 26">
+            <a:extLst>
+              <a:ext uri="{FF2B5EF4-FFF2-40B4-BE49-F238E27FC236}">
+                <a16:creationId xmlns:a16="http://schemas.microsoft.com/office/drawing/2014/main" id="{FE7D50E7-1D26-31DE-4890-6E5529F8A095}"/>
+              </a:ext>
+            </a:extLst>
+          </p:cNvPr>
+          <p:cNvCxnSpPr>
+            <a:cxnSpLocks/>
+          </p:cNvCxnSpPr>
+          <p:nvPr/>
+        </p:nvCxnSpPr>
+        <p:spPr>
+          <a:xfrm>
+            <a:off x="9592686" y="3280322"/>
+            <a:ext cx="505299" cy="0"/>
+          </a:xfrm>
+          <a:prstGeom prst="straightConnector1">
+            <a:avLst/>
+          </a:prstGeom>
+          <a:ln w="28575">
+            <a:solidFill>
+              <a:schemeClr val="bg1">
+                <a:lumMod val="50000"/>
+              </a:schemeClr>
+            </a:solidFill>
+            <a:tailEnd type="triangle"/>
+          </a:ln>
+        </p:spPr>
+        <p:style>
+          <a:lnRef idx="1">
+            <a:schemeClr val="accent1"/>
+          </a:lnRef>
+          <a:fillRef idx="0">
+            <a:schemeClr val="accent1"/>
+          </a:fillRef>
+          <a:effectRef idx="0">
+            <a:schemeClr val="accent1"/>
+          </a:effectRef>
+          <a:fontRef idx="minor">
+            <a:schemeClr val="tx1"/>
+          </a:fontRef>
+        </p:style>
+      </p:cxnSp>
+    </p:spTree>
+    <p:extLst>
+      <p:ext uri="{BB962C8B-B14F-4D97-AF65-F5344CB8AC3E}">
+        <p14:creationId xmlns:p14="http://schemas.microsoft.com/office/powerpoint/2010/main" val="2752002074"/>
+      </p:ext>
+    </p:extLst>
+  </p:cSld>
+  <p:clrMapOvr>
+    <a:masterClrMapping/>
+  </p:clrMapOvr>
+</p:sld>
+</file>
+
+<file path=ppt/slides/slide11.xml><?xml version="1.0" encoding="utf-8"?>
+<p:sld xmlns:a="http://schemas.openxmlformats.org/drawingml/2006/main" xmlns:r="http://schemas.openxmlformats.org/officeDocument/2006/relationships" xmlns:p="http://schemas.openxmlformats.org/presentationml/2006/main">
+  <p:cSld>
+    <p:spTree>
+      <p:nvGrpSpPr>
+        <p:cNvPr id="1" name="">
+          <a:extLst>
+            <a:ext uri="{FF2B5EF4-FFF2-40B4-BE49-F238E27FC236}">
+              <a16:creationId xmlns:a16="http://schemas.microsoft.com/office/drawing/2014/main" id="{9DC32AAA-C239-35F2-CE12-21EBCB2597F9}"/>
+            </a:ext>
+          </a:extLst>
+        </p:cNvPr>
+        <p:cNvGrpSpPr/>
+        <p:nvPr/>
+      </p:nvGrpSpPr>
+      <p:grpSpPr>
+        <a:xfrm>
+          <a:off x="0" y="0"/>
+          <a:ext cx="0" cy="0"/>
+          <a:chOff x="0" y="0"/>
+          <a:chExt cx="0" cy="0"/>
+        </a:xfrm>
+      </p:grpSpPr>
+      <p:sp>
+        <p:nvSpPr>
+          <p:cNvPr id="2" name="Title 1">
+            <a:extLst>
+              <a:ext uri="{FF2B5EF4-FFF2-40B4-BE49-F238E27FC236}">
+                <a16:creationId xmlns:a16="http://schemas.microsoft.com/office/drawing/2014/main" id="{26F88B60-9E6B-92A6-6C6B-088BD6F07685}"/>
+              </a:ext>
+            </a:extLst>
+          </p:cNvPr>
+          <p:cNvSpPr>
+            <a:spLocks noGrp="1"/>
+          </p:cNvSpPr>
+          <p:nvPr>
+            <p:ph type="title"/>
+          </p:nvPr>
+        </p:nvSpPr>
+        <p:spPr/>
+        <p:txBody>
+          <a:bodyPr/>
+          <a:lstStyle/>
+          <a:p>
+            <a:r>
+              <a:rPr lang="en-US" dirty="0" err="1"/>
+              <a:t>Nextflow</a:t>
+            </a:r>
+            <a:r>
+              <a:rPr lang="en-US" dirty="0"/>
+              <a:t> components: </a:t>
+            </a:r>
+            <a:r>
+              <a:rPr lang="en-US" b="1" dirty="0"/>
+              <a:t>channels</a:t>
+            </a:r>
+          </a:p>
+        </p:txBody>
+      </p:sp>
+      <p:sp>
+        <p:nvSpPr>
+          <p:cNvPr id="3" name="Content Placeholder 2">
+            <a:extLst>
+              <a:ext uri="{FF2B5EF4-FFF2-40B4-BE49-F238E27FC236}">
+                <a16:creationId xmlns:a16="http://schemas.microsoft.com/office/drawing/2014/main" id="{7DD7BE7F-B5C1-C7E9-4399-A95B68CF9A98}"/>
+              </a:ext>
+            </a:extLst>
+          </p:cNvPr>
+          <p:cNvSpPr>
+            <a:spLocks noGrp="1"/>
+          </p:cNvSpPr>
+          <p:nvPr>
+            <p:ph idx="1"/>
+          </p:nvPr>
+        </p:nvSpPr>
+        <p:spPr/>
+        <p:txBody>
+          <a:bodyPr/>
+          <a:lstStyle/>
+          <a:p>
+            <a:pPr marL="0" indent="0">
+              <a:buNone/>
+            </a:pPr>
+            <a:r>
+              <a:rPr lang="en-US" b="1" dirty="0">
+                <a:solidFill>
+                  <a:schemeClr val="accent4">
+                    <a:lumMod val="75000"/>
+                  </a:schemeClr>
+                </a:solidFill>
+              </a:rPr>
+              <a:t>Channels</a:t>
+            </a:r>
+            <a:r>
+              <a:rPr lang="en-US" dirty="0"/>
+              <a:t> are asynchronous queues that connect processes and handle data flow. They're </a:t>
+            </a:r>
+            <a:r>
+              <a:rPr lang="en-US" dirty="0" err="1"/>
+              <a:t>Nextflow's</a:t>
+            </a:r>
+            <a:r>
+              <a:rPr lang="en-US" dirty="0"/>
+              <a:t> way of passing data between processes. Key types:</a:t>
+            </a:r>
+          </a:p>
+          <a:p>
+            <a:r>
+              <a:rPr lang="en-US" b="1" dirty="0"/>
+              <a:t>Queue channels</a:t>
+            </a:r>
+            <a:r>
+              <a:rPr lang="en-US" dirty="0"/>
+              <a:t>: Consumed once, ideal for streaming data</a:t>
+            </a:r>
+          </a:p>
+          <a:p>
+            <a:r>
+              <a:rPr lang="en-US" b="1" dirty="0"/>
+              <a:t>Value channels</a:t>
+            </a:r>
+            <a:r>
+              <a:rPr lang="en-US" dirty="0"/>
+              <a:t>: Can be read multiple times, useful for reference files and databases</a:t>
+            </a:r>
+          </a:p>
+          <a:p>
+            <a:pPr marL="0" indent="0">
+              <a:buNone/>
+            </a:pPr>
+            <a:endParaRPr lang="en-US" dirty="0"/>
+          </a:p>
+          <a:p>
+            <a:pPr marL="0" indent="0">
+              <a:buNone/>
+            </a:pPr>
+            <a:r>
+              <a:rPr lang="en-US" dirty="0"/>
+              <a:t>Channels enable parallel processing when multiple data items flow through the pipeline.</a:t>
+            </a:r>
+          </a:p>
+        </p:txBody>
+      </p:sp>
+      <p:pic>
+        <p:nvPicPr>
+          <p:cNvPr id="2050" name="Picture 2" descr="Conveyor Belt Icon Style 7246936 Vector Art at Vecteezy">
+            <a:extLst>
+              <a:ext uri="{FF2B5EF4-FFF2-40B4-BE49-F238E27FC236}">
+                <a16:creationId xmlns:a16="http://schemas.microsoft.com/office/drawing/2014/main" id="{1575CC90-6DA8-21E2-58ED-4F945AA8B702}"/>
+              </a:ext>
+            </a:extLst>
+          </p:cNvPr>
+          <p:cNvPicPr>
+            <a:picLocks noChangeAspect="1" noChangeArrowheads="1"/>
+          </p:cNvPicPr>
+          <p:nvPr/>
+        </p:nvPicPr>
+        <p:blipFill>
+          <a:blip r:embed="rId2">
+            <a:extLst>
+              <a:ext uri="{28A0092B-C50C-407E-A947-70E740481C1C}">
+                <a14:useLocalDpi xmlns:a14="http://schemas.microsoft.com/office/drawing/2010/main" val="0"/>
+              </a:ext>
+            </a:extLst>
+          </a:blip>
+          <a:srcRect/>
+          <a:stretch>
+            <a:fillRect/>
+          </a:stretch>
+        </p:blipFill>
+        <p:spPr bwMode="auto">
+          <a:xfrm>
+            <a:off x="8710962" y="230188"/>
+            <a:ext cx="1460500" cy="1460500"/>
+          </a:xfrm>
+          <a:prstGeom prst="rect">
+            <a:avLst/>
+          </a:prstGeom>
+          <a:noFill/>
+          <a:extLst>
+            <a:ext uri="{909E8E84-426E-40DD-AFC4-6F175D3DCCD1}">
+              <a14:hiddenFill xmlns:a14="http://schemas.microsoft.com/office/drawing/2010/main">
+                <a:solidFill>
+                  <a:srgbClr val="FFFFFF"/>
+                </a:solidFill>
+              </a14:hiddenFill>
+            </a:ext>
+          </a:extLst>
+        </p:spPr>
+      </p:pic>
+    </p:spTree>
+    <p:extLst>
+      <p:ext uri="{BB962C8B-B14F-4D97-AF65-F5344CB8AC3E}">
+        <p14:creationId xmlns:p14="http://schemas.microsoft.com/office/powerpoint/2010/main" val="3587417096"/>
+      </p:ext>
+    </p:extLst>
+  </p:cSld>
+  <p:clrMapOvr>
+    <a:masterClrMapping/>
+  </p:clrMapOvr>
+</p:sld>
+</file>
+
+<file path=ppt/slides/slide12.xml><?xml version="1.0" encoding="utf-8"?>
+<p:sld xmlns:a="http://schemas.openxmlformats.org/drawingml/2006/main" xmlns:r="http://schemas.openxmlformats.org/officeDocument/2006/relationships" xmlns:p="http://schemas.openxmlformats.org/presentationml/2006/main">
+  <p:cSld>
+    <p:spTree>
+      <p:nvGrpSpPr>
+        <p:cNvPr id="1" name="">
+          <a:extLst>
+            <a:ext uri="{FF2B5EF4-FFF2-40B4-BE49-F238E27FC236}">
+              <a16:creationId xmlns:a16="http://schemas.microsoft.com/office/drawing/2014/main" id="{7AAA5EFD-99C1-E921-F08C-47D76A612262}"/>
+            </a:ext>
+          </a:extLst>
+        </p:cNvPr>
+        <p:cNvGrpSpPr/>
+        <p:nvPr/>
+      </p:nvGrpSpPr>
+      <p:grpSpPr>
+        <a:xfrm>
+          <a:off x="0" y="0"/>
+          <a:ext cx="0" cy="0"/>
+          <a:chOff x="0" y="0"/>
+          <a:chExt cx="0" cy="0"/>
+        </a:xfrm>
+      </p:grpSpPr>
+      <p:sp>
+        <p:nvSpPr>
+          <p:cNvPr id="8" name="Title 1">
+            <a:extLst>
+              <a:ext uri="{FF2B5EF4-FFF2-40B4-BE49-F238E27FC236}">
+                <a16:creationId xmlns:a16="http://schemas.microsoft.com/office/drawing/2014/main" id="{1E14E91D-D938-80ED-EE1D-71AAD9F446F2}"/>
+              </a:ext>
+            </a:extLst>
+          </p:cNvPr>
+          <p:cNvSpPr>
+            <a:spLocks noGrp="1"/>
+          </p:cNvSpPr>
+          <p:nvPr>
+            <p:ph type="title"/>
+          </p:nvPr>
+        </p:nvSpPr>
+        <p:spPr>
+          <a:xfrm>
+            <a:off x="838200" y="365125"/>
+            <a:ext cx="10515600" cy="1325563"/>
+          </a:xfrm>
+        </p:spPr>
+        <p:txBody>
+          <a:bodyPr/>
+          <a:lstStyle/>
+          <a:p>
+            <a:r>
+              <a:rPr lang="en-US" dirty="0"/>
+              <a:t>Processes</a:t>
+            </a:r>
+          </a:p>
+        </p:txBody>
+      </p:sp>
+      <p:sp>
+        <p:nvSpPr>
+          <p:cNvPr id="10" name="Rectangle 9">
+            <a:extLst>
+              <a:ext uri="{FF2B5EF4-FFF2-40B4-BE49-F238E27FC236}">
+                <a16:creationId xmlns:a16="http://schemas.microsoft.com/office/drawing/2014/main" id="{838FDC0B-339B-AD2D-0F58-A88995B41BE7}"/>
+              </a:ext>
+            </a:extLst>
+          </p:cNvPr>
+          <p:cNvSpPr/>
+          <p:nvPr/>
+        </p:nvSpPr>
+        <p:spPr>
+          <a:xfrm>
+            <a:off x="662871" y="2841171"/>
+            <a:ext cx="1413164" cy="587829"/>
+          </a:xfrm>
+          <a:prstGeom prst="rect">
+            <a:avLst/>
+          </a:prstGeom>
+          <a:solidFill>
+            <a:schemeClr val="accent4">
+              <a:lumMod val="60000"/>
+              <a:lumOff val="40000"/>
+            </a:schemeClr>
+          </a:solidFill>
+          <a:ln w="28575">
+            <a:solidFill>
+              <a:srgbClr val="BF9001"/>
+            </a:solidFill>
+          </a:ln>
+        </p:spPr>
+        <p:style>
+          <a:lnRef idx="2">
+            <a:schemeClr val="dk1"/>
+          </a:lnRef>
+          <a:fillRef idx="1">
+            <a:schemeClr val="lt1"/>
+          </a:fillRef>
+          <a:effectRef idx="0">
+            <a:schemeClr val="dk1"/>
+          </a:effectRef>
+          <a:fontRef idx="minor">
+            <a:schemeClr val="dk1"/>
+          </a:fontRef>
+        </p:style>
+        <p:txBody>
+          <a:bodyPr rtlCol="0" anchor="ctr"/>
+          <a:lstStyle/>
+          <a:p>
+            <a:pPr algn="ctr"/>
+            <a:r>
+              <a:rPr lang="en-US" dirty="0">
+                <a:solidFill>
+                  <a:schemeClr val="accent4">
+                    <a:lumMod val="50000"/>
+                  </a:schemeClr>
+                </a:solidFill>
+              </a:rPr>
+              <a:t>Raw reads</a:t>
+            </a:r>
+          </a:p>
+        </p:txBody>
+      </p:sp>
+      <p:sp>
+        <p:nvSpPr>
+          <p:cNvPr id="11" name="Rectangle 10">
+            <a:extLst>
+              <a:ext uri="{FF2B5EF4-FFF2-40B4-BE49-F238E27FC236}">
+                <a16:creationId xmlns:a16="http://schemas.microsoft.com/office/drawing/2014/main" id="{F828853F-76CD-1E30-F08D-A11DC71CA173}"/>
+              </a:ext>
+            </a:extLst>
+          </p:cNvPr>
+          <p:cNvSpPr/>
+          <p:nvPr/>
+        </p:nvSpPr>
+        <p:spPr>
+          <a:xfrm>
+            <a:off x="3410639" y="2323437"/>
+            <a:ext cx="1413164" cy="587829"/>
+          </a:xfrm>
+          <a:prstGeom prst="rect">
+            <a:avLst/>
+          </a:prstGeom>
+          <a:ln>
+            <a:noFill/>
+          </a:ln>
+        </p:spPr>
+        <p:style>
+          <a:lnRef idx="2">
+            <a:schemeClr val="accent2">
+              <a:shade val="15000"/>
+            </a:schemeClr>
+          </a:lnRef>
+          <a:fillRef idx="1">
+            <a:schemeClr val="accent2"/>
+          </a:fillRef>
+          <a:effectRef idx="0">
+            <a:schemeClr val="accent2"/>
+          </a:effectRef>
+          <a:fontRef idx="minor">
+            <a:schemeClr val="lt1"/>
+          </a:fontRef>
+        </p:style>
+        <p:txBody>
+          <a:bodyPr rtlCol="0" anchor="ctr"/>
+          <a:lstStyle/>
+          <a:p>
+            <a:pPr algn="ctr"/>
+            <a:r>
+              <a:rPr lang="en-US" dirty="0" err="1"/>
+              <a:t>FastQC</a:t>
+            </a:r>
+            <a:endParaRPr lang="en-US" dirty="0"/>
+          </a:p>
+        </p:txBody>
+      </p:sp>
+      <p:sp>
+        <p:nvSpPr>
+          <p:cNvPr id="12" name="Rectangle 11">
+            <a:extLst>
+              <a:ext uri="{FF2B5EF4-FFF2-40B4-BE49-F238E27FC236}">
+                <a16:creationId xmlns:a16="http://schemas.microsoft.com/office/drawing/2014/main" id="{143CF5DC-DEB6-9EF8-49FE-5B46FCCCC0FE}"/>
+              </a:ext>
+            </a:extLst>
+          </p:cNvPr>
+          <p:cNvSpPr/>
+          <p:nvPr/>
+        </p:nvSpPr>
+        <p:spPr>
+          <a:xfrm>
+            <a:off x="3410639" y="3411186"/>
+            <a:ext cx="1506186" cy="587829"/>
+          </a:xfrm>
+          <a:prstGeom prst="rect">
+            <a:avLst/>
+          </a:prstGeom>
+          <a:ln>
+            <a:noFill/>
+          </a:ln>
+        </p:spPr>
+        <p:style>
+          <a:lnRef idx="2">
+            <a:schemeClr val="accent2">
+              <a:shade val="15000"/>
+            </a:schemeClr>
+          </a:lnRef>
+          <a:fillRef idx="1">
+            <a:schemeClr val="accent2"/>
+          </a:fillRef>
+          <a:effectRef idx="0">
+            <a:schemeClr val="accent2"/>
+          </a:effectRef>
+          <a:fontRef idx="minor">
+            <a:schemeClr val="lt1"/>
+          </a:fontRef>
+        </p:style>
+        <p:txBody>
+          <a:bodyPr rtlCol="0" anchor="ctr"/>
+          <a:lstStyle/>
+          <a:p>
+            <a:pPr algn="ctr"/>
+            <a:r>
+              <a:rPr lang="en-US" dirty="0" err="1"/>
+              <a:t>Trimmomatic</a:t>
+            </a:r>
+            <a:endParaRPr lang="en-US" dirty="0"/>
+          </a:p>
+        </p:txBody>
+      </p:sp>
+      <p:sp>
+        <p:nvSpPr>
+          <p:cNvPr id="13" name="Rectangle 12">
+            <a:extLst>
+              <a:ext uri="{FF2B5EF4-FFF2-40B4-BE49-F238E27FC236}">
+                <a16:creationId xmlns:a16="http://schemas.microsoft.com/office/drawing/2014/main" id="{0965C719-070A-9148-F0BE-078722611EC0}"/>
+              </a:ext>
+            </a:extLst>
+          </p:cNvPr>
+          <p:cNvSpPr/>
+          <p:nvPr/>
+        </p:nvSpPr>
+        <p:spPr>
+          <a:xfrm>
+            <a:off x="8074780" y="3008199"/>
+            <a:ext cx="1413164" cy="587829"/>
+          </a:xfrm>
+          <a:prstGeom prst="rect">
+            <a:avLst/>
+          </a:prstGeom>
+          <a:ln>
+            <a:noFill/>
+          </a:ln>
+        </p:spPr>
+        <p:style>
+          <a:lnRef idx="2">
+            <a:schemeClr val="accent2">
+              <a:shade val="15000"/>
+            </a:schemeClr>
+          </a:lnRef>
+          <a:fillRef idx="1">
+            <a:schemeClr val="accent2"/>
+          </a:fillRef>
+          <a:effectRef idx="0">
+            <a:schemeClr val="accent2"/>
+          </a:effectRef>
+          <a:fontRef idx="minor">
+            <a:schemeClr val="lt1"/>
+          </a:fontRef>
+        </p:style>
+        <p:txBody>
+          <a:bodyPr rtlCol="0" anchor="ctr"/>
+          <a:lstStyle/>
+          <a:p>
+            <a:pPr algn="ctr"/>
+            <a:r>
+              <a:rPr lang="en-US" dirty="0" err="1"/>
+              <a:t>FastQC</a:t>
+            </a:r>
+            <a:endParaRPr lang="en-US" dirty="0"/>
+          </a:p>
+        </p:txBody>
+      </p:sp>
+      <p:sp>
+        <p:nvSpPr>
+          <p:cNvPr id="14" name="Rectangle 13">
+            <a:extLst>
+              <a:ext uri="{FF2B5EF4-FFF2-40B4-BE49-F238E27FC236}">
+                <a16:creationId xmlns:a16="http://schemas.microsoft.com/office/drawing/2014/main" id="{E5C68A6C-031C-4548-16AA-58AB4BFA783B}"/>
+              </a:ext>
+            </a:extLst>
+          </p:cNvPr>
+          <p:cNvSpPr/>
+          <p:nvPr/>
+        </p:nvSpPr>
+        <p:spPr>
+          <a:xfrm>
+            <a:off x="5703074" y="2323437"/>
+            <a:ext cx="1413164" cy="587829"/>
+          </a:xfrm>
+          <a:prstGeom prst="rect">
+            <a:avLst/>
+          </a:prstGeom>
+        </p:spPr>
+        <p:style>
+          <a:lnRef idx="2">
+            <a:schemeClr val="dk1"/>
+          </a:lnRef>
+          <a:fillRef idx="1">
+            <a:schemeClr val="lt1"/>
+          </a:fillRef>
+          <a:effectRef idx="0">
+            <a:schemeClr val="dk1"/>
+          </a:effectRef>
+          <a:fontRef idx="minor">
+            <a:schemeClr val="dk1"/>
+          </a:fontRef>
+        </p:style>
+        <p:txBody>
+          <a:bodyPr rtlCol="0" anchor="ctr"/>
+          <a:lstStyle/>
+          <a:p>
+            <a:pPr algn="ctr"/>
+            <a:r>
+              <a:rPr lang="en-US" dirty="0"/>
+              <a:t>Quality report</a:t>
+            </a:r>
+          </a:p>
+        </p:txBody>
+      </p:sp>
+      <p:sp>
+        <p:nvSpPr>
+          <p:cNvPr id="15" name="Rectangle 14">
+            <a:extLst>
+              <a:ext uri="{FF2B5EF4-FFF2-40B4-BE49-F238E27FC236}">
+                <a16:creationId xmlns:a16="http://schemas.microsoft.com/office/drawing/2014/main" id="{D9A2FC42-3B72-94AC-37D3-34B4A7B1118B}"/>
+              </a:ext>
+            </a:extLst>
+          </p:cNvPr>
+          <p:cNvSpPr/>
+          <p:nvPr/>
+        </p:nvSpPr>
+        <p:spPr>
+          <a:xfrm>
+            <a:off x="10208988" y="2989849"/>
+            <a:ext cx="1413164" cy="587829"/>
+          </a:xfrm>
+          <a:prstGeom prst="rect">
+            <a:avLst/>
+          </a:prstGeom>
+        </p:spPr>
+        <p:style>
+          <a:lnRef idx="2">
+            <a:schemeClr val="dk1"/>
+          </a:lnRef>
+          <a:fillRef idx="1">
+            <a:schemeClr val="lt1"/>
+          </a:fillRef>
+          <a:effectRef idx="0">
+            <a:schemeClr val="dk1"/>
+          </a:effectRef>
+          <a:fontRef idx="minor">
+            <a:schemeClr val="dk1"/>
+          </a:fontRef>
+        </p:style>
+        <p:txBody>
+          <a:bodyPr rtlCol="0" anchor="ctr"/>
+          <a:lstStyle/>
+          <a:p>
+            <a:pPr algn="ctr"/>
+            <a:r>
+              <a:rPr lang="en-US" dirty="0"/>
+              <a:t>Quality report</a:t>
+            </a:r>
+          </a:p>
+        </p:txBody>
+      </p:sp>
+      <p:sp>
+        <p:nvSpPr>
+          <p:cNvPr id="16" name="Rectangle 15">
+            <a:extLst>
+              <a:ext uri="{FF2B5EF4-FFF2-40B4-BE49-F238E27FC236}">
+                <a16:creationId xmlns:a16="http://schemas.microsoft.com/office/drawing/2014/main" id="{1C8F641D-6BB5-3E16-1F4E-A7F101DEEB63}"/>
+              </a:ext>
+            </a:extLst>
+          </p:cNvPr>
+          <p:cNvSpPr/>
+          <p:nvPr/>
+        </p:nvSpPr>
+        <p:spPr>
+          <a:xfrm>
+            <a:off x="5730667" y="3403531"/>
+            <a:ext cx="1413164" cy="587829"/>
+          </a:xfrm>
+          <a:prstGeom prst="rect">
+            <a:avLst/>
+          </a:prstGeom>
+        </p:spPr>
+        <p:style>
+          <a:lnRef idx="2">
+            <a:schemeClr val="dk1"/>
+          </a:lnRef>
+          <a:fillRef idx="1">
+            <a:schemeClr val="lt1"/>
+          </a:fillRef>
+          <a:effectRef idx="0">
+            <a:schemeClr val="dk1"/>
+          </a:effectRef>
+          <a:fontRef idx="minor">
+            <a:schemeClr val="dk1"/>
+          </a:fontRef>
+        </p:style>
+        <p:txBody>
+          <a:bodyPr rtlCol="0" anchor="ctr"/>
+          <a:lstStyle/>
+          <a:p>
+            <a:pPr algn="ctr"/>
+            <a:r>
+              <a:rPr lang="en-US" dirty="0"/>
+              <a:t>Clean reads</a:t>
+            </a:r>
+          </a:p>
+        </p:txBody>
+      </p:sp>
+      <p:cxnSp>
+        <p:nvCxnSpPr>
+          <p:cNvPr id="18" name="Straight Arrow Connector 17">
+            <a:extLst>
+              <a:ext uri="{FF2B5EF4-FFF2-40B4-BE49-F238E27FC236}">
+                <a16:creationId xmlns:a16="http://schemas.microsoft.com/office/drawing/2014/main" id="{BB5E225D-FDB9-488A-7300-3E45B8DEA129}"/>
+              </a:ext>
+            </a:extLst>
+          </p:cNvPr>
+          <p:cNvCxnSpPr>
+            <a:cxnSpLocks/>
+          </p:cNvCxnSpPr>
+          <p:nvPr/>
+        </p:nvCxnSpPr>
+        <p:spPr>
+          <a:xfrm flipV="1">
+            <a:off x="2174566" y="2642260"/>
+            <a:ext cx="964708" cy="442617"/>
+          </a:xfrm>
+          <a:prstGeom prst="straightConnector1">
+            <a:avLst/>
+          </a:prstGeom>
+          <a:ln w="28575">
+            <a:solidFill>
+              <a:schemeClr val="bg1">
+                <a:lumMod val="50000"/>
+              </a:schemeClr>
+            </a:solidFill>
+            <a:tailEnd type="triangle"/>
+          </a:ln>
+        </p:spPr>
+        <p:style>
+          <a:lnRef idx="1">
+            <a:schemeClr val="accent1"/>
+          </a:lnRef>
+          <a:fillRef idx="0">
+            <a:schemeClr val="accent1"/>
+          </a:fillRef>
+          <a:effectRef idx="0">
+            <a:schemeClr val="accent1"/>
+          </a:effectRef>
+          <a:fontRef idx="minor">
+            <a:schemeClr val="tx1"/>
+          </a:fontRef>
+        </p:style>
+      </p:cxnSp>
+      <p:cxnSp>
+        <p:nvCxnSpPr>
+          <p:cNvPr id="21" name="Straight Arrow Connector 20">
+            <a:extLst>
+              <a:ext uri="{FF2B5EF4-FFF2-40B4-BE49-F238E27FC236}">
+                <a16:creationId xmlns:a16="http://schemas.microsoft.com/office/drawing/2014/main" id="{F82502B5-0967-62B7-F523-645F9109E5DC}"/>
+              </a:ext>
+            </a:extLst>
+          </p:cNvPr>
+          <p:cNvCxnSpPr>
+            <a:cxnSpLocks/>
+          </p:cNvCxnSpPr>
+          <p:nvPr/>
+        </p:nvCxnSpPr>
+        <p:spPr>
+          <a:xfrm>
+            <a:off x="2174566" y="3160087"/>
+            <a:ext cx="918956" cy="479700"/>
+          </a:xfrm>
+          <a:prstGeom prst="straightConnector1">
+            <a:avLst/>
+          </a:prstGeom>
+          <a:ln w="28575">
+            <a:solidFill>
+              <a:schemeClr val="bg1">
+                <a:lumMod val="50000"/>
+              </a:schemeClr>
+            </a:solidFill>
+            <a:tailEnd type="triangle"/>
+          </a:ln>
+        </p:spPr>
+        <p:style>
+          <a:lnRef idx="1">
+            <a:schemeClr val="accent1"/>
+          </a:lnRef>
+          <a:fillRef idx="0">
+            <a:schemeClr val="accent1"/>
+          </a:fillRef>
+          <a:effectRef idx="0">
+            <a:schemeClr val="accent1"/>
+          </a:effectRef>
+          <a:fontRef idx="minor">
+            <a:schemeClr val="tx1"/>
+          </a:fontRef>
+        </p:style>
+      </p:cxnSp>
+      <p:sp>
+        <p:nvSpPr>
+          <p:cNvPr id="22" name="Rectangle 21">
+            <a:extLst>
+              <a:ext uri="{FF2B5EF4-FFF2-40B4-BE49-F238E27FC236}">
+                <a16:creationId xmlns:a16="http://schemas.microsoft.com/office/drawing/2014/main" id="{F6CC4E19-C4F6-B8A6-7C53-3DAC79259A66}"/>
+              </a:ext>
+            </a:extLst>
+          </p:cNvPr>
+          <p:cNvSpPr/>
+          <p:nvPr/>
+        </p:nvSpPr>
+        <p:spPr>
+          <a:xfrm>
+            <a:off x="8074780" y="3850272"/>
+            <a:ext cx="1413164" cy="802617"/>
+          </a:xfrm>
+          <a:prstGeom prst="rect">
+            <a:avLst/>
+          </a:prstGeom>
+          <a:solidFill>
+            <a:schemeClr val="accent2">
+              <a:lumMod val="60000"/>
+              <a:lumOff val="40000"/>
+            </a:schemeClr>
+          </a:solidFill>
+          <a:ln>
+            <a:noFill/>
+          </a:ln>
+        </p:spPr>
+        <p:style>
+          <a:lnRef idx="2">
+            <a:schemeClr val="accent2">
+              <a:shade val="15000"/>
+            </a:schemeClr>
+          </a:lnRef>
+          <a:fillRef idx="1">
+            <a:schemeClr val="accent2"/>
+          </a:fillRef>
+          <a:effectRef idx="0">
+            <a:schemeClr val="accent2"/>
+          </a:effectRef>
+          <a:fontRef idx="minor">
+            <a:schemeClr val="lt1"/>
+          </a:fontRef>
+        </p:style>
+        <p:txBody>
+          <a:bodyPr rtlCol="0" anchor="ctr"/>
+          <a:lstStyle/>
+          <a:p>
+            <a:pPr algn="ctr"/>
+            <a:r>
+              <a:rPr lang="en-US" dirty="0"/>
+              <a:t>Assembly with MEGAHIT</a:t>
+            </a:r>
+          </a:p>
+        </p:txBody>
+      </p:sp>
+      <p:sp>
+        <p:nvSpPr>
+          <p:cNvPr id="23" name="Rectangle 22">
+            <a:extLst>
+              <a:ext uri="{FF2B5EF4-FFF2-40B4-BE49-F238E27FC236}">
+                <a16:creationId xmlns:a16="http://schemas.microsoft.com/office/drawing/2014/main" id="{FFFA3C34-A3A8-69EE-033B-B5F6BF87DCDD}"/>
+              </a:ext>
+            </a:extLst>
+          </p:cNvPr>
+          <p:cNvSpPr/>
+          <p:nvPr/>
+        </p:nvSpPr>
+        <p:spPr>
+          <a:xfrm>
+            <a:off x="8074780" y="4913539"/>
+            <a:ext cx="1413164" cy="587829"/>
+          </a:xfrm>
+          <a:prstGeom prst="rect">
+            <a:avLst/>
+          </a:prstGeom>
+          <a:solidFill>
+            <a:schemeClr val="accent2">
+              <a:lumMod val="60000"/>
+              <a:lumOff val="40000"/>
+            </a:schemeClr>
+          </a:solidFill>
+          <a:ln>
+            <a:noFill/>
+          </a:ln>
+        </p:spPr>
+        <p:style>
+          <a:lnRef idx="2">
+            <a:schemeClr val="accent2">
+              <a:shade val="15000"/>
+            </a:schemeClr>
+          </a:lnRef>
+          <a:fillRef idx="1">
+            <a:schemeClr val="accent2"/>
+          </a:fillRef>
+          <a:effectRef idx="0">
+            <a:schemeClr val="accent2"/>
+          </a:effectRef>
+          <a:fontRef idx="minor">
+            <a:schemeClr val="lt1"/>
+          </a:fontRef>
+        </p:style>
+        <p:txBody>
+          <a:bodyPr rtlCol="0" anchor="ctr"/>
+          <a:lstStyle/>
+          <a:p>
+            <a:pPr algn="ctr"/>
+            <a:r>
+              <a:rPr lang="en-US" dirty="0"/>
+              <a:t>Kraken2 annotation</a:t>
+            </a:r>
+          </a:p>
+        </p:txBody>
+      </p:sp>
+      <p:cxnSp>
+        <p:nvCxnSpPr>
+          <p:cNvPr id="5" name="Straight Arrow Connector 4">
+            <a:extLst>
+              <a:ext uri="{FF2B5EF4-FFF2-40B4-BE49-F238E27FC236}">
+                <a16:creationId xmlns:a16="http://schemas.microsoft.com/office/drawing/2014/main" id="{4BC0FE40-305D-74DF-49AB-5E79D2599656}"/>
+              </a:ext>
+            </a:extLst>
+          </p:cNvPr>
+          <p:cNvCxnSpPr>
+            <a:cxnSpLocks/>
+          </p:cNvCxnSpPr>
+          <p:nvPr/>
+        </p:nvCxnSpPr>
+        <p:spPr>
+          <a:xfrm>
+            <a:off x="5010789" y="2617351"/>
+            <a:ext cx="505299" cy="0"/>
+          </a:xfrm>
+          <a:prstGeom prst="straightConnector1">
+            <a:avLst/>
+          </a:prstGeom>
+          <a:ln w="28575">
+            <a:solidFill>
+              <a:schemeClr val="bg1">
+                <a:lumMod val="50000"/>
+              </a:schemeClr>
+            </a:solidFill>
+            <a:tailEnd type="triangle"/>
+          </a:ln>
+        </p:spPr>
+        <p:style>
+          <a:lnRef idx="1">
+            <a:schemeClr val="accent1"/>
+          </a:lnRef>
+          <a:fillRef idx="0">
+            <a:schemeClr val="accent1"/>
+          </a:fillRef>
+          <a:effectRef idx="0">
+            <a:schemeClr val="accent1"/>
+          </a:effectRef>
+          <a:fontRef idx="minor">
+            <a:schemeClr val="tx1"/>
+          </a:fontRef>
+        </p:style>
+      </p:cxnSp>
+      <p:cxnSp>
+        <p:nvCxnSpPr>
+          <p:cNvPr id="7" name="Straight Arrow Connector 6">
+            <a:extLst>
+              <a:ext uri="{FF2B5EF4-FFF2-40B4-BE49-F238E27FC236}">
+                <a16:creationId xmlns:a16="http://schemas.microsoft.com/office/drawing/2014/main" id="{60BEF8B5-7302-E652-D133-BF79E736934C}"/>
+              </a:ext>
+            </a:extLst>
+          </p:cNvPr>
+          <p:cNvCxnSpPr>
+            <a:cxnSpLocks/>
+          </p:cNvCxnSpPr>
+          <p:nvPr/>
+        </p:nvCxnSpPr>
+        <p:spPr>
+          <a:xfrm>
+            <a:off x="5070856" y="3639787"/>
+            <a:ext cx="505299" cy="0"/>
+          </a:xfrm>
+          <a:prstGeom prst="straightConnector1">
+            <a:avLst/>
+          </a:prstGeom>
+          <a:ln w="28575">
+            <a:solidFill>
+              <a:schemeClr val="bg1">
+                <a:lumMod val="50000"/>
+              </a:schemeClr>
+            </a:solidFill>
+            <a:tailEnd type="triangle"/>
+          </a:ln>
+        </p:spPr>
+        <p:style>
+          <a:lnRef idx="1">
+            <a:schemeClr val="accent1"/>
+          </a:lnRef>
+          <a:fillRef idx="0">
+            <a:schemeClr val="accent1"/>
+          </a:fillRef>
+          <a:effectRef idx="0">
+            <a:schemeClr val="accent1"/>
+          </a:effectRef>
+          <a:fontRef idx="minor">
+            <a:schemeClr val="tx1"/>
+          </a:fontRef>
+        </p:style>
+      </p:cxnSp>
+      <p:cxnSp>
+        <p:nvCxnSpPr>
+          <p:cNvPr id="9" name="Straight Arrow Connector 8">
+            <a:extLst>
+              <a:ext uri="{FF2B5EF4-FFF2-40B4-BE49-F238E27FC236}">
+                <a16:creationId xmlns:a16="http://schemas.microsoft.com/office/drawing/2014/main" id="{9DBB3D7B-248A-AA49-4272-3E8CC26F678F}"/>
+              </a:ext>
+            </a:extLst>
+          </p:cNvPr>
+          <p:cNvCxnSpPr>
+            <a:cxnSpLocks/>
+          </p:cNvCxnSpPr>
+          <p:nvPr/>
+        </p:nvCxnSpPr>
+        <p:spPr>
+          <a:xfrm flipV="1">
+            <a:off x="7247999" y="3302113"/>
+            <a:ext cx="625341" cy="337674"/>
+          </a:xfrm>
+          <a:prstGeom prst="straightConnector1">
+            <a:avLst/>
+          </a:prstGeom>
+          <a:ln w="28575">
+            <a:solidFill>
+              <a:schemeClr val="bg1">
+                <a:lumMod val="50000"/>
+              </a:schemeClr>
+            </a:solidFill>
+            <a:tailEnd type="triangle"/>
+          </a:ln>
+        </p:spPr>
+        <p:style>
+          <a:lnRef idx="1">
+            <a:schemeClr val="accent1"/>
+          </a:lnRef>
+          <a:fillRef idx="0">
+            <a:schemeClr val="accent1"/>
+          </a:fillRef>
+          <a:effectRef idx="0">
+            <a:schemeClr val="accent1"/>
+          </a:effectRef>
+          <a:fontRef idx="minor">
+            <a:schemeClr val="tx1"/>
+          </a:fontRef>
+        </p:style>
+      </p:cxnSp>
+      <p:cxnSp>
+        <p:nvCxnSpPr>
+          <p:cNvPr id="19" name="Straight Arrow Connector 18">
+            <a:extLst>
+              <a:ext uri="{FF2B5EF4-FFF2-40B4-BE49-F238E27FC236}">
+                <a16:creationId xmlns:a16="http://schemas.microsoft.com/office/drawing/2014/main" id="{4B57B62A-CCFC-A084-8FA8-EC849087F0DB}"/>
+              </a:ext>
+            </a:extLst>
+          </p:cNvPr>
+          <p:cNvCxnSpPr>
+            <a:cxnSpLocks/>
+          </p:cNvCxnSpPr>
+          <p:nvPr/>
+        </p:nvCxnSpPr>
+        <p:spPr>
+          <a:xfrm>
+            <a:off x="7296635" y="3760735"/>
+            <a:ext cx="576705" cy="437192"/>
+          </a:xfrm>
+          <a:prstGeom prst="straightConnector1">
+            <a:avLst/>
+          </a:prstGeom>
+          <a:ln w="28575">
+            <a:solidFill>
+              <a:schemeClr val="bg1">
+                <a:lumMod val="50000"/>
+              </a:schemeClr>
+            </a:solidFill>
+            <a:prstDash val="dash"/>
+            <a:tailEnd type="triangle"/>
+          </a:ln>
+        </p:spPr>
+        <p:style>
+          <a:lnRef idx="1">
+            <a:schemeClr val="accent1"/>
+          </a:lnRef>
+          <a:fillRef idx="0">
+            <a:schemeClr val="accent1"/>
+          </a:fillRef>
+          <a:effectRef idx="0">
+            <a:schemeClr val="accent1"/>
+          </a:effectRef>
+          <a:fontRef idx="minor">
+            <a:schemeClr val="tx1"/>
+          </a:fontRef>
+        </p:style>
+      </p:cxnSp>
+      <p:cxnSp>
+        <p:nvCxnSpPr>
+          <p:cNvPr id="24" name="Straight Arrow Connector 23">
+            <a:extLst>
+              <a:ext uri="{FF2B5EF4-FFF2-40B4-BE49-F238E27FC236}">
+                <a16:creationId xmlns:a16="http://schemas.microsoft.com/office/drawing/2014/main" id="{DCE1E2EF-A89A-E4A5-2FA5-45A460B532EF}"/>
+              </a:ext>
+            </a:extLst>
+          </p:cNvPr>
+          <p:cNvCxnSpPr>
+            <a:cxnSpLocks/>
+          </p:cNvCxnSpPr>
+          <p:nvPr/>
+        </p:nvCxnSpPr>
+        <p:spPr>
+          <a:xfrm>
+            <a:off x="7275177" y="3850272"/>
+            <a:ext cx="702331" cy="1315494"/>
+          </a:xfrm>
+          <a:prstGeom prst="straightConnector1">
+            <a:avLst/>
+          </a:prstGeom>
+          <a:ln w="28575">
+            <a:solidFill>
+              <a:schemeClr val="bg1">
+                <a:lumMod val="50000"/>
+              </a:schemeClr>
+            </a:solidFill>
+            <a:prstDash val="dash"/>
+            <a:tailEnd type="triangle"/>
+          </a:ln>
+        </p:spPr>
+        <p:style>
+          <a:lnRef idx="1">
+            <a:schemeClr val="accent1"/>
+          </a:lnRef>
+          <a:fillRef idx="0">
+            <a:schemeClr val="accent1"/>
+          </a:fillRef>
+          <a:effectRef idx="0">
+            <a:schemeClr val="accent1"/>
+          </a:effectRef>
+          <a:fontRef idx="minor">
+            <a:schemeClr val="tx1"/>
+          </a:fontRef>
+        </p:style>
+      </p:cxnSp>
+      <p:cxnSp>
+        <p:nvCxnSpPr>
+          <p:cNvPr id="27" name="Straight Arrow Connector 26">
+            <a:extLst>
+              <a:ext uri="{FF2B5EF4-FFF2-40B4-BE49-F238E27FC236}">
+                <a16:creationId xmlns:a16="http://schemas.microsoft.com/office/drawing/2014/main" id="{2AA8370A-F25F-B894-668C-5EF82B503CAE}"/>
+              </a:ext>
+            </a:extLst>
+          </p:cNvPr>
+          <p:cNvCxnSpPr>
+            <a:cxnSpLocks/>
+          </p:cNvCxnSpPr>
+          <p:nvPr/>
+        </p:nvCxnSpPr>
+        <p:spPr>
+          <a:xfrm>
+            <a:off x="9592686" y="3280322"/>
+            <a:ext cx="505299" cy="0"/>
+          </a:xfrm>
+          <a:prstGeom prst="straightConnector1">
+            <a:avLst/>
+          </a:prstGeom>
+          <a:ln w="28575">
+            <a:solidFill>
+              <a:schemeClr val="bg1">
+                <a:lumMod val="50000"/>
+              </a:schemeClr>
+            </a:solidFill>
+            <a:tailEnd type="triangle"/>
+          </a:ln>
+        </p:spPr>
+        <p:style>
+          <a:lnRef idx="1">
+            <a:schemeClr val="accent1"/>
+          </a:lnRef>
+          <a:fillRef idx="0">
+            <a:schemeClr val="accent1"/>
+          </a:fillRef>
+          <a:effectRef idx="0">
+            <a:schemeClr val="accent1"/>
+          </a:effectRef>
+          <a:fontRef idx="minor">
+            <a:schemeClr val="tx1"/>
+          </a:fontRef>
+        </p:style>
+      </p:cxnSp>
+      <p:sp>
+        <p:nvSpPr>
+          <p:cNvPr id="2" name="TextBox 1">
+            <a:extLst>
+              <a:ext uri="{FF2B5EF4-FFF2-40B4-BE49-F238E27FC236}">
+                <a16:creationId xmlns:a16="http://schemas.microsoft.com/office/drawing/2014/main" id="{52EA8736-55C8-5CFE-B7F6-5ADFFA5C2651}"/>
+              </a:ext>
+            </a:extLst>
+          </p:cNvPr>
+          <p:cNvSpPr txBox="1"/>
+          <p:nvPr/>
+        </p:nvSpPr>
+        <p:spPr>
+          <a:xfrm>
+            <a:off x="507056" y="4508019"/>
+            <a:ext cx="6609182" cy="646331"/>
+          </a:xfrm>
+          <a:prstGeom prst="rect">
+            <a:avLst/>
+          </a:prstGeom>
+          <a:noFill/>
+        </p:spPr>
+        <p:txBody>
+          <a:bodyPr wrap="none" rtlCol="0">
+            <a:spAutoFit/>
+          </a:bodyPr>
+          <a:lstStyle/>
+          <a:p>
+            <a:r>
+              <a:rPr lang="en-US" dirty="0"/>
+              <a:t>Reads = 1 channel</a:t>
+            </a:r>
+          </a:p>
+          <a:p>
+            <a:r>
+              <a:rPr lang="en-US" dirty="0"/>
+              <a:t>Channel gets created when we need to initiate or modify a data flow</a:t>
+            </a:r>
+          </a:p>
+        </p:txBody>
+      </p:sp>
+      <p:sp>
+        <p:nvSpPr>
+          <p:cNvPr id="6" name="TextBox 5">
+            <a:extLst>
+              <a:ext uri="{FF2B5EF4-FFF2-40B4-BE49-F238E27FC236}">
+                <a16:creationId xmlns:a16="http://schemas.microsoft.com/office/drawing/2014/main" id="{6727E8CE-D22C-9703-04E7-B46D0FDF8DEE}"/>
+              </a:ext>
+            </a:extLst>
+          </p:cNvPr>
+          <p:cNvSpPr txBox="1"/>
+          <p:nvPr/>
+        </p:nvSpPr>
+        <p:spPr>
+          <a:xfrm>
+            <a:off x="298826" y="6060119"/>
+            <a:ext cx="9103774" cy="369332"/>
+          </a:xfrm>
+          <a:prstGeom prst="rect">
+            <a:avLst/>
+          </a:prstGeom>
+          <a:noFill/>
+        </p:spPr>
+        <p:txBody>
+          <a:bodyPr wrap="none" rtlCol="0">
+            <a:spAutoFit/>
+          </a:bodyPr>
+          <a:lstStyle/>
+          <a:p>
+            <a:r>
+              <a:rPr lang="en-US" dirty="0"/>
+              <a:t>Channels – not only data, but also a logic behind how data is going to flow through the pipeline</a:t>
+            </a:r>
+          </a:p>
+        </p:txBody>
+      </p:sp>
+    </p:spTree>
+    <p:extLst>
+      <p:ext uri="{BB962C8B-B14F-4D97-AF65-F5344CB8AC3E}">
+        <p14:creationId xmlns:p14="http://schemas.microsoft.com/office/powerpoint/2010/main" val="4280788472"/>
+      </p:ext>
+    </p:extLst>
+  </p:cSld>
+  <p:clrMapOvr>
+    <a:masterClrMapping/>
+  </p:clrMapOvr>
+</p:sld>
+</file>
+
+<file path=ppt/slides/slide13.xml><?xml version="1.0" encoding="utf-8"?>
+<p:sld xmlns:a="http://schemas.openxmlformats.org/drawingml/2006/main" xmlns:r="http://schemas.openxmlformats.org/officeDocument/2006/relationships" xmlns:p="http://schemas.openxmlformats.org/presentationml/2006/main">
+  <p:cSld>
+    <p:spTree>
+      <p:nvGrpSpPr>
+        <p:cNvPr id="1" name="">
+          <a:extLst>
+            <a:ext uri="{FF2B5EF4-FFF2-40B4-BE49-F238E27FC236}">
+              <a16:creationId xmlns:a16="http://schemas.microsoft.com/office/drawing/2014/main" id="{D7630D0A-EFC7-E604-4797-27EFE0CD94D5}"/>
+            </a:ext>
+          </a:extLst>
+        </p:cNvPr>
+        <p:cNvGrpSpPr/>
+        <p:nvPr/>
+      </p:nvGrpSpPr>
+      <p:grpSpPr>
+        <a:xfrm>
+          <a:off x="0" y="0"/>
+          <a:ext cx="0" cy="0"/>
+          <a:chOff x="0" y="0"/>
+          <a:chExt cx="0" cy="0"/>
+        </a:xfrm>
+      </p:grpSpPr>
+      <p:sp>
+        <p:nvSpPr>
+          <p:cNvPr id="2" name="Title 1">
+            <a:extLst>
+              <a:ext uri="{FF2B5EF4-FFF2-40B4-BE49-F238E27FC236}">
+                <a16:creationId xmlns:a16="http://schemas.microsoft.com/office/drawing/2014/main" id="{F16E025B-6EFB-C1F8-F10F-F49939B2E322}"/>
+              </a:ext>
+            </a:extLst>
+          </p:cNvPr>
+          <p:cNvSpPr>
+            <a:spLocks noGrp="1"/>
+          </p:cNvSpPr>
+          <p:nvPr>
+            <p:ph type="title"/>
+          </p:nvPr>
+        </p:nvSpPr>
+        <p:spPr/>
+        <p:txBody>
+          <a:bodyPr/>
+          <a:lstStyle/>
+          <a:p>
+            <a:r>
+              <a:rPr lang="en-US" dirty="0" err="1"/>
+              <a:t>Nextflow</a:t>
+            </a:r>
+            <a:r>
+              <a:rPr lang="en-US" dirty="0"/>
+              <a:t> components: </a:t>
+            </a:r>
+            <a:r>
+              <a:rPr lang="en-US" b="1" dirty="0"/>
+              <a:t>workflows</a:t>
+            </a:r>
+          </a:p>
+        </p:txBody>
+      </p:sp>
+      <p:sp>
+        <p:nvSpPr>
+          <p:cNvPr id="3" name="Content Placeholder 2">
+            <a:extLst>
+              <a:ext uri="{FF2B5EF4-FFF2-40B4-BE49-F238E27FC236}">
+                <a16:creationId xmlns:a16="http://schemas.microsoft.com/office/drawing/2014/main" id="{1410A44D-B6A5-5208-9EE8-7C55FA293879}"/>
+              </a:ext>
+            </a:extLst>
+          </p:cNvPr>
+          <p:cNvSpPr>
+            <a:spLocks noGrp="1"/>
+          </p:cNvSpPr>
+          <p:nvPr>
+            <p:ph idx="1"/>
+          </p:nvPr>
+        </p:nvSpPr>
+        <p:spPr/>
+        <p:txBody>
+          <a:bodyPr/>
+          <a:lstStyle/>
+          <a:p>
+            <a:pPr marL="0" indent="0">
+              <a:buNone/>
+            </a:pPr>
+            <a:r>
+              <a:rPr lang="en-US" b="1" dirty="0">
+                <a:solidFill>
+                  <a:schemeClr val="accent5"/>
+                </a:solidFill>
+              </a:rPr>
+              <a:t>Workflows</a:t>
+            </a:r>
+            <a:r>
+              <a:rPr lang="en-US" dirty="0"/>
+              <a:t> orchestrate how processes connect and execute. They define:</a:t>
+            </a:r>
+          </a:p>
+          <a:p>
+            <a:r>
+              <a:rPr lang="en-US" dirty="0"/>
+              <a:t>The order and dependencies between processes</a:t>
+            </a:r>
+          </a:p>
+          <a:p>
+            <a:r>
+              <a:rPr lang="en-US" dirty="0"/>
+              <a:t>How data flows from one process to another</a:t>
+            </a:r>
+          </a:p>
+          <a:p>
+            <a:r>
+              <a:rPr lang="en-US" dirty="0"/>
+              <a:t>Conditional execution logic</a:t>
+            </a:r>
+          </a:p>
+          <a:p>
+            <a:pPr marL="0" indent="0">
+              <a:buNone/>
+            </a:pPr>
+            <a:endParaRPr lang="en-US" dirty="0"/>
+          </a:p>
+          <a:p>
+            <a:pPr marL="0" indent="0">
+              <a:buNone/>
+            </a:pPr>
+            <a:r>
+              <a:rPr lang="en-US" dirty="0"/>
+              <a:t>A workflow composes multiple processes into a complete data analysis pipeline.</a:t>
+            </a:r>
+          </a:p>
+        </p:txBody>
+      </p:sp>
+      <p:pic>
+        <p:nvPicPr>
+          <p:cNvPr id="3074" name="Picture 2" descr="Floor plan - Free buildings icons">
+            <a:extLst>
+              <a:ext uri="{FF2B5EF4-FFF2-40B4-BE49-F238E27FC236}">
+                <a16:creationId xmlns:a16="http://schemas.microsoft.com/office/drawing/2014/main" id="{E0AFBA6D-38EF-DF3F-B32F-B09C3C546ED7}"/>
+              </a:ext>
+            </a:extLst>
+          </p:cNvPr>
+          <p:cNvPicPr>
+            <a:picLocks noChangeAspect="1" noChangeArrowheads="1"/>
+          </p:cNvPicPr>
+          <p:nvPr/>
+        </p:nvPicPr>
+        <p:blipFill>
+          <a:blip r:embed="rId2">
+            <a:extLst>
+              <a:ext uri="{BEBA8EAE-BF5A-486C-A8C5-ECC9F3942E4B}">
+                <a14:imgProps xmlns:a14="http://schemas.microsoft.com/office/drawing/2010/main">
+                  <a14:imgLayer r:embed="rId3">
+                    <a14:imgEffect>
+                      <a14:saturation sat="0"/>
+                    </a14:imgEffect>
+                  </a14:imgLayer>
+                </a14:imgProps>
+              </a:ext>
+              <a:ext uri="{28A0092B-C50C-407E-A947-70E740481C1C}">
+                <a14:useLocalDpi xmlns:a14="http://schemas.microsoft.com/office/drawing/2010/main" val="0"/>
+              </a:ext>
+            </a:extLst>
+          </a:blip>
+          <a:srcRect/>
+          <a:stretch>
+            <a:fillRect/>
+          </a:stretch>
+        </p:blipFill>
+        <p:spPr bwMode="auto">
+          <a:xfrm>
+            <a:off x="9372922" y="509286"/>
+            <a:ext cx="1038065" cy="1038065"/>
+          </a:xfrm>
+          <a:prstGeom prst="rect">
+            <a:avLst/>
+          </a:prstGeom>
+          <a:noFill/>
+          <a:extLst>
+            <a:ext uri="{909E8E84-426E-40DD-AFC4-6F175D3DCCD1}">
+              <a14:hiddenFill xmlns:a14="http://schemas.microsoft.com/office/drawing/2010/main">
+                <a:solidFill>
+                  <a:srgbClr val="FFFFFF"/>
+                </a:solidFill>
+              </a14:hiddenFill>
+            </a:ext>
+          </a:extLst>
+        </p:spPr>
+      </p:pic>
+    </p:spTree>
+    <p:extLst>
+      <p:ext uri="{BB962C8B-B14F-4D97-AF65-F5344CB8AC3E}">
+        <p14:creationId xmlns:p14="http://schemas.microsoft.com/office/powerpoint/2010/main" val="831354523"/>
+      </p:ext>
+    </p:extLst>
+  </p:cSld>
+  <p:clrMapOvr>
+    <a:masterClrMapping/>
+  </p:clrMapOvr>
+</p:sld>
+</file>
+
+<file path=ppt/slides/slide14.xml><?xml version="1.0" encoding="utf-8"?>
+<p:sld xmlns:a="http://schemas.openxmlformats.org/drawingml/2006/main" xmlns:r="http://schemas.openxmlformats.org/officeDocument/2006/relationships" xmlns:p="http://schemas.openxmlformats.org/presentationml/2006/main">
+  <p:cSld>
+    <p:spTree>
+      <p:nvGrpSpPr>
+        <p:cNvPr id="1" name="">
+          <a:extLst>
+            <a:ext uri="{FF2B5EF4-FFF2-40B4-BE49-F238E27FC236}">
+              <a16:creationId xmlns:a16="http://schemas.microsoft.com/office/drawing/2014/main" id="{6F9009F4-010A-5D70-CA6A-D0AA9A1BD035}"/>
+            </a:ext>
+          </a:extLst>
+        </p:cNvPr>
+        <p:cNvGrpSpPr/>
+        <p:nvPr/>
+      </p:nvGrpSpPr>
+      <p:grpSpPr>
+        <a:xfrm>
+          <a:off x="0" y="0"/>
+          <a:ext cx="0" cy="0"/>
+          <a:chOff x="0" y="0"/>
+          <a:chExt cx="0" cy="0"/>
+        </a:xfrm>
+      </p:grpSpPr>
+      <p:sp>
+        <p:nvSpPr>
+          <p:cNvPr id="11" name="TextBox 10">
+            <a:extLst>
+              <a:ext uri="{FF2B5EF4-FFF2-40B4-BE49-F238E27FC236}">
+                <a16:creationId xmlns:a16="http://schemas.microsoft.com/office/drawing/2014/main" id="{AEE21A41-5CCE-BF3D-34F8-BE9F217F2891}"/>
+              </a:ext>
+            </a:extLst>
+          </p:cNvPr>
+          <p:cNvSpPr txBox="1"/>
+          <p:nvPr/>
+        </p:nvSpPr>
+        <p:spPr>
+          <a:xfrm>
+            <a:off x="925364" y="1690688"/>
+            <a:ext cx="5499558" cy="5262979"/>
+          </a:xfrm>
+          <a:prstGeom prst="rect">
+            <a:avLst/>
+          </a:prstGeom>
+          <a:noFill/>
+        </p:spPr>
+        <p:txBody>
+          <a:bodyPr wrap="square" rtlCol="0">
+            <a:spAutoFit/>
+          </a:bodyPr>
+          <a:lstStyle/>
+          <a:p>
+            <a:r>
+              <a:rPr lang="en-US" dirty="0"/>
+              <a:t>The </a:t>
+            </a:r>
+            <a:r>
+              <a:rPr lang="en-US" b="1" dirty="0">
+                <a:solidFill>
+                  <a:srgbClr val="C00000"/>
+                </a:solidFill>
+              </a:rPr>
+              <a:t>work/ </a:t>
+            </a:r>
+            <a:r>
+              <a:rPr lang="en-US" dirty="0"/>
+              <a:t>is where </a:t>
+            </a:r>
+            <a:r>
+              <a:rPr lang="en-US" b="1" dirty="0"/>
+              <a:t>all the actual execution happens</a:t>
+            </a:r>
+            <a:r>
+              <a:rPr lang="en-US" dirty="0"/>
+              <a:t>. Every process runs in its own isolated subdirectory within work/.</a:t>
+            </a:r>
+          </a:p>
+          <a:p>
+            <a:pPr marL="285750" indent="-285750">
+              <a:buFont typeface="Arial" panose="020B0604020202020204" pitchFamily="34" charset="0"/>
+              <a:buChar char="•"/>
+            </a:pPr>
+            <a:r>
+              <a:rPr lang="en-US" dirty="0"/>
+              <a:t>Contains temporary files and logs</a:t>
+            </a:r>
+          </a:p>
+          <a:p>
+            <a:pPr marL="285750" indent="-285750">
+              <a:buFont typeface="Arial" panose="020B0604020202020204" pitchFamily="34" charset="0"/>
+              <a:buChar char="•"/>
+            </a:pPr>
+            <a:r>
+              <a:rPr lang="en-US" dirty="0"/>
+              <a:t>Uses cryptic hash subdirectories (e.g., work/a3/f2d8e9...)</a:t>
+            </a:r>
+          </a:p>
+          <a:p>
+            <a:pPr marL="285750" indent="-285750">
+              <a:buFont typeface="Arial" panose="020B0604020202020204" pitchFamily="34" charset="0"/>
+              <a:buChar char="•"/>
+            </a:pPr>
+            <a:r>
+              <a:rPr lang="en-US" dirty="0"/>
+              <a:t>Should be cleaned periodically but useful for debugging</a:t>
+            </a:r>
+          </a:p>
+          <a:p>
+            <a:pPr marL="285750" indent="-285750">
+              <a:buFont typeface="Arial" panose="020B0604020202020204" pitchFamily="34" charset="0"/>
+              <a:buChar char="•"/>
+            </a:pPr>
+            <a:r>
+              <a:rPr lang="en-US" dirty="0"/>
+              <a:t>Usually not where you want your final results</a:t>
+            </a:r>
+          </a:p>
+          <a:p>
+            <a:pPr marL="285750" indent="-285750">
+              <a:buFont typeface="Arial" panose="020B0604020202020204" pitchFamily="34" charset="0"/>
+              <a:buChar char="•"/>
+            </a:pPr>
+            <a:r>
+              <a:rPr lang="en-US" dirty="0"/>
+              <a:t>Allows to </a:t>
+            </a:r>
+            <a:r>
+              <a:rPr lang="en-US" sz="1200" dirty="0">
+                <a:latin typeface="Menlo" panose="020B0609030804020204" pitchFamily="49" charset="0"/>
+                <a:ea typeface="Menlo" panose="020B0609030804020204" pitchFamily="49" charset="0"/>
+                <a:cs typeface="Menlo" panose="020B0609030804020204" pitchFamily="49" charset="0"/>
+              </a:rPr>
+              <a:t>–resume </a:t>
+            </a:r>
+            <a:r>
+              <a:rPr lang="en-US" dirty="0"/>
+              <a:t>pipeline at different stages</a:t>
+            </a:r>
+          </a:p>
+          <a:p>
+            <a:pPr marL="285750" indent="-285750">
+              <a:buFont typeface="Arial" panose="020B0604020202020204" pitchFamily="34" charset="0"/>
+              <a:buChar char="•"/>
+            </a:pPr>
+            <a:endParaRPr lang="en-US" dirty="0"/>
+          </a:p>
+          <a:p>
+            <a:r>
+              <a:rPr lang="en-US" b="1" dirty="0"/>
+              <a:t>Important for troubleshooting</a:t>
+            </a:r>
+            <a:r>
+              <a:rPr lang="en-US" dirty="0"/>
+              <a:t>: When something fails, the error message tells you which work subdirectory to check.</a:t>
+            </a:r>
+          </a:p>
+          <a:p>
+            <a:endParaRPr lang="en-US" dirty="0"/>
+          </a:p>
+          <a:p>
+            <a:r>
+              <a:rPr lang="en-US" sz="1600" b="1" dirty="0"/>
+              <a:t>The conveyor belt (channel) doesn't carry the actual products through the customer-facing factory floor</a:t>
+            </a:r>
+            <a:r>
+              <a:rPr lang="en-US" sz="1600" dirty="0"/>
+              <a:t> - it carries instructions about where to find them in the workshop!</a:t>
+            </a:r>
+          </a:p>
+          <a:p>
+            <a:endParaRPr lang="en-US" dirty="0"/>
+          </a:p>
+        </p:txBody>
+      </p:sp>
+      <p:sp>
+        <p:nvSpPr>
+          <p:cNvPr id="12" name="Title 1">
+            <a:extLst>
+              <a:ext uri="{FF2B5EF4-FFF2-40B4-BE49-F238E27FC236}">
+                <a16:creationId xmlns:a16="http://schemas.microsoft.com/office/drawing/2014/main" id="{BB77EEF3-8889-EB33-D27E-3F77D73D1546}"/>
+              </a:ext>
+            </a:extLst>
+          </p:cNvPr>
+          <p:cNvSpPr>
+            <a:spLocks noGrp="1"/>
+          </p:cNvSpPr>
+          <p:nvPr>
+            <p:ph type="title"/>
+          </p:nvPr>
+        </p:nvSpPr>
+        <p:spPr>
+          <a:xfrm>
+            <a:off x="838200" y="365125"/>
+            <a:ext cx="10515600" cy="1325563"/>
+          </a:xfrm>
+        </p:spPr>
+        <p:txBody>
+          <a:bodyPr/>
+          <a:lstStyle/>
+          <a:p>
+            <a:r>
+              <a:rPr lang="en-US" dirty="0" err="1"/>
+              <a:t>Nextflow</a:t>
+            </a:r>
+            <a:r>
+              <a:rPr lang="en-US" dirty="0"/>
+              <a:t> components: </a:t>
+            </a:r>
+            <a:r>
+              <a:rPr lang="en-US" b="1" dirty="0"/>
+              <a:t>work directory</a:t>
+            </a:r>
+          </a:p>
+        </p:txBody>
+      </p:sp>
+      <p:pic>
+        <p:nvPicPr>
+          <p:cNvPr id="15" name="Picture 14">
+            <a:extLst>
+              <a:ext uri="{FF2B5EF4-FFF2-40B4-BE49-F238E27FC236}">
+                <a16:creationId xmlns:a16="http://schemas.microsoft.com/office/drawing/2014/main" id="{141CA3CA-489D-B6C8-49AD-4C308DB0A1EC}"/>
+              </a:ext>
+            </a:extLst>
+          </p:cNvPr>
+          <p:cNvPicPr>
+            <a:picLocks noChangeAspect="1"/>
+          </p:cNvPicPr>
+          <p:nvPr/>
+        </p:nvPicPr>
+        <p:blipFill>
+          <a:blip r:embed="rId2"/>
+          <a:stretch>
+            <a:fillRect/>
+          </a:stretch>
+        </p:blipFill>
+        <p:spPr>
+          <a:xfrm>
+            <a:off x="7158049" y="2157721"/>
+            <a:ext cx="4410894" cy="2892173"/>
+          </a:xfrm>
+          <a:prstGeom prst="rect">
+            <a:avLst/>
+          </a:prstGeom>
+        </p:spPr>
+      </p:pic>
+      <p:sp>
+        <p:nvSpPr>
+          <p:cNvPr id="17" name="TextBox 16">
+            <a:extLst>
+              <a:ext uri="{FF2B5EF4-FFF2-40B4-BE49-F238E27FC236}">
+                <a16:creationId xmlns:a16="http://schemas.microsoft.com/office/drawing/2014/main" id="{5F7D7772-1DCF-BBB2-F068-BAD2D977C2B2}"/>
+              </a:ext>
+            </a:extLst>
+          </p:cNvPr>
+          <p:cNvSpPr txBox="1"/>
+          <p:nvPr/>
+        </p:nvSpPr>
+        <p:spPr>
+          <a:xfrm>
+            <a:off x="7112000" y="5159945"/>
+            <a:ext cx="4241800" cy="461665"/>
+          </a:xfrm>
+          <a:prstGeom prst="rect">
+            <a:avLst/>
+          </a:prstGeom>
+          <a:noFill/>
+        </p:spPr>
+        <p:txBody>
+          <a:bodyPr wrap="square">
+            <a:spAutoFit/>
+          </a:bodyPr>
+          <a:lstStyle/>
+          <a:p>
+            <a:r>
+              <a:rPr lang="en-US" sz="1200" dirty="0">
+                <a:solidFill>
+                  <a:schemeClr val="tx1">
+                    <a:lumMod val="65000"/>
+                    <a:lumOff val="35000"/>
+                  </a:schemeClr>
+                </a:solidFill>
+              </a:rPr>
+              <a:t>Each hash subdirectory (like </a:t>
+            </a:r>
+            <a:r>
+              <a:rPr lang="en-US" sz="1200" dirty="0">
+                <a:solidFill>
+                  <a:schemeClr val="tx1">
+                    <a:lumMod val="65000"/>
+                    <a:lumOff val="35000"/>
+                  </a:schemeClr>
+                </a:solidFill>
+                <a:latin typeface="Courier New" panose="02070309020205020404" pitchFamily="49" charset="0"/>
+              </a:rPr>
+              <a:t>a3/f2d8e9...</a:t>
+            </a:r>
+            <a:r>
+              <a:rPr lang="en-US" sz="1200" dirty="0">
+                <a:solidFill>
+                  <a:schemeClr val="tx1">
+                    <a:lumMod val="65000"/>
+                    <a:lumOff val="35000"/>
+                  </a:schemeClr>
+                </a:solidFill>
+              </a:rPr>
+              <a:t>) represents </a:t>
+            </a:r>
+            <a:r>
+              <a:rPr lang="en-US" sz="1200" b="1" dirty="0">
+                <a:solidFill>
+                  <a:schemeClr val="tx1">
+                    <a:lumMod val="65000"/>
+                    <a:lumOff val="35000"/>
+                  </a:schemeClr>
+                </a:solidFill>
+              </a:rPr>
+              <a:t>one task execution</a:t>
+            </a:r>
+            <a:r>
+              <a:rPr lang="en-US" sz="1200" dirty="0">
+                <a:solidFill>
+                  <a:schemeClr val="tx1">
+                    <a:lumMod val="65000"/>
+                    <a:lumOff val="35000"/>
+                  </a:schemeClr>
+                </a:solidFill>
+              </a:rPr>
+              <a:t> - one sample going through one process.</a:t>
+            </a:r>
+          </a:p>
+        </p:txBody>
+      </p:sp>
+      <p:pic>
+        <p:nvPicPr>
+          <p:cNvPr id="3076" name="Picture 4" descr="Black line icon for storage room 42725354 Vector Art at Vecteezy">
+            <a:extLst>
+              <a:ext uri="{FF2B5EF4-FFF2-40B4-BE49-F238E27FC236}">
+                <a16:creationId xmlns:a16="http://schemas.microsoft.com/office/drawing/2014/main" id="{F1AEF158-55D7-D9DC-3F3D-5A13B5FF92A1}"/>
+              </a:ext>
+            </a:extLst>
+          </p:cNvPr>
+          <p:cNvPicPr>
+            <a:picLocks noChangeAspect="1" noChangeArrowheads="1"/>
+          </p:cNvPicPr>
+          <p:nvPr/>
+        </p:nvPicPr>
+        <p:blipFill>
+          <a:blip r:embed="rId3">
+            <a:extLst>
+              <a:ext uri="{28A0092B-C50C-407E-A947-70E740481C1C}">
+                <a14:useLocalDpi xmlns:a14="http://schemas.microsoft.com/office/drawing/2010/main" val="0"/>
+              </a:ext>
+            </a:extLst>
+          </a:blip>
+          <a:srcRect/>
+          <a:stretch>
+            <a:fillRect/>
+          </a:stretch>
+        </p:blipFill>
+        <p:spPr bwMode="auto">
+          <a:xfrm>
+            <a:off x="9857210" y="647074"/>
+            <a:ext cx="635365" cy="635365"/>
+          </a:xfrm>
+          <a:prstGeom prst="rect">
+            <a:avLst/>
+          </a:prstGeom>
+          <a:noFill/>
+          <a:extLst>
+            <a:ext uri="{909E8E84-426E-40DD-AFC4-6F175D3DCCD1}">
+              <a14:hiddenFill xmlns:a14="http://schemas.microsoft.com/office/drawing/2010/main">
+                <a:solidFill>
+                  <a:srgbClr val="FFFFFF"/>
+                </a:solidFill>
+              </a14:hiddenFill>
+            </a:ext>
+          </a:extLst>
+        </p:spPr>
+      </p:pic>
+    </p:spTree>
+    <p:extLst>
+      <p:ext uri="{BB962C8B-B14F-4D97-AF65-F5344CB8AC3E}">
+        <p14:creationId xmlns:p14="http://schemas.microsoft.com/office/powerpoint/2010/main" val="1546092884"/>
+      </p:ext>
+    </p:extLst>
+  </p:cSld>
+  <p:clrMapOvr>
+    <a:masterClrMapping/>
+  </p:clrMapOvr>
+</p:sld>
+</file>
+
+<file path=ppt/slides/slide15.xml><?xml version="1.0" encoding="utf-8"?>
+<p:sld xmlns:a="http://schemas.openxmlformats.org/drawingml/2006/main" xmlns:r="http://schemas.openxmlformats.org/officeDocument/2006/relationships" xmlns:p="http://schemas.openxmlformats.org/presentationml/2006/main">
+  <p:cSld>
+    <p:spTree>
+      <p:nvGrpSpPr>
+        <p:cNvPr id="1" name=""/>
+        <p:cNvGrpSpPr/>
+        <p:nvPr/>
+      </p:nvGrpSpPr>
+      <p:grpSpPr>
+        <a:xfrm>
+          <a:off x="0" y="0"/>
+          <a:ext cx="0" cy="0"/>
+          <a:chOff x="0" y="0"/>
+          <a:chExt cx="0" cy="0"/>
+        </a:xfrm>
+      </p:grpSpPr>
+      <p:pic>
+        <p:nvPicPr>
+          <p:cNvPr id="5124" name="Picture 4" descr="Industrial conveyor belt line vector illustration. Conveyor process  abstract machine production Stock Vector Image &amp; Art - Alamy">
+            <a:extLst>
+              <a:ext uri="{FF2B5EF4-FFF2-40B4-BE49-F238E27FC236}">
+                <a16:creationId xmlns:a16="http://schemas.microsoft.com/office/drawing/2014/main" id="{5B846E23-333C-EC1B-6E34-8636F94E9D61}"/>
+              </a:ext>
+            </a:extLst>
+          </p:cNvPr>
+          <p:cNvPicPr>
+            <a:picLocks noChangeAspect="1" noChangeArrowheads="1"/>
+          </p:cNvPicPr>
+          <p:nvPr/>
+        </p:nvPicPr>
+        <p:blipFill rotWithShape="1">
+          <a:blip r:embed="rId2">
+            <a:extLst>
+              <a:ext uri="{28A0092B-C50C-407E-A947-70E740481C1C}">
+                <a14:useLocalDpi xmlns:a14="http://schemas.microsoft.com/office/drawing/2010/main" val="0"/>
+              </a:ext>
+            </a:extLst>
+          </a:blip>
+          <a:srcRect b="16962"/>
+          <a:stretch>
+            <a:fillRect/>
+          </a:stretch>
+        </p:blipFill>
+        <p:spPr bwMode="auto">
+          <a:xfrm>
+            <a:off x="2208172" y="1241529"/>
+            <a:ext cx="8232193" cy="4374941"/>
+          </a:xfrm>
+          <a:prstGeom prst="rect">
+            <a:avLst/>
+          </a:prstGeom>
+          <a:noFill/>
+          <a:extLst>
+            <a:ext uri="{909E8E84-426E-40DD-AFC4-6F175D3DCCD1}">
+              <a14:hiddenFill xmlns:a14="http://schemas.microsoft.com/office/drawing/2010/main">
+                <a:solidFill>
+                  <a:srgbClr val="FFFFFF"/>
+                </a:solidFill>
+              </a14:hiddenFill>
+            </a:ext>
+          </a:extLst>
+        </p:spPr>
+      </p:pic>
+      <p:sp>
+        <p:nvSpPr>
+          <p:cNvPr id="2" name="Oval 1">
+            <a:extLst>
+              <a:ext uri="{FF2B5EF4-FFF2-40B4-BE49-F238E27FC236}">
+                <a16:creationId xmlns:a16="http://schemas.microsoft.com/office/drawing/2014/main" id="{3EBE1959-0A4E-237E-64F3-F30C5C3AB922}"/>
+              </a:ext>
+            </a:extLst>
+          </p:cNvPr>
+          <p:cNvSpPr/>
+          <p:nvPr/>
+        </p:nvSpPr>
+        <p:spPr>
+          <a:xfrm>
+            <a:off x="2208171" y="3044142"/>
+            <a:ext cx="2978631" cy="2572328"/>
+          </a:xfrm>
+          <a:prstGeom prst="ellipse">
+            <a:avLst/>
+          </a:prstGeom>
+          <a:noFill/>
+          <a:ln w="38100">
+            <a:solidFill>
+              <a:schemeClr val="tx1"/>
+            </a:solidFill>
+          </a:ln>
+        </p:spPr>
+        <p:style>
+          <a:lnRef idx="2">
+            <a:schemeClr val="accent1">
+              <a:shade val="15000"/>
+            </a:schemeClr>
+          </a:lnRef>
+          <a:fillRef idx="1">
+            <a:schemeClr val="accent1"/>
+          </a:fillRef>
+          <a:effectRef idx="0">
+            <a:schemeClr val="accent1"/>
+          </a:effectRef>
+          <a:fontRef idx="minor">
+            <a:schemeClr val="lt1"/>
+          </a:fontRef>
+        </p:style>
+        <p:txBody>
+          <a:bodyPr rtlCol="0" anchor="ctr"/>
+          <a:lstStyle/>
+          <a:p>
+            <a:pPr algn="ctr"/>
+            <a:endParaRPr lang="en-US"/>
+          </a:p>
+        </p:txBody>
+      </p:sp>
+      <p:sp>
+        <p:nvSpPr>
+          <p:cNvPr id="3" name="TextBox 2">
+            <a:extLst>
+              <a:ext uri="{FF2B5EF4-FFF2-40B4-BE49-F238E27FC236}">
+                <a16:creationId xmlns:a16="http://schemas.microsoft.com/office/drawing/2014/main" id="{D55BC98E-B37A-DA70-9929-7E21645409FA}"/>
+              </a:ext>
+            </a:extLst>
+          </p:cNvPr>
+          <p:cNvSpPr txBox="1"/>
+          <p:nvPr/>
+        </p:nvSpPr>
+        <p:spPr>
+          <a:xfrm>
+            <a:off x="1179450" y="3428999"/>
+            <a:ext cx="1448003" cy="1200329"/>
+          </a:xfrm>
+          <a:prstGeom prst="rect">
+            <a:avLst/>
+          </a:prstGeom>
+          <a:noFill/>
+        </p:spPr>
+        <p:txBody>
+          <a:bodyPr wrap="square" rtlCol="0">
+            <a:spAutoFit/>
+          </a:bodyPr>
+          <a:lstStyle/>
+          <a:p>
+            <a:r>
+              <a:rPr lang="en-US" b="1" dirty="0"/>
+              <a:t>Processes </a:t>
+            </a:r>
+            <a:r>
+              <a:rPr lang="en-US" dirty="0"/>
+              <a:t>(tools, factory stations)</a:t>
+            </a:r>
+          </a:p>
+        </p:txBody>
+      </p:sp>
+      <p:sp>
+        <p:nvSpPr>
+          <p:cNvPr id="4" name="TextBox 3">
+            <a:extLst>
+              <a:ext uri="{FF2B5EF4-FFF2-40B4-BE49-F238E27FC236}">
+                <a16:creationId xmlns:a16="http://schemas.microsoft.com/office/drawing/2014/main" id="{3AB2DFB6-66E8-71F3-714E-BBBA2AC625F5}"/>
+              </a:ext>
+            </a:extLst>
+          </p:cNvPr>
+          <p:cNvSpPr txBox="1"/>
+          <p:nvPr/>
+        </p:nvSpPr>
+        <p:spPr>
+          <a:xfrm>
+            <a:off x="4698697" y="555457"/>
+            <a:ext cx="3251141" cy="369332"/>
+          </a:xfrm>
+          <a:prstGeom prst="rect">
+            <a:avLst/>
+          </a:prstGeom>
+          <a:noFill/>
+        </p:spPr>
+        <p:txBody>
+          <a:bodyPr wrap="square" rtlCol="0">
+            <a:spAutoFit/>
+          </a:bodyPr>
+          <a:lstStyle/>
+          <a:p>
+            <a:r>
+              <a:rPr lang="en-US" b="1" dirty="0"/>
+              <a:t>Workflow</a:t>
+            </a:r>
+            <a:r>
+              <a:rPr lang="en-US" dirty="0"/>
+              <a:t> (logic, factory plan)</a:t>
+            </a:r>
+          </a:p>
+        </p:txBody>
+      </p:sp>
+      <p:sp>
+        <p:nvSpPr>
+          <p:cNvPr id="6" name="Oval 5">
+            <a:extLst>
+              <a:ext uri="{FF2B5EF4-FFF2-40B4-BE49-F238E27FC236}">
+                <a16:creationId xmlns:a16="http://schemas.microsoft.com/office/drawing/2014/main" id="{E52505B3-8FB4-B96B-55F4-630EDFF6CC74}"/>
+              </a:ext>
+            </a:extLst>
+          </p:cNvPr>
+          <p:cNvSpPr/>
+          <p:nvPr/>
+        </p:nvSpPr>
+        <p:spPr>
+          <a:xfrm>
+            <a:off x="5425933" y="2083443"/>
+            <a:ext cx="2051312" cy="2215442"/>
+          </a:xfrm>
+          <a:prstGeom prst="ellipse">
+            <a:avLst/>
+          </a:prstGeom>
+          <a:noFill/>
+          <a:ln w="38100">
+            <a:solidFill>
+              <a:schemeClr val="tx1"/>
+            </a:solidFill>
+          </a:ln>
+        </p:spPr>
+        <p:style>
+          <a:lnRef idx="2">
+            <a:schemeClr val="accent1">
+              <a:shade val="15000"/>
+            </a:schemeClr>
+          </a:lnRef>
+          <a:fillRef idx="1">
+            <a:schemeClr val="accent1"/>
+          </a:fillRef>
+          <a:effectRef idx="0">
+            <a:schemeClr val="accent1"/>
+          </a:effectRef>
+          <a:fontRef idx="minor">
+            <a:schemeClr val="lt1"/>
+          </a:fontRef>
+        </p:style>
+        <p:txBody>
+          <a:bodyPr rtlCol="0" anchor="ctr"/>
+          <a:lstStyle/>
+          <a:p>
+            <a:pPr algn="ctr"/>
+            <a:endParaRPr lang="en-US"/>
+          </a:p>
+        </p:txBody>
+      </p:sp>
+      <p:sp>
+        <p:nvSpPr>
+          <p:cNvPr id="7" name="Right Brace 6">
+            <a:extLst>
+              <a:ext uri="{FF2B5EF4-FFF2-40B4-BE49-F238E27FC236}">
+                <a16:creationId xmlns:a16="http://schemas.microsoft.com/office/drawing/2014/main" id="{2A438F05-38E5-12B8-AAD5-3063E2A4AAA4}"/>
+              </a:ext>
+            </a:extLst>
+          </p:cNvPr>
+          <p:cNvSpPr/>
+          <p:nvPr/>
+        </p:nvSpPr>
+        <p:spPr>
+          <a:xfrm rot="16200000">
+            <a:off x="5944232" y="-2705692"/>
+            <a:ext cx="303535" cy="7775658"/>
+          </a:xfrm>
+          <a:prstGeom prst="rightBrace">
+            <a:avLst/>
+          </a:prstGeom>
+          <a:ln w="38100">
+            <a:solidFill>
+              <a:schemeClr val="tx1"/>
+            </a:solidFill>
+          </a:ln>
+        </p:spPr>
+        <p:style>
+          <a:lnRef idx="1">
+            <a:schemeClr val="accent1"/>
+          </a:lnRef>
+          <a:fillRef idx="0">
+            <a:schemeClr val="accent1"/>
+          </a:fillRef>
+          <a:effectRef idx="0">
+            <a:schemeClr val="accent1"/>
+          </a:effectRef>
+          <a:fontRef idx="minor">
+            <a:schemeClr val="tx1"/>
+          </a:fontRef>
+        </p:style>
+        <p:txBody>
+          <a:bodyPr rtlCol="0" anchor="ctr"/>
+          <a:lstStyle/>
+          <a:p>
+            <a:pPr algn="ctr"/>
+            <a:endParaRPr lang="en-US"/>
+          </a:p>
+        </p:txBody>
+      </p:sp>
+      <p:sp>
+        <p:nvSpPr>
+          <p:cNvPr id="8" name="Oval 7">
+            <a:extLst>
+              <a:ext uri="{FF2B5EF4-FFF2-40B4-BE49-F238E27FC236}">
+                <a16:creationId xmlns:a16="http://schemas.microsoft.com/office/drawing/2014/main" id="{BC164923-0666-18DF-DD14-76912076C831}"/>
+              </a:ext>
+            </a:extLst>
+          </p:cNvPr>
+          <p:cNvSpPr/>
+          <p:nvPr/>
+        </p:nvSpPr>
+        <p:spPr>
+          <a:xfrm>
+            <a:off x="5186801" y="4298885"/>
+            <a:ext cx="5253563" cy="1710237"/>
+          </a:xfrm>
+          <a:prstGeom prst="ellipse">
+            <a:avLst/>
+          </a:prstGeom>
+          <a:noFill/>
+          <a:ln w="38100">
+            <a:solidFill>
+              <a:schemeClr val="tx1"/>
+            </a:solidFill>
+          </a:ln>
+        </p:spPr>
+        <p:style>
+          <a:lnRef idx="2">
+            <a:schemeClr val="accent1">
+              <a:shade val="15000"/>
+            </a:schemeClr>
+          </a:lnRef>
+          <a:fillRef idx="1">
+            <a:schemeClr val="accent1"/>
+          </a:fillRef>
+          <a:effectRef idx="0">
+            <a:schemeClr val="accent1"/>
+          </a:effectRef>
+          <a:fontRef idx="minor">
+            <a:schemeClr val="lt1"/>
+          </a:fontRef>
+        </p:style>
+        <p:txBody>
+          <a:bodyPr rtlCol="0" anchor="ctr"/>
+          <a:lstStyle/>
+          <a:p>
+            <a:pPr algn="ctr"/>
+            <a:endParaRPr lang="en-US"/>
+          </a:p>
+        </p:txBody>
+      </p:sp>
+      <p:sp>
+        <p:nvSpPr>
+          <p:cNvPr id="9" name="TextBox 8">
+            <a:extLst>
+              <a:ext uri="{FF2B5EF4-FFF2-40B4-BE49-F238E27FC236}">
+                <a16:creationId xmlns:a16="http://schemas.microsoft.com/office/drawing/2014/main" id="{AF4CBF7F-D725-7413-DAD3-09016AB6F0A1}"/>
+              </a:ext>
+            </a:extLst>
+          </p:cNvPr>
+          <p:cNvSpPr txBox="1"/>
+          <p:nvPr/>
+        </p:nvSpPr>
+        <p:spPr>
+          <a:xfrm>
+            <a:off x="6451589" y="6044519"/>
+            <a:ext cx="3251141" cy="369332"/>
+          </a:xfrm>
+          <a:prstGeom prst="rect">
+            <a:avLst/>
+          </a:prstGeom>
+          <a:noFill/>
+        </p:spPr>
+        <p:txBody>
+          <a:bodyPr wrap="square" rtlCol="0">
+            <a:spAutoFit/>
+          </a:bodyPr>
+          <a:lstStyle/>
+          <a:p>
+            <a:r>
+              <a:rPr lang="en-US" b="1" dirty="0"/>
+              <a:t>Channels </a:t>
+            </a:r>
+            <a:r>
+              <a:rPr lang="en-US" dirty="0"/>
+              <a:t>(conveyor belts)</a:t>
+            </a:r>
+          </a:p>
+        </p:txBody>
+      </p:sp>
+    </p:spTree>
+    <p:extLst>
+      <p:ext uri="{BB962C8B-B14F-4D97-AF65-F5344CB8AC3E}">
+        <p14:creationId xmlns:p14="http://schemas.microsoft.com/office/powerpoint/2010/main" val="4078347271"/>
+      </p:ext>
+    </p:extLst>
+  </p:cSld>
+  <p:clrMapOvr>
+    <a:masterClrMapping/>
+  </p:clrMapOvr>
+  <p:timing>
+    <p:tnLst>
+      <p:par>
+        <p:cTn id="1" dur="indefinite" restart="never" nodeType="tmRoot">
+          <p:childTnLst>
+            <p:seq concurrent="1" nextAc="seek">
+              <p:cTn id="2" dur="indefinite" nodeType="mainSeq">
+                <p:childTnLst>
+                  <p:par>
+                    <p:cTn id="3" fill="hold">
+                      <p:stCondLst>
+                        <p:cond delay="indefinite"/>
+                      </p:stCondLst>
+                      <p:childTnLst>
+                        <p:par>
+                          <p:cTn id="4" fill="hold">
+                            <p:stCondLst>
+                              <p:cond delay="0"/>
+                            </p:stCondLst>
+                            <p:childTnLst>
+                              <p:par>
+                                <p:cTn id="5" presetID="1" presetClass="entr" presetSubtype="0" fill="hold" grpId="0" nodeType="clickEffect">
+                                  <p:stCondLst>
+                                    <p:cond delay="0"/>
+                                  </p:stCondLst>
+                                  <p:childTnLst>
+                                    <p:set>
+                                      <p:cBhvr>
+                                        <p:cTn id="6" dur="1" fill="hold">
+                                          <p:stCondLst>
+                                            <p:cond delay="0"/>
+                                          </p:stCondLst>
+                                        </p:cTn>
+                                        <p:tgtEl>
+                                          <p:spTgt spid="2"/>
+                                        </p:tgtEl>
+                                        <p:attrNameLst>
+                                          <p:attrName>style.visibility</p:attrName>
+                                        </p:attrNameLst>
+                                      </p:cBhvr>
+                                      <p:to>
+                                        <p:strVal val="visible"/>
+                                      </p:to>
+                                    </p:set>
+                                  </p:childTnLst>
+                                </p:cTn>
+                              </p:par>
+                              <p:par>
+                                <p:cTn id="7" presetID="1" presetClass="entr" presetSubtype="0" fill="hold" grpId="0" nodeType="withEffect">
+                                  <p:stCondLst>
+                                    <p:cond delay="0"/>
+                                  </p:stCondLst>
+                                  <p:childTnLst>
+                                    <p:set>
+                                      <p:cBhvr>
+                                        <p:cTn id="8" dur="1" fill="hold">
+                                          <p:stCondLst>
+                                            <p:cond delay="0"/>
+                                          </p:stCondLst>
+                                        </p:cTn>
+                                        <p:tgtEl>
+                                          <p:spTgt spid="6"/>
+                                        </p:tgtEl>
+                                        <p:attrNameLst>
+                                          <p:attrName>style.visibility</p:attrName>
+                                        </p:attrNameLst>
+                                      </p:cBhvr>
+                                      <p:to>
+                                        <p:strVal val="visible"/>
+                                      </p:to>
+                                    </p:set>
+                                  </p:childTnLst>
+                                </p:cTn>
+                              </p:par>
+                              <p:par>
+                                <p:cTn id="9" presetID="1" presetClass="entr" presetSubtype="0" fill="hold" grpId="0" nodeType="withEffect">
+                                  <p:stCondLst>
+                                    <p:cond delay="0"/>
+                                  </p:stCondLst>
+                                  <p:childTnLst>
+                                    <p:set>
+                                      <p:cBhvr>
+                                        <p:cTn id="10" dur="1" fill="hold">
+                                          <p:stCondLst>
+                                            <p:cond delay="0"/>
+                                          </p:stCondLst>
+                                        </p:cTn>
+                                        <p:tgtEl>
+                                          <p:spTgt spid="3"/>
+                                        </p:tgtEl>
+                                        <p:attrNameLst>
+                                          <p:attrName>style.visibility</p:attrName>
+                                        </p:attrNameLst>
+                                      </p:cBhvr>
+                                      <p:to>
+                                        <p:strVal val="visible"/>
+                                      </p:to>
+                                    </p:set>
+                                  </p:childTnLst>
+                                </p:cTn>
+                              </p:par>
+                            </p:childTnLst>
+                          </p:cTn>
+                        </p:par>
+                      </p:childTnLst>
+                    </p:cTn>
+                  </p:par>
+                  <p:par>
+                    <p:cTn id="11" fill="hold">
+                      <p:stCondLst>
+                        <p:cond delay="indefinite"/>
+                      </p:stCondLst>
+                      <p:childTnLst>
+                        <p:par>
+                          <p:cTn id="12" fill="hold">
+                            <p:stCondLst>
+                              <p:cond delay="0"/>
+                            </p:stCondLst>
+                            <p:childTnLst>
+                              <p:par>
+                                <p:cTn id="13" presetID="1" presetClass="entr" presetSubtype="0" fill="hold" grpId="0" nodeType="clickEffect">
+                                  <p:stCondLst>
+                                    <p:cond delay="0"/>
+                                  </p:stCondLst>
+                                  <p:childTnLst>
+                                    <p:set>
+                                      <p:cBhvr>
+                                        <p:cTn id="14" dur="1" fill="hold">
+                                          <p:stCondLst>
+                                            <p:cond delay="0"/>
+                                          </p:stCondLst>
+                                        </p:cTn>
+                                        <p:tgtEl>
+                                          <p:spTgt spid="4"/>
+                                        </p:tgtEl>
+                                        <p:attrNameLst>
+                                          <p:attrName>style.visibility</p:attrName>
+                                        </p:attrNameLst>
+                                      </p:cBhvr>
+                                      <p:to>
+                                        <p:strVal val="visible"/>
+                                      </p:to>
+                                    </p:set>
+                                  </p:childTnLst>
+                                </p:cTn>
+                              </p:par>
+                              <p:par>
+                                <p:cTn id="15" presetID="1" presetClass="entr" presetSubtype="0" fill="hold" grpId="0" nodeType="withEffect">
+                                  <p:stCondLst>
+                                    <p:cond delay="0"/>
+                                  </p:stCondLst>
+                                  <p:childTnLst>
+                                    <p:set>
+                                      <p:cBhvr>
+                                        <p:cTn id="16" dur="1" fill="hold">
+                                          <p:stCondLst>
+                                            <p:cond delay="0"/>
+                                          </p:stCondLst>
+                                        </p:cTn>
+                                        <p:tgtEl>
+                                          <p:spTgt spid="7"/>
+                                        </p:tgtEl>
+                                        <p:attrNameLst>
+                                          <p:attrName>style.visibility</p:attrName>
+                                        </p:attrNameLst>
+                                      </p:cBhvr>
+                                      <p:to>
+                                        <p:strVal val="visible"/>
+                                      </p:to>
+                                    </p:set>
+                                  </p:childTnLst>
+                                </p:cTn>
+                              </p:par>
+                            </p:childTnLst>
+                          </p:cTn>
+                        </p:par>
+                      </p:childTnLst>
+                    </p:cTn>
+                  </p:par>
+                  <p:par>
+                    <p:cTn id="17" fill="hold">
+                      <p:stCondLst>
+                        <p:cond delay="indefinite"/>
+                      </p:stCondLst>
+                      <p:childTnLst>
+                        <p:par>
+                          <p:cTn id="18" fill="hold">
+                            <p:stCondLst>
+                              <p:cond delay="0"/>
+                            </p:stCondLst>
+                            <p:childTnLst>
+                              <p:par>
+                                <p:cTn id="19" presetID="1" presetClass="entr" presetSubtype="0" fill="hold" grpId="0" nodeType="clickEffect">
+                                  <p:stCondLst>
+                                    <p:cond delay="0"/>
+                                  </p:stCondLst>
+                                  <p:childTnLst>
+                                    <p:set>
+                                      <p:cBhvr>
+                                        <p:cTn id="20" dur="1" fill="hold">
+                                          <p:stCondLst>
+                                            <p:cond delay="0"/>
+                                          </p:stCondLst>
+                                        </p:cTn>
+                                        <p:tgtEl>
+                                          <p:spTgt spid="8"/>
+                                        </p:tgtEl>
+                                        <p:attrNameLst>
+                                          <p:attrName>style.visibility</p:attrName>
+                                        </p:attrNameLst>
+                                      </p:cBhvr>
+                                      <p:to>
+                                        <p:strVal val="visible"/>
+                                      </p:to>
+                                    </p:set>
+                                  </p:childTnLst>
+                                </p:cTn>
+                              </p:par>
+                              <p:par>
+                                <p:cTn id="21" presetID="1" presetClass="entr" presetSubtype="0" fill="hold" grpId="0" nodeType="withEffect">
+                                  <p:stCondLst>
+                                    <p:cond delay="0"/>
+                                  </p:stCondLst>
+                                  <p:childTnLst>
+                                    <p:set>
+                                      <p:cBhvr>
+                                        <p:cTn id="22" dur="1" fill="hold">
+                                          <p:stCondLst>
+                                            <p:cond delay="0"/>
+                                          </p:stCondLst>
+                                        </p:cTn>
+                                        <p:tgtEl>
+                                          <p:spTgt spid="9"/>
+                                        </p:tgtEl>
+                                        <p:attrNameLst>
+                                          <p:attrName>style.visibility</p:attrName>
+                                        </p:attrNameLst>
+                                      </p:cBhvr>
+                                      <p:to>
+                                        <p:strVal val="visible"/>
+                                      </p:to>
+                                    </p:set>
+                                  </p:childTnLst>
+                                </p:cTn>
+                              </p:par>
+                            </p:childTnLst>
+                          </p:cTn>
+                        </p:par>
+                      </p:childTnLst>
+                    </p:cTn>
+                  </p:par>
+                </p:childTnLst>
+              </p:cTn>
+              <p:prevCondLst>
+                <p:cond evt="onPrev" delay="0">
+                  <p:tgtEl>
+                    <p:sldTgt/>
+                  </p:tgtEl>
+                </p:cond>
+              </p:prevCondLst>
+              <p:nextCondLst>
+                <p:cond evt="onNext" delay="0">
+                  <p:tgtEl>
+                    <p:sldTgt/>
+                  </p:tgtEl>
+                </p:cond>
+              </p:nextCondLst>
+            </p:seq>
+          </p:childTnLst>
+        </p:cTn>
+      </p:par>
+    </p:tnLst>
+    <p:bldLst>
+      <p:bldP spid="2" grpId="0" animBg="1"/>
+      <p:bldP spid="3" grpId="0"/>
+      <p:bldP spid="4" grpId="0"/>
+      <p:bldP spid="6" grpId="0" animBg="1"/>
+      <p:bldP spid="7" grpId="0" animBg="1"/>
+      <p:bldP spid="8" grpId="0" animBg="1"/>
+      <p:bldP spid="9" grpId="0"/>
+    </p:bldLst>
+  </p:timing>
+</p:sld>
+</file>
+
 <file path=ppt/slides/slide2.xml><?xml version="1.0" encoding="utf-8"?>
+<p:sld xmlns:a="http://schemas.openxmlformats.org/drawingml/2006/main" xmlns:r="http://schemas.openxmlformats.org/officeDocument/2006/relationships" xmlns:p="http://schemas.openxmlformats.org/presentationml/2006/main">
+  <p:cSld>
+    <p:spTree>
+      <p:nvGrpSpPr>
+        <p:cNvPr id="1" name=""/>
+        <p:cNvGrpSpPr/>
+        <p:nvPr/>
+      </p:nvGrpSpPr>
+      <p:grpSpPr>
+        <a:xfrm>
+          <a:off x="0" y="0"/>
+          <a:ext cx="0" cy="0"/>
+          <a:chOff x="0" y="0"/>
+          <a:chExt cx="0" cy="0"/>
+        </a:xfrm>
+      </p:grpSpPr>
+      <p:sp>
+        <p:nvSpPr>
+          <p:cNvPr id="2" name="Title 1">
+            <a:extLst>
+              <a:ext uri="{FF2B5EF4-FFF2-40B4-BE49-F238E27FC236}">
+                <a16:creationId xmlns:a16="http://schemas.microsoft.com/office/drawing/2014/main" id="{C8439672-E7F5-1723-B190-A3D07B73B95A}"/>
+              </a:ext>
+            </a:extLst>
+          </p:cNvPr>
+          <p:cNvSpPr>
+            <a:spLocks noGrp="1"/>
+          </p:cNvSpPr>
+          <p:nvPr>
+            <p:ph type="title"/>
+          </p:nvPr>
+        </p:nvSpPr>
+        <p:spPr/>
+        <p:txBody>
+          <a:bodyPr/>
+          <a:lstStyle/>
+          <a:p>
+            <a:r>
+              <a:rPr lang="en-US" dirty="0"/>
+              <a:t>Plan</a:t>
+            </a:r>
+          </a:p>
+        </p:txBody>
+      </p:sp>
+      <p:sp>
+        <p:nvSpPr>
+          <p:cNvPr id="3" name="Content Placeholder 2">
+            <a:extLst>
+              <a:ext uri="{FF2B5EF4-FFF2-40B4-BE49-F238E27FC236}">
+                <a16:creationId xmlns:a16="http://schemas.microsoft.com/office/drawing/2014/main" id="{588B3222-58DD-375B-1D58-C6FD304DA78A}"/>
+              </a:ext>
+            </a:extLst>
+          </p:cNvPr>
+          <p:cNvSpPr>
+            <a:spLocks noGrp="1"/>
+          </p:cNvSpPr>
+          <p:nvPr>
+            <p:ph idx="1"/>
+          </p:nvPr>
+        </p:nvSpPr>
+        <p:spPr/>
+        <p:txBody>
+          <a:bodyPr/>
+          <a:lstStyle/>
+          <a:p>
+            <a:endParaRPr lang="en-US"/>
+          </a:p>
+        </p:txBody>
+      </p:sp>
+    </p:spTree>
+    <p:extLst>
+      <p:ext uri="{BB962C8B-B14F-4D97-AF65-F5344CB8AC3E}">
+        <p14:creationId xmlns:p14="http://schemas.microsoft.com/office/powerpoint/2010/main" val="1157480680"/>
+      </p:ext>
+    </p:extLst>
+  </p:cSld>
+  <p:clrMapOvr>
+    <a:masterClrMapping/>
+  </p:clrMapOvr>
+</p:sld>
+</file>
+
+<file path=ppt/slides/slide3.xml><?xml version="1.0" encoding="utf-8"?>
+<p:sld xmlns:a="http://schemas.openxmlformats.org/drawingml/2006/main" xmlns:r="http://schemas.openxmlformats.org/officeDocument/2006/relationships" xmlns:p="http://schemas.openxmlformats.org/presentationml/2006/main">
+  <p:cSld>
+    <p:spTree>
+      <p:nvGrpSpPr>
+        <p:cNvPr id="1" name="">
+          <a:extLst>
+            <a:ext uri="{FF2B5EF4-FFF2-40B4-BE49-F238E27FC236}">
+              <a16:creationId xmlns:a16="http://schemas.microsoft.com/office/drawing/2014/main" id="{7FD6CF97-2D22-8E1E-3F34-B27E93D76833}"/>
+            </a:ext>
+          </a:extLst>
+        </p:cNvPr>
+        <p:cNvGrpSpPr/>
+        <p:nvPr/>
+      </p:nvGrpSpPr>
+      <p:grpSpPr>
+        <a:xfrm>
+          <a:off x="0" y="0"/>
+          <a:ext cx="0" cy="0"/>
+          <a:chOff x="0" y="0"/>
+          <a:chExt cx="0" cy="0"/>
+        </a:xfrm>
+      </p:grpSpPr>
+      <p:sp>
+        <p:nvSpPr>
+          <p:cNvPr id="2" name="Title 1">
+            <a:extLst>
+              <a:ext uri="{FF2B5EF4-FFF2-40B4-BE49-F238E27FC236}">
+                <a16:creationId xmlns:a16="http://schemas.microsoft.com/office/drawing/2014/main" id="{36C6EF45-3CB5-FC67-9990-ADE3E6E83413}"/>
+              </a:ext>
+            </a:extLst>
+          </p:cNvPr>
+          <p:cNvSpPr>
+            <a:spLocks noGrp="1"/>
+          </p:cNvSpPr>
+          <p:nvPr>
+            <p:ph type="title"/>
+          </p:nvPr>
+        </p:nvSpPr>
+        <p:spPr/>
+        <p:txBody>
+          <a:bodyPr/>
+          <a:lstStyle/>
+          <a:p>
+            <a:r>
+              <a:rPr lang="en-US" dirty="0"/>
+              <a:t>Practical considerations</a:t>
+            </a:r>
+          </a:p>
+        </p:txBody>
+      </p:sp>
+      <p:sp>
+        <p:nvSpPr>
+          <p:cNvPr id="3" name="Content Placeholder 2">
+            <a:extLst>
+              <a:ext uri="{FF2B5EF4-FFF2-40B4-BE49-F238E27FC236}">
+                <a16:creationId xmlns:a16="http://schemas.microsoft.com/office/drawing/2014/main" id="{8DD2894A-4E57-70B8-6548-52FDF58AC0DA}"/>
+              </a:ext>
+            </a:extLst>
+          </p:cNvPr>
+          <p:cNvSpPr>
+            <a:spLocks noGrp="1"/>
+          </p:cNvSpPr>
+          <p:nvPr>
+            <p:ph idx="1"/>
+          </p:nvPr>
+        </p:nvSpPr>
+        <p:spPr/>
+        <p:txBody>
+          <a:bodyPr/>
+          <a:lstStyle/>
+          <a:p>
+            <a:endParaRPr lang="en-US"/>
+          </a:p>
+        </p:txBody>
+      </p:sp>
+    </p:spTree>
+    <p:extLst>
+      <p:ext uri="{BB962C8B-B14F-4D97-AF65-F5344CB8AC3E}">
+        <p14:creationId xmlns:p14="http://schemas.microsoft.com/office/powerpoint/2010/main" val="3196202313"/>
+      </p:ext>
+    </p:extLst>
+  </p:cSld>
+  <p:clrMapOvr>
+    <a:masterClrMapping/>
+  </p:clrMapOvr>
+</p:sld>
+</file>
+
+<file path=ppt/slides/slide4.xml><?xml version="1.0" encoding="utf-8"?>
 <p:sld xmlns:a="http://schemas.openxmlformats.org/drawingml/2006/main" xmlns:r="http://schemas.openxmlformats.org/officeDocument/2006/relationships" xmlns:p="http://schemas.openxmlformats.org/presentationml/2006/main">
   <p:cSld>
     <p:spTree>
@@ -4615,7 +8205,7 @@
 </p:sld>
 </file>
 
-<file path=ppt/slides/slide3.xml><?xml version="1.0" encoding="utf-8"?>
+<file path=ppt/slides/slide5.xml><?xml version="1.0" encoding="utf-8"?>
 <p:sld xmlns:a="http://schemas.openxmlformats.org/drawingml/2006/main" xmlns:r="http://schemas.openxmlformats.org/officeDocument/2006/relationships" xmlns:p="http://schemas.openxmlformats.org/presentationml/2006/main">
   <p:cSld>
     <p:spTree>
@@ -4739,7 +8329,7 @@
 </p:sld>
 </file>
 
-<file path=ppt/slides/slide4.xml><?xml version="1.0" encoding="utf-8"?>
+<file path=ppt/slides/slide6.xml><?xml version="1.0" encoding="utf-8"?>
 <p:sld xmlns:a="http://schemas.openxmlformats.org/drawingml/2006/main" xmlns:r="http://schemas.openxmlformats.org/officeDocument/2006/relationships" xmlns:p="http://schemas.openxmlformats.org/presentationml/2006/main">
   <p:cSld>
     <p:spTree>
@@ -4835,7 +8425,7 @@
 </p:sld>
 </file>
 
-<file path=ppt/slides/slide5.xml><?xml version="1.0" encoding="utf-8"?>
+<file path=ppt/slides/slide7.xml><?xml version="1.0" encoding="utf-8"?>
 <p:sld xmlns:a="http://schemas.openxmlformats.org/drawingml/2006/main" xmlns:r="http://schemas.openxmlformats.org/officeDocument/2006/relationships" xmlns:p="http://schemas.openxmlformats.org/presentationml/2006/main">
   <p:cSld>
     <p:spTree>
@@ -4904,7 +8494,7 @@
 </p:sld>
 </file>
 
-<file path=ppt/slides/slide6.xml><?xml version="1.0" encoding="utf-8"?>
+<file path=ppt/slides/slide8.xml><?xml version="1.0" encoding="utf-8"?>
 <p:sld xmlns:a="http://schemas.openxmlformats.org/drawingml/2006/main" xmlns:r="http://schemas.openxmlformats.org/officeDocument/2006/relationships" xmlns:p="http://schemas.openxmlformats.org/presentationml/2006/main">
   <p:cSld>
     <p:spTree>
@@ -6041,7 +9631,7 @@
 </p:sld>
 </file>
 
-<file path=ppt/slides/slide7.xml><?xml version="1.0" encoding="utf-8"?>
+<file path=ppt/slides/slide9.xml><?xml version="1.0" encoding="utf-8"?>
 <p:sld xmlns:a="http://schemas.openxmlformats.org/drawingml/2006/main" xmlns:r="http://schemas.openxmlformats.org/officeDocument/2006/relationships" xmlns:p="http://schemas.openxmlformats.org/presentationml/2006/main">
   <p:cSld>
     <p:spTree>
@@ -6255,908 +9845,6 @@
     <p:extLst>
       <p:ext uri="{BB962C8B-B14F-4D97-AF65-F5344CB8AC3E}">
         <p14:creationId xmlns:p14="http://schemas.microsoft.com/office/powerpoint/2010/main" val="3903298263"/>
-      </p:ext>
-    </p:extLst>
-  </p:cSld>
-  <p:clrMapOvr>
-    <a:masterClrMapping/>
-  </p:clrMapOvr>
-</p:sld>
-</file>
-
-<file path=ppt/slides/slide8.xml><?xml version="1.0" encoding="utf-8"?>
-<p:sld xmlns:a="http://schemas.openxmlformats.org/drawingml/2006/main" xmlns:r="http://schemas.openxmlformats.org/officeDocument/2006/relationships" xmlns:p="http://schemas.openxmlformats.org/presentationml/2006/main">
-  <p:cSld>
-    <p:spTree>
-      <p:nvGrpSpPr>
-        <p:cNvPr id="1" name="">
-          <a:extLst>
-            <a:ext uri="{FF2B5EF4-FFF2-40B4-BE49-F238E27FC236}">
-              <a16:creationId xmlns:a16="http://schemas.microsoft.com/office/drawing/2014/main" id="{E3AD97CB-B8A2-C139-67D1-19D621A2F549}"/>
-            </a:ext>
-          </a:extLst>
-        </p:cNvPr>
-        <p:cNvGrpSpPr/>
-        <p:nvPr/>
-      </p:nvGrpSpPr>
-      <p:grpSpPr>
-        <a:xfrm>
-          <a:off x="0" y="0"/>
-          <a:ext cx="0" cy="0"/>
-          <a:chOff x="0" y="0"/>
-          <a:chExt cx="0" cy="0"/>
-        </a:xfrm>
-      </p:grpSpPr>
-      <p:sp>
-        <p:nvSpPr>
-          <p:cNvPr id="8" name="Title 1">
-            <a:extLst>
-              <a:ext uri="{FF2B5EF4-FFF2-40B4-BE49-F238E27FC236}">
-                <a16:creationId xmlns:a16="http://schemas.microsoft.com/office/drawing/2014/main" id="{7336D5C8-7018-6AAC-AA60-DC2E2C108243}"/>
-              </a:ext>
-            </a:extLst>
-          </p:cNvPr>
-          <p:cNvSpPr>
-            <a:spLocks noGrp="1"/>
-          </p:cNvSpPr>
-          <p:nvPr>
-            <p:ph type="title"/>
-          </p:nvPr>
-        </p:nvSpPr>
-        <p:spPr>
-          <a:xfrm>
-            <a:off x="838200" y="365125"/>
-            <a:ext cx="10515600" cy="1325563"/>
-          </a:xfrm>
-        </p:spPr>
-        <p:txBody>
-          <a:bodyPr/>
-          <a:lstStyle/>
-          <a:p>
-            <a:r>
-              <a:rPr lang="en-US" dirty="0"/>
-              <a:t>Processes</a:t>
-            </a:r>
-          </a:p>
-        </p:txBody>
-      </p:sp>
-      <p:sp>
-        <p:nvSpPr>
-          <p:cNvPr id="10" name="Rectangle 9">
-            <a:extLst>
-              <a:ext uri="{FF2B5EF4-FFF2-40B4-BE49-F238E27FC236}">
-                <a16:creationId xmlns:a16="http://schemas.microsoft.com/office/drawing/2014/main" id="{74EBEBF9-FD16-4830-389A-C0EE85FF218B}"/>
-              </a:ext>
-            </a:extLst>
-          </p:cNvPr>
-          <p:cNvSpPr/>
-          <p:nvPr/>
-        </p:nvSpPr>
-        <p:spPr>
-          <a:xfrm>
-            <a:off x="662871" y="2841171"/>
-            <a:ext cx="1413164" cy="587829"/>
-          </a:xfrm>
-          <a:prstGeom prst="rect">
-            <a:avLst/>
-          </a:prstGeom>
-        </p:spPr>
-        <p:style>
-          <a:lnRef idx="2">
-            <a:schemeClr val="dk1"/>
-          </a:lnRef>
-          <a:fillRef idx="1">
-            <a:schemeClr val="lt1"/>
-          </a:fillRef>
-          <a:effectRef idx="0">
-            <a:schemeClr val="dk1"/>
-          </a:effectRef>
-          <a:fontRef idx="minor">
-            <a:schemeClr val="dk1"/>
-          </a:fontRef>
-        </p:style>
-        <p:txBody>
-          <a:bodyPr rtlCol="0" anchor="ctr"/>
-          <a:lstStyle/>
-          <a:p>
-            <a:pPr algn="ctr"/>
-            <a:r>
-              <a:rPr lang="en-US" dirty="0"/>
-              <a:t>Raw reads</a:t>
-            </a:r>
-          </a:p>
-        </p:txBody>
-      </p:sp>
-      <p:sp>
-        <p:nvSpPr>
-          <p:cNvPr id="11" name="Rectangle 10">
-            <a:extLst>
-              <a:ext uri="{FF2B5EF4-FFF2-40B4-BE49-F238E27FC236}">
-                <a16:creationId xmlns:a16="http://schemas.microsoft.com/office/drawing/2014/main" id="{EA32FA45-5CE0-546E-8507-1E41FF311C28}"/>
-              </a:ext>
-            </a:extLst>
-          </p:cNvPr>
-          <p:cNvSpPr/>
-          <p:nvPr/>
-        </p:nvSpPr>
-        <p:spPr>
-          <a:xfrm>
-            <a:off x="3410639" y="2323437"/>
-            <a:ext cx="1413164" cy="587829"/>
-          </a:xfrm>
-          <a:prstGeom prst="rect">
-            <a:avLst/>
-          </a:prstGeom>
-          <a:ln>
-            <a:noFill/>
-          </a:ln>
-        </p:spPr>
-        <p:style>
-          <a:lnRef idx="2">
-            <a:schemeClr val="accent2">
-              <a:shade val="15000"/>
-            </a:schemeClr>
-          </a:lnRef>
-          <a:fillRef idx="1">
-            <a:schemeClr val="accent2"/>
-          </a:fillRef>
-          <a:effectRef idx="0">
-            <a:schemeClr val="accent2"/>
-          </a:effectRef>
-          <a:fontRef idx="minor">
-            <a:schemeClr val="lt1"/>
-          </a:fontRef>
-        </p:style>
-        <p:txBody>
-          <a:bodyPr rtlCol="0" anchor="ctr"/>
-          <a:lstStyle/>
-          <a:p>
-            <a:pPr algn="ctr"/>
-            <a:r>
-              <a:rPr lang="en-US" dirty="0" err="1"/>
-              <a:t>FastQC</a:t>
-            </a:r>
-            <a:endParaRPr lang="en-US" dirty="0"/>
-          </a:p>
-        </p:txBody>
-      </p:sp>
-      <p:sp>
-        <p:nvSpPr>
-          <p:cNvPr id="12" name="Rectangle 11">
-            <a:extLst>
-              <a:ext uri="{FF2B5EF4-FFF2-40B4-BE49-F238E27FC236}">
-                <a16:creationId xmlns:a16="http://schemas.microsoft.com/office/drawing/2014/main" id="{B83C6B10-0A5B-D19F-2051-E7A46BA24C95}"/>
-              </a:ext>
-            </a:extLst>
-          </p:cNvPr>
-          <p:cNvSpPr/>
-          <p:nvPr/>
-        </p:nvSpPr>
-        <p:spPr>
-          <a:xfrm>
-            <a:off x="3410639" y="3411186"/>
-            <a:ext cx="1506186" cy="587829"/>
-          </a:xfrm>
-          <a:prstGeom prst="rect">
-            <a:avLst/>
-          </a:prstGeom>
-          <a:ln>
-            <a:noFill/>
-          </a:ln>
-        </p:spPr>
-        <p:style>
-          <a:lnRef idx="2">
-            <a:schemeClr val="accent2">
-              <a:shade val="15000"/>
-            </a:schemeClr>
-          </a:lnRef>
-          <a:fillRef idx="1">
-            <a:schemeClr val="accent2"/>
-          </a:fillRef>
-          <a:effectRef idx="0">
-            <a:schemeClr val="accent2"/>
-          </a:effectRef>
-          <a:fontRef idx="minor">
-            <a:schemeClr val="lt1"/>
-          </a:fontRef>
-        </p:style>
-        <p:txBody>
-          <a:bodyPr rtlCol="0" anchor="ctr"/>
-          <a:lstStyle/>
-          <a:p>
-            <a:pPr algn="ctr"/>
-            <a:r>
-              <a:rPr lang="en-US" dirty="0" err="1"/>
-              <a:t>Trimmomatic</a:t>
-            </a:r>
-            <a:endParaRPr lang="en-US" dirty="0"/>
-          </a:p>
-        </p:txBody>
-      </p:sp>
-      <p:sp>
-        <p:nvSpPr>
-          <p:cNvPr id="13" name="Rectangle 12">
-            <a:extLst>
-              <a:ext uri="{FF2B5EF4-FFF2-40B4-BE49-F238E27FC236}">
-                <a16:creationId xmlns:a16="http://schemas.microsoft.com/office/drawing/2014/main" id="{9D4239F9-1627-FE39-63B3-2B78B5B17BA1}"/>
-              </a:ext>
-            </a:extLst>
-          </p:cNvPr>
-          <p:cNvSpPr/>
-          <p:nvPr/>
-        </p:nvSpPr>
-        <p:spPr>
-          <a:xfrm>
-            <a:off x="8074780" y="3008199"/>
-            <a:ext cx="1413164" cy="587829"/>
-          </a:xfrm>
-          <a:prstGeom prst="rect">
-            <a:avLst/>
-          </a:prstGeom>
-          <a:ln>
-            <a:noFill/>
-          </a:ln>
-        </p:spPr>
-        <p:style>
-          <a:lnRef idx="2">
-            <a:schemeClr val="accent2">
-              <a:shade val="15000"/>
-            </a:schemeClr>
-          </a:lnRef>
-          <a:fillRef idx="1">
-            <a:schemeClr val="accent2"/>
-          </a:fillRef>
-          <a:effectRef idx="0">
-            <a:schemeClr val="accent2"/>
-          </a:effectRef>
-          <a:fontRef idx="minor">
-            <a:schemeClr val="lt1"/>
-          </a:fontRef>
-        </p:style>
-        <p:txBody>
-          <a:bodyPr rtlCol="0" anchor="ctr"/>
-          <a:lstStyle/>
-          <a:p>
-            <a:pPr algn="ctr"/>
-            <a:r>
-              <a:rPr lang="en-US" dirty="0" err="1"/>
-              <a:t>FastQC</a:t>
-            </a:r>
-            <a:endParaRPr lang="en-US" dirty="0"/>
-          </a:p>
-        </p:txBody>
-      </p:sp>
-      <p:sp>
-        <p:nvSpPr>
-          <p:cNvPr id="14" name="Rectangle 13">
-            <a:extLst>
-              <a:ext uri="{FF2B5EF4-FFF2-40B4-BE49-F238E27FC236}">
-                <a16:creationId xmlns:a16="http://schemas.microsoft.com/office/drawing/2014/main" id="{601C7A4E-08D3-7E28-8122-BCE11DC926B3}"/>
-              </a:ext>
-            </a:extLst>
-          </p:cNvPr>
-          <p:cNvSpPr/>
-          <p:nvPr/>
-        </p:nvSpPr>
-        <p:spPr>
-          <a:xfrm>
-            <a:off x="5703074" y="2323437"/>
-            <a:ext cx="1413164" cy="587829"/>
-          </a:xfrm>
-          <a:prstGeom prst="rect">
-            <a:avLst/>
-          </a:prstGeom>
-        </p:spPr>
-        <p:style>
-          <a:lnRef idx="2">
-            <a:schemeClr val="dk1"/>
-          </a:lnRef>
-          <a:fillRef idx="1">
-            <a:schemeClr val="lt1"/>
-          </a:fillRef>
-          <a:effectRef idx="0">
-            <a:schemeClr val="dk1"/>
-          </a:effectRef>
-          <a:fontRef idx="minor">
-            <a:schemeClr val="dk1"/>
-          </a:fontRef>
-        </p:style>
-        <p:txBody>
-          <a:bodyPr rtlCol="0" anchor="ctr"/>
-          <a:lstStyle/>
-          <a:p>
-            <a:pPr algn="ctr"/>
-            <a:r>
-              <a:rPr lang="en-US" dirty="0"/>
-              <a:t>Quality report</a:t>
-            </a:r>
-          </a:p>
-        </p:txBody>
-      </p:sp>
-      <p:sp>
-        <p:nvSpPr>
-          <p:cNvPr id="15" name="Rectangle 14">
-            <a:extLst>
-              <a:ext uri="{FF2B5EF4-FFF2-40B4-BE49-F238E27FC236}">
-                <a16:creationId xmlns:a16="http://schemas.microsoft.com/office/drawing/2014/main" id="{913B5712-BA3C-192F-AD9B-BF8DB8DBC49A}"/>
-              </a:ext>
-            </a:extLst>
-          </p:cNvPr>
-          <p:cNvSpPr/>
-          <p:nvPr/>
-        </p:nvSpPr>
-        <p:spPr>
-          <a:xfrm>
-            <a:off x="10208988" y="2989849"/>
-            <a:ext cx="1413164" cy="587829"/>
-          </a:xfrm>
-          <a:prstGeom prst="rect">
-            <a:avLst/>
-          </a:prstGeom>
-        </p:spPr>
-        <p:style>
-          <a:lnRef idx="2">
-            <a:schemeClr val="dk1"/>
-          </a:lnRef>
-          <a:fillRef idx="1">
-            <a:schemeClr val="lt1"/>
-          </a:fillRef>
-          <a:effectRef idx="0">
-            <a:schemeClr val="dk1"/>
-          </a:effectRef>
-          <a:fontRef idx="minor">
-            <a:schemeClr val="dk1"/>
-          </a:fontRef>
-        </p:style>
-        <p:txBody>
-          <a:bodyPr rtlCol="0" anchor="ctr"/>
-          <a:lstStyle/>
-          <a:p>
-            <a:pPr algn="ctr"/>
-            <a:r>
-              <a:rPr lang="en-US" dirty="0"/>
-              <a:t>Quality report</a:t>
-            </a:r>
-          </a:p>
-        </p:txBody>
-      </p:sp>
-      <p:sp>
-        <p:nvSpPr>
-          <p:cNvPr id="16" name="Rectangle 15">
-            <a:extLst>
-              <a:ext uri="{FF2B5EF4-FFF2-40B4-BE49-F238E27FC236}">
-                <a16:creationId xmlns:a16="http://schemas.microsoft.com/office/drawing/2014/main" id="{3D213401-9B8D-ADDA-CBFA-8FE8F9047E78}"/>
-              </a:ext>
-            </a:extLst>
-          </p:cNvPr>
-          <p:cNvSpPr/>
-          <p:nvPr/>
-        </p:nvSpPr>
-        <p:spPr>
-          <a:xfrm>
-            <a:off x="5730667" y="3403531"/>
-            <a:ext cx="1413164" cy="587829"/>
-          </a:xfrm>
-          <a:prstGeom prst="rect">
-            <a:avLst/>
-          </a:prstGeom>
-        </p:spPr>
-        <p:style>
-          <a:lnRef idx="2">
-            <a:schemeClr val="dk1"/>
-          </a:lnRef>
-          <a:fillRef idx="1">
-            <a:schemeClr val="lt1"/>
-          </a:fillRef>
-          <a:effectRef idx="0">
-            <a:schemeClr val="dk1"/>
-          </a:effectRef>
-          <a:fontRef idx="minor">
-            <a:schemeClr val="dk1"/>
-          </a:fontRef>
-        </p:style>
-        <p:txBody>
-          <a:bodyPr rtlCol="0" anchor="ctr"/>
-          <a:lstStyle/>
-          <a:p>
-            <a:pPr algn="ctr"/>
-            <a:r>
-              <a:rPr lang="en-US" dirty="0"/>
-              <a:t>Clean reads</a:t>
-            </a:r>
-          </a:p>
-        </p:txBody>
-      </p:sp>
-      <p:cxnSp>
-        <p:nvCxnSpPr>
-          <p:cNvPr id="18" name="Straight Arrow Connector 17">
-            <a:extLst>
-              <a:ext uri="{FF2B5EF4-FFF2-40B4-BE49-F238E27FC236}">
-                <a16:creationId xmlns:a16="http://schemas.microsoft.com/office/drawing/2014/main" id="{951783CE-1317-F7ED-B505-1B8527F88840}"/>
-              </a:ext>
-            </a:extLst>
-          </p:cNvPr>
-          <p:cNvCxnSpPr>
-            <a:cxnSpLocks/>
-          </p:cNvCxnSpPr>
-          <p:nvPr/>
-        </p:nvCxnSpPr>
-        <p:spPr>
-          <a:xfrm flipV="1">
-            <a:off x="2174566" y="2642260"/>
-            <a:ext cx="964708" cy="442617"/>
-          </a:xfrm>
-          <a:prstGeom prst="straightConnector1">
-            <a:avLst/>
-          </a:prstGeom>
-          <a:ln w="28575">
-            <a:solidFill>
-              <a:schemeClr val="bg1">
-                <a:lumMod val="50000"/>
-              </a:schemeClr>
-            </a:solidFill>
-            <a:tailEnd type="triangle"/>
-          </a:ln>
-        </p:spPr>
-        <p:style>
-          <a:lnRef idx="1">
-            <a:schemeClr val="accent1"/>
-          </a:lnRef>
-          <a:fillRef idx="0">
-            <a:schemeClr val="accent1"/>
-          </a:fillRef>
-          <a:effectRef idx="0">
-            <a:schemeClr val="accent1"/>
-          </a:effectRef>
-          <a:fontRef idx="minor">
-            <a:schemeClr val="tx1"/>
-          </a:fontRef>
-        </p:style>
-      </p:cxnSp>
-      <p:cxnSp>
-        <p:nvCxnSpPr>
-          <p:cNvPr id="21" name="Straight Arrow Connector 20">
-            <a:extLst>
-              <a:ext uri="{FF2B5EF4-FFF2-40B4-BE49-F238E27FC236}">
-                <a16:creationId xmlns:a16="http://schemas.microsoft.com/office/drawing/2014/main" id="{47695FAF-8D51-0A43-5988-FE4DD948F635}"/>
-              </a:ext>
-            </a:extLst>
-          </p:cNvPr>
-          <p:cNvCxnSpPr>
-            <a:cxnSpLocks/>
-          </p:cNvCxnSpPr>
-          <p:nvPr/>
-        </p:nvCxnSpPr>
-        <p:spPr>
-          <a:xfrm>
-            <a:off x="2174566" y="3160087"/>
-            <a:ext cx="918956" cy="479700"/>
-          </a:xfrm>
-          <a:prstGeom prst="straightConnector1">
-            <a:avLst/>
-          </a:prstGeom>
-          <a:ln w="28575">
-            <a:solidFill>
-              <a:schemeClr val="bg1">
-                <a:lumMod val="50000"/>
-              </a:schemeClr>
-            </a:solidFill>
-            <a:tailEnd type="triangle"/>
-          </a:ln>
-        </p:spPr>
-        <p:style>
-          <a:lnRef idx="1">
-            <a:schemeClr val="accent1"/>
-          </a:lnRef>
-          <a:fillRef idx="0">
-            <a:schemeClr val="accent1"/>
-          </a:fillRef>
-          <a:effectRef idx="0">
-            <a:schemeClr val="accent1"/>
-          </a:effectRef>
-          <a:fontRef idx="minor">
-            <a:schemeClr val="tx1"/>
-          </a:fontRef>
-        </p:style>
-      </p:cxnSp>
-      <p:sp>
-        <p:nvSpPr>
-          <p:cNvPr id="22" name="Rectangle 21">
-            <a:extLst>
-              <a:ext uri="{FF2B5EF4-FFF2-40B4-BE49-F238E27FC236}">
-                <a16:creationId xmlns:a16="http://schemas.microsoft.com/office/drawing/2014/main" id="{5F318C63-FBF8-1C16-0D1E-69F765233998}"/>
-              </a:ext>
-            </a:extLst>
-          </p:cNvPr>
-          <p:cNvSpPr/>
-          <p:nvPr/>
-        </p:nvSpPr>
-        <p:spPr>
-          <a:xfrm>
-            <a:off x="8074780" y="3850272"/>
-            <a:ext cx="1413164" cy="802617"/>
-          </a:xfrm>
-          <a:prstGeom prst="rect">
-            <a:avLst/>
-          </a:prstGeom>
-          <a:solidFill>
-            <a:schemeClr val="accent2">
-              <a:lumMod val="60000"/>
-              <a:lumOff val="40000"/>
-            </a:schemeClr>
-          </a:solidFill>
-          <a:ln>
-            <a:noFill/>
-          </a:ln>
-        </p:spPr>
-        <p:style>
-          <a:lnRef idx="2">
-            <a:schemeClr val="accent2">
-              <a:shade val="15000"/>
-            </a:schemeClr>
-          </a:lnRef>
-          <a:fillRef idx="1">
-            <a:schemeClr val="accent2"/>
-          </a:fillRef>
-          <a:effectRef idx="0">
-            <a:schemeClr val="accent2"/>
-          </a:effectRef>
-          <a:fontRef idx="minor">
-            <a:schemeClr val="lt1"/>
-          </a:fontRef>
-        </p:style>
-        <p:txBody>
-          <a:bodyPr rtlCol="0" anchor="ctr"/>
-          <a:lstStyle/>
-          <a:p>
-            <a:pPr algn="ctr"/>
-            <a:r>
-              <a:rPr lang="en-US" dirty="0"/>
-              <a:t>Assembly with MEGAHIT</a:t>
-            </a:r>
-          </a:p>
-        </p:txBody>
-      </p:sp>
-      <p:sp>
-        <p:nvSpPr>
-          <p:cNvPr id="23" name="Rectangle 22">
-            <a:extLst>
-              <a:ext uri="{FF2B5EF4-FFF2-40B4-BE49-F238E27FC236}">
-                <a16:creationId xmlns:a16="http://schemas.microsoft.com/office/drawing/2014/main" id="{3F1F81AC-7470-E110-D9DC-5BCBCE4B54D6}"/>
-              </a:ext>
-            </a:extLst>
-          </p:cNvPr>
-          <p:cNvSpPr/>
-          <p:nvPr/>
-        </p:nvSpPr>
-        <p:spPr>
-          <a:xfrm>
-            <a:off x="8074780" y="4913539"/>
-            <a:ext cx="1413164" cy="587829"/>
-          </a:xfrm>
-          <a:prstGeom prst="rect">
-            <a:avLst/>
-          </a:prstGeom>
-          <a:solidFill>
-            <a:schemeClr val="accent2">
-              <a:lumMod val="60000"/>
-              <a:lumOff val="40000"/>
-            </a:schemeClr>
-          </a:solidFill>
-          <a:ln>
-            <a:noFill/>
-          </a:ln>
-        </p:spPr>
-        <p:style>
-          <a:lnRef idx="2">
-            <a:schemeClr val="accent2">
-              <a:shade val="15000"/>
-            </a:schemeClr>
-          </a:lnRef>
-          <a:fillRef idx="1">
-            <a:schemeClr val="accent2"/>
-          </a:fillRef>
-          <a:effectRef idx="0">
-            <a:schemeClr val="accent2"/>
-          </a:effectRef>
-          <a:fontRef idx="minor">
-            <a:schemeClr val="lt1"/>
-          </a:fontRef>
-        </p:style>
-        <p:txBody>
-          <a:bodyPr rtlCol="0" anchor="ctr"/>
-          <a:lstStyle/>
-          <a:p>
-            <a:pPr algn="ctr"/>
-            <a:r>
-              <a:rPr lang="en-US" dirty="0"/>
-              <a:t>Kraken2 annotation</a:t>
-            </a:r>
-          </a:p>
-        </p:txBody>
-      </p:sp>
-      <p:cxnSp>
-        <p:nvCxnSpPr>
-          <p:cNvPr id="5" name="Straight Arrow Connector 4">
-            <a:extLst>
-              <a:ext uri="{FF2B5EF4-FFF2-40B4-BE49-F238E27FC236}">
-                <a16:creationId xmlns:a16="http://schemas.microsoft.com/office/drawing/2014/main" id="{A97F1F21-D721-A862-FE46-0460393EEC26}"/>
-              </a:ext>
-            </a:extLst>
-          </p:cNvPr>
-          <p:cNvCxnSpPr>
-            <a:cxnSpLocks/>
-          </p:cNvCxnSpPr>
-          <p:nvPr/>
-        </p:nvCxnSpPr>
-        <p:spPr>
-          <a:xfrm>
-            <a:off x="5010789" y="2617351"/>
-            <a:ext cx="505299" cy="0"/>
-          </a:xfrm>
-          <a:prstGeom prst="straightConnector1">
-            <a:avLst/>
-          </a:prstGeom>
-          <a:ln w="28575">
-            <a:solidFill>
-              <a:schemeClr val="bg1">
-                <a:lumMod val="50000"/>
-              </a:schemeClr>
-            </a:solidFill>
-            <a:tailEnd type="triangle"/>
-          </a:ln>
-        </p:spPr>
-        <p:style>
-          <a:lnRef idx="1">
-            <a:schemeClr val="accent1"/>
-          </a:lnRef>
-          <a:fillRef idx="0">
-            <a:schemeClr val="accent1"/>
-          </a:fillRef>
-          <a:effectRef idx="0">
-            <a:schemeClr val="accent1"/>
-          </a:effectRef>
-          <a:fontRef idx="minor">
-            <a:schemeClr val="tx1"/>
-          </a:fontRef>
-        </p:style>
-      </p:cxnSp>
-      <p:cxnSp>
-        <p:nvCxnSpPr>
-          <p:cNvPr id="7" name="Straight Arrow Connector 6">
-            <a:extLst>
-              <a:ext uri="{FF2B5EF4-FFF2-40B4-BE49-F238E27FC236}">
-                <a16:creationId xmlns:a16="http://schemas.microsoft.com/office/drawing/2014/main" id="{494EE73E-41EF-32E5-71EA-B3707C3BABFF}"/>
-              </a:ext>
-            </a:extLst>
-          </p:cNvPr>
-          <p:cNvCxnSpPr>
-            <a:cxnSpLocks/>
-          </p:cNvCxnSpPr>
-          <p:nvPr/>
-        </p:nvCxnSpPr>
-        <p:spPr>
-          <a:xfrm>
-            <a:off x="5070856" y="3639787"/>
-            <a:ext cx="505299" cy="0"/>
-          </a:xfrm>
-          <a:prstGeom prst="straightConnector1">
-            <a:avLst/>
-          </a:prstGeom>
-          <a:ln w="28575">
-            <a:solidFill>
-              <a:schemeClr val="bg1">
-                <a:lumMod val="50000"/>
-              </a:schemeClr>
-            </a:solidFill>
-            <a:tailEnd type="triangle"/>
-          </a:ln>
-        </p:spPr>
-        <p:style>
-          <a:lnRef idx="1">
-            <a:schemeClr val="accent1"/>
-          </a:lnRef>
-          <a:fillRef idx="0">
-            <a:schemeClr val="accent1"/>
-          </a:fillRef>
-          <a:effectRef idx="0">
-            <a:schemeClr val="accent1"/>
-          </a:effectRef>
-          <a:fontRef idx="minor">
-            <a:schemeClr val="tx1"/>
-          </a:fontRef>
-        </p:style>
-      </p:cxnSp>
-      <p:cxnSp>
-        <p:nvCxnSpPr>
-          <p:cNvPr id="9" name="Straight Arrow Connector 8">
-            <a:extLst>
-              <a:ext uri="{FF2B5EF4-FFF2-40B4-BE49-F238E27FC236}">
-                <a16:creationId xmlns:a16="http://schemas.microsoft.com/office/drawing/2014/main" id="{4310864F-799A-B103-2368-6064039DA5C0}"/>
-              </a:ext>
-            </a:extLst>
-          </p:cNvPr>
-          <p:cNvCxnSpPr>
-            <a:cxnSpLocks/>
-          </p:cNvCxnSpPr>
-          <p:nvPr/>
-        </p:nvCxnSpPr>
-        <p:spPr>
-          <a:xfrm flipV="1">
-            <a:off x="7247999" y="3302113"/>
-            <a:ext cx="625341" cy="337674"/>
-          </a:xfrm>
-          <a:prstGeom prst="straightConnector1">
-            <a:avLst/>
-          </a:prstGeom>
-          <a:ln w="28575">
-            <a:solidFill>
-              <a:schemeClr val="bg1">
-                <a:lumMod val="50000"/>
-              </a:schemeClr>
-            </a:solidFill>
-            <a:tailEnd type="triangle"/>
-          </a:ln>
-        </p:spPr>
-        <p:style>
-          <a:lnRef idx="1">
-            <a:schemeClr val="accent1"/>
-          </a:lnRef>
-          <a:fillRef idx="0">
-            <a:schemeClr val="accent1"/>
-          </a:fillRef>
-          <a:effectRef idx="0">
-            <a:schemeClr val="accent1"/>
-          </a:effectRef>
-          <a:fontRef idx="minor">
-            <a:schemeClr val="tx1"/>
-          </a:fontRef>
-        </p:style>
-      </p:cxnSp>
-      <p:cxnSp>
-        <p:nvCxnSpPr>
-          <p:cNvPr id="19" name="Straight Arrow Connector 18">
-            <a:extLst>
-              <a:ext uri="{FF2B5EF4-FFF2-40B4-BE49-F238E27FC236}">
-                <a16:creationId xmlns:a16="http://schemas.microsoft.com/office/drawing/2014/main" id="{A9D7B9D3-62D7-FB6F-B472-705F209A86AB}"/>
-              </a:ext>
-            </a:extLst>
-          </p:cNvPr>
-          <p:cNvCxnSpPr>
-            <a:cxnSpLocks/>
-          </p:cNvCxnSpPr>
-          <p:nvPr/>
-        </p:nvCxnSpPr>
-        <p:spPr>
-          <a:xfrm>
-            <a:off x="7296635" y="3760735"/>
-            <a:ext cx="576705" cy="437192"/>
-          </a:xfrm>
-          <a:prstGeom prst="straightConnector1">
-            <a:avLst/>
-          </a:prstGeom>
-          <a:ln w="28575">
-            <a:solidFill>
-              <a:schemeClr val="bg1">
-                <a:lumMod val="50000"/>
-              </a:schemeClr>
-            </a:solidFill>
-            <a:prstDash val="dash"/>
-            <a:tailEnd type="triangle"/>
-          </a:ln>
-        </p:spPr>
-        <p:style>
-          <a:lnRef idx="1">
-            <a:schemeClr val="accent1"/>
-          </a:lnRef>
-          <a:fillRef idx="0">
-            <a:schemeClr val="accent1"/>
-          </a:fillRef>
-          <a:effectRef idx="0">
-            <a:schemeClr val="accent1"/>
-          </a:effectRef>
-          <a:fontRef idx="minor">
-            <a:schemeClr val="tx1"/>
-          </a:fontRef>
-        </p:style>
-      </p:cxnSp>
-      <p:cxnSp>
-        <p:nvCxnSpPr>
-          <p:cNvPr id="24" name="Straight Arrow Connector 23">
-            <a:extLst>
-              <a:ext uri="{FF2B5EF4-FFF2-40B4-BE49-F238E27FC236}">
-                <a16:creationId xmlns:a16="http://schemas.microsoft.com/office/drawing/2014/main" id="{F31E96CF-3BF5-D004-0616-BA655DA25C05}"/>
-              </a:ext>
-            </a:extLst>
-          </p:cNvPr>
-          <p:cNvCxnSpPr>
-            <a:cxnSpLocks/>
-          </p:cNvCxnSpPr>
-          <p:nvPr/>
-        </p:nvCxnSpPr>
-        <p:spPr>
-          <a:xfrm>
-            <a:off x="7275177" y="3850272"/>
-            <a:ext cx="702331" cy="1315494"/>
-          </a:xfrm>
-          <a:prstGeom prst="straightConnector1">
-            <a:avLst/>
-          </a:prstGeom>
-          <a:ln w="28575">
-            <a:solidFill>
-              <a:schemeClr val="bg1">
-                <a:lumMod val="50000"/>
-              </a:schemeClr>
-            </a:solidFill>
-            <a:prstDash val="dash"/>
-            <a:tailEnd type="triangle"/>
-          </a:ln>
-        </p:spPr>
-        <p:style>
-          <a:lnRef idx="1">
-            <a:schemeClr val="accent1"/>
-          </a:lnRef>
-          <a:fillRef idx="0">
-            <a:schemeClr val="accent1"/>
-          </a:fillRef>
-          <a:effectRef idx="0">
-            <a:schemeClr val="accent1"/>
-          </a:effectRef>
-          <a:fontRef idx="minor">
-            <a:schemeClr val="tx1"/>
-          </a:fontRef>
-        </p:style>
-      </p:cxnSp>
-      <p:cxnSp>
-        <p:nvCxnSpPr>
-          <p:cNvPr id="27" name="Straight Arrow Connector 26">
-            <a:extLst>
-              <a:ext uri="{FF2B5EF4-FFF2-40B4-BE49-F238E27FC236}">
-                <a16:creationId xmlns:a16="http://schemas.microsoft.com/office/drawing/2014/main" id="{FE7D50E7-1D26-31DE-4890-6E5529F8A095}"/>
-              </a:ext>
-            </a:extLst>
-          </p:cNvPr>
-          <p:cNvCxnSpPr>
-            <a:cxnSpLocks/>
-          </p:cNvCxnSpPr>
-          <p:nvPr/>
-        </p:nvCxnSpPr>
-        <p:spPr>
-          <a:xfrm>
-            <a:off x="9592686" y="3280322"/>
-            <a:ext cx="505299" cy="0"/>
-          </a:xfrm>
-          <a:prstGeom prst="straightConnector1">
-            <a:avLst/>
-          </a:prstGeom>
-          <a:ln w="28575">
-            <a:solidFill>
-              <a:schemeClr val="bg1">
-                <a:lumMod val="50000"/>
-              </a:schemeClr>
-            </a:solidFill>
-            <a:tailEnd type="triangle"/>
-          </a:ln>
-        </p:spPr>
-        <p:style>
-          <a:lnRef idx="1">
-            <a:schemeClr val="accent1"/>
-          </a:lnRef>
-          <a:fillRef idx="0">
-            <a:schemeClr val="accent1"/>
-          </a:fillRef>
-          <a:effectRef idx="0">
-            <a:schemeClr val="accent1"/>
-          </a:effectRef>
-          <a:fontRef idx="minor">
-            <a:schemeClr val="tx1"/>
-          </a:fontRef>
-        </p:style>
-      </p:cxnSp>
-    </p:spTree>
-    <p:extLst>
-      <p:ext uri="{BB962C8B-B14F-4D97-AF65-F5344CB8AC3E}">
-        <p14:creationId xmlns:p14="http://schemas.microsoft.com/office/powerpoint/2010/main" val="2752002074"/>
       </p:ext>
     </p:extLst>
   </p:cSld>

</xml_diff>

<commit_message>
added utils and manifest
</commit_message>
<xml_diff>
--- a/day1_material/slides/day1.pptx
+++ b/day1_material/slides/day1.pptx
@@ -5,28 +5,29 @@
     <p:sldMasterId id="2147483648" r:id="rId1"/>
   </p:sldMasterIdLst>
   <p:notesMasterIdLst>
-    <p:notesMasterId r:id="rId21"/>
+    <p:notesMasterId r:id="rId22"/>
   </p:notesMasterIdLst>
   <p:sldIdLst>
     <p:sldId id="256" r:id="rId2"/>
     <p:sldId id="273" r:id="rId3"/>
     <p:sldId id="274" r:id="rId4"/>
     <p:sldId id="257" r:id="rId5"/>
-    <p:sldId id="259" r:id="rId6"/>
-    <p:sldId id="258" r:id="rId7"/>
-    <p:sldId id="260" r:id="rId8"/>
-    <p:sldId id="271" r:id="rId9"/>
-    <p:sldId id="270" r:id="rId10"/>
-    <p:sldId id="272" r:id="rId11"/>
-    <p:sldId id="276" r:id="rId12"/>
-    <p:sldId id="282" r:id="rId13"/>
-    <p:sldId id="283" r:id="rId14"/>
-    <p:sldId id="275" r:id="rId15"/>
-    <p:sldId id="285" r:id="rId16"/>
-    <p:sldId id="284" r:id="rId17"/>
-    <p:sldId id="286" r:id="rId18"/>
-    <p:sldId id="281" r:id="rId19"/>
-    <p:sldId id="277" r:id="rId20"/>
+    <p:sldId id="287" r:id="rId6"/>
+    <p:sldId id="259" r:id="rId7"/>
+    <p:sldId id="258" r:id="rId8"/>
+    <p:sldId id="260" r:id="rId9"/>
+    <p:sldId id="271" r:id="rId10"/>
+    <p:sldId id="270" r:id="rId11"/>
+    <p:sldId id="272" r:id="rId12"/>
+    <p:sldId id="276" r:id="rId13"/>
+    <p:sldId id="282" r:id="rId14"/>
+    <p:sldId id="283" r:id="rId15"/>
+    <p:sldId id="275" r:id="rId16"/>
+    <p:sldId id="285" r:id="rId17"/>
+    <p:sldId id="284" r:id="rId18"/>
+    <p:sldId id="286" r:id="rId19"/>
+    <p:sldId id="281" r:id="rId20"/>
+    <p:sldId id="277" r:id="rId21"/>
   </p:sldIdLst>
   <p:sldSz cx="12192000" cy="6858000"/>
   <p:notesSz cx="6858000" cy="9144000"/>
@@ -215,7 +216,7 @@
           <a:p>
             <a:fld id="{09C84A49-CA76-E84D-B4CB-59BA5B0597A2}" type="datetimeFigureOut">
               <a:rPr lang="en-US" smtClean="0"/>
-              <a:t>8/28/26</a:t>
+              <a:t>9/1/26</a:t>
             </a:fld>
             <a:endParaRPr lang="en-US"/>
           </a:p>
@@ -566,6 +567,114 @@
 </p:notes>
 </file>
 
+<file path=ppt/notesSlides/notesSlide2.xml><?xml version="1.0" encoding="utf-8"?>
+<p:notes xmlns:a="http://schemas.openxmlformats.org/drawingml/2006/main" xmlns:r="http://schemas.openxmlformats.org/officeDocument/2006/relationships" xmlns:p="http://schemas.openxmlformats.org/presentationml/2006/main">
+  <p:cSld>
+    <p:spTree>
+      <p:nvGrpSpPr>
+        <p:cNvPr id="1" name="">
+          <a:extLst>
+            <a:ext uri="{FF2B5EF4-FFF2-40B4-BE49-F238E27FC236}">
+              <a16:creationId xmlns:a16="http://schemas.microsoft.com/office/drawing/2014/main" id="{D25B0662-0BB0-A76F-794F-8643D9E0FB01}"/>
+            </a:ext>
+          </a:extLst>
+        </p:cNvPr>
+        <p:cNvGrpSpPr/>
+        <p:nvPr/>
+      </p:nvGrpSpPr>
+      <p:grpSpPr>
+        <a:xfrm>
+          <a:off x="0" y="0"/>
+          <a:ext cx="0" cy="0"/>
+          <a:chOff x="0" y="0"/>
+          <a:chExt cx="0" cy="0"/>
+        </a:xfrm>
+      </p:grpSpPr>
+      <p:sp>
+        <p:nvSpPr>
+          <p:cNvPr id="2" name="Slide Image Placeholder 1">
+            <a:extLst>
+              <a:ext uri="{FF2B5EF4-FFF2-40B4-BE49-F238E27FC236}">
+                <a16:creationId xmlns:a16="http://schemas.microsoft.com/office/drawing/2014/main" id="{EF7CE147-3464-757D-C634-403EDF83A6B7}"/>
+              </a:ext>
+            </a:extLst>
+          </p:cNvPr>
+          <p:cNvSpPr>
+            <a:spLocks noGrp="1" noRot="1" noChangeAspect="1"/>
+          </p:cNvSpPr>
+          <p:nvPr>
+            <p:ph type="sldImg"/>
+          </p:nvPr>
+        </p:nvSpPr>
+        <p:spPr/>
+      </p:sp>
+      <p:sp>
+        <p:nvSpPr>
+          <p:cNvPr id="3" name="Notes Placeholder 2">
+            <a:extLst>
+              <a:ext uri="{FF2B5EF4-FFF2-40B4-BE49-F238E27FC236}">
+                <a16:creationId xmlns:a16="http://schemas.microsoft.com/office/drawing/2014/main" id="{41FDFD67-4A73-06FD-272B-0E4B38450BF3}"/>
+              </a:ext>
+            </a:extLst>
+          </p:cNvPr>
+          <p:cNvSpPr>
+            <a:spLocks noGrp="1"/>
+          </p:cNvSpPr>
+          <p:nvPr>
+            <p:ph type="body" idx="1"/>
+          </p:nvPr>
+        </p:nvSpPr>
+        <p:spPr/>
+        <p:txBody>
+          <a:bodyPr/>
+          <a:lstStyle/>
+          <a:p>
+            <a:endParaRPr lang="en-US" dirty="0"/>
+          </a:p>
+        </p:txBody>
+      </p:sp>
+      <p:sp>
+        <p:nvSpPr>
+          <p:cNvPr id="4" name="Slide Number Placeholder 3">
+            <a:extLst>
+              <a:ext uri="{FF2B5EF4-FFF2-40B4-BE49-F238E27FC236}">
+                <a16:creationId xmlns:a16="http://schemas.microsoft.com/office/drawing/2014/main" id="{BAD02BB7-B796-EB2F-4893-C1800B17EBAC}"/>
+              </a:ext>
+            </a:extLst>
+          </p:cNvPr>
+          <p:cNvSpPr>
+            <a:spLocks noGrp="1"/>
+          </p:cNvSpPr>
+          <p:nvPr>
+            <p:ph type="sldNum" sz="quarter" idx="5"/>
+          </p:nvPr>
+        </p:nvSpPr>
+        <p:spPr/>
+        <p:txBody>
+          <a:bodyPr/>
+          <a:lstStyle/>
+          <a:p>
+            <a:fld id="{F57EA08E-C47D-AB46-A93F-BAC6507A654E}" type="slidenum">
+              <a:rPr lang="en-US" smtClean="0"/>
+              <a:t>5</a:t>
+            </a:fld>
+            <a:endParaRPr lang="en-US"/>
+          </a:p>
+        </p:txBody>
+      </p:sp>
+    </p:spTree>
+    <p:extLst>
+      <p:ext uri="{BB962C8B-B14F-4D97-AF65-F5344CB8AC3E}">
+        <p14:creationId xmlns:p14="http://schemas.microsoft.com/office/powerpoint/2010/main" val="2793444167"/>
+      </p:ext>
+    </p:extLst>
+  </p:cSld>
+  <p:clrMapOvr>
+    <a:masterClrMapping/>
+  </p:clrMapOvr>
+</p:notes>
+</file>
+
 <file path=ppt/slideLayouts/slideLayout1.xml><?xml version="1.0" encoding="utf-8"?>
 <p:sldLayout xmlns:a="http://schemas.openxmlformats.org/drawingml/2006/main" xmlns:r="http://schemas.openxmlformats.org/officeDocument/2006/relationships" xmlns:p="http://schemas.openxmlformats.org/presentationml/2006/main" type="title" preserve="1">
   <p:cSld name="Title Slide">
@@ -713,7 +822,7 @@
           <a:p>
             <a:fld id="{EC483935-07C3-DB40-BDCF-E55515B19C93}" type="datetimeFigureOut">
               <a:rPr lang="en-US" smtClean="0"/>
-              <a:t>8/28/26</a:t>
+              <a:t>9/1/26</a:t>
             </a:fld>
             <a:endParaRPr lang="en-US"/>
           </a:p>
@@ -911,7 +1020,7 @@
           <a:p>
             <a:fld id="{EC483935-07C3-DB40-BDCF-E55515B19C93}" type="datetimeFigureOut">
               <a:rPr lang="en-US" smtClean="0"/>
-              <a:t>8/28/26</a:t>
+              <a:t>9/1/26</a:t>
             </a:fld>
             <a:endParaRPr lang="en-US"/>
           </a:p>
@@ -1119,7 +1228,7 @@
           <a:p>
             <a:fld id="{EC483935-07C3-DB40-BDCF-E55515B19C93}" type="datetimeFigureOut">
               <a:rPr lang="en-US" smtClean="0"/>
-              <a:t>8/28/26</a:t>
+              <a:t>9/1/26</a:t>
             </a:fld>
             <a:endParaRPr lang="en-US"/>
           </a:p>
@@ -1317,7 +1426,7 @@
           <a:p>
             <a:fld id="{EC483935-07C3-DB40-BDCF-E55515B19C93}" type="datetimeFigureOut">
               <a:rPr lang="en-US" smtClean="0"/>
-              <a:t>8/28/26</a:t>
+              <a:t>9/1/26</a:t>
             </a:fld>
             <a:endParaRPr lang="en-US"/>
           </a:p>
@@ -1592,7 +1701,7 @@
           <a:p>
             <a:fld id="{EC483935-07C3-DB40-BDCF-E55515B19C93}" type="datetimeFigureOut">
               <a:rPr lang="en-US" smtClean="0"/>
-              <a:t>8/28/26</a:t>
+              <a:t>9/1/26</a:t>
             </a:fld>
             <a:endParaRPr lang="en-US"/>
           </a:p>
@@ -1857,7 +1966,7 @@
           <a:p>
             <a:fld id="{EC483935-07C3-DB40-BDCF-E55515B19C93}" type="datetimeFigureOut">
               <a:rPr lang="en-US" smtClean="0"/>
-              <a:t>8/28/26</a:t>
+              <a:t>9/1/26</a:t>
             </a:fld>
             <a:endParaRPr lang="en-US"/>
           </a:p>
@@ -2269,7 +2378,7 @@
           <a:p>
             <a:fld id="{EC483935-07C3-DB40-BDCF-E55515B19C93}" type="datetimeFigureOut">
               <a:rPr lang="en-US" smtClean="0"/>
-              <a:t>8/28/26</a:t>
+              <a:t>9/1/26</a:t>
             </a:fld>
             <a:endParaRPr lang="en-US"/>
           </a:p>
@@ -2410,7 +2519,7 @@
           <a:p>
             <a:fld id="{EC483935-07C3-DB40-BDCF-E55515B19C93}" type="datetimeFigureOut">
               <a:rPr lang="en-US" smtClean="0"/>
-              <a:t>8/28/26</a:t>
+              <a:t>9/1/26</a:t>
             </a:fld>
             <a:endParaRPr lang="en-US"/>
           </a:p>
@@ -2523,7 +2632,7 @@
           <a:p>
             <a:fld id="{EC483935-07C3-DB40-BDCF-E55515B19C93}" type="datetimeFigureOut">
               <a:rPr lang="en-US" smtClean="0"/>
-              <a:t>8/28/26</a:t>
+              <a:t>9/1/26</a:t>
             </a:fld>
             <a:endParaRPr lang="en-US"/>
           </a:p>
@@ -2834,7 +2943,7 @@
           <a:p>
             <a:fld id="{EC483935-07C3-DB40-BDCF-E55515B19C93}" type="datetimeFigureOut">
               <a:rPr lang="en-US" smtClean="0"/>
-              <a:t>8/28/26</a:t>
+              <a:t>9/1/26</a:t>
             </a:fld>
             <a:endParaRPr lang="en-US"/>
           </a:p>
@@ -3122,7 +3231,7 @@
           <a:p>
             <a:fld id="{EC483935-07C3-DB40-BDCF-E55515B19C93}" type="datetimeFigureOut">
               <a:rPr lang="en-US" smtClean="0"/>
-              <a:t>8/28/26</a:t>
+              <a:t>9/1/26</a:t>
             </a:fld>
             <a:endParaRPr lang="en-US"/>
           </a:p>
@@ -3363,7 +3472,7 @@
           <a:p>
             <a:fld id="{EC483935-07C3-DB40-BDCF-E55515B19C93}" type="datetimeFigureOut">
               <a:rPr lang="en-US" smtClean="0"/>
-              <a:t>8/28/26</a:t>
+              <a:t>9/1/26</a:t>
             </a:fld>
             <a:endParaRPr lang="en-US"/>
           </a:p>
@@ -3890,6 +3999,229 @@
         <p:cNvPr id="1" name="">
           <a:extLst>
             <a:ext uri="{FF2B5EF4-FFF2-40B4-BE49-F238E27FC236}">
+              <a16:creationId xmlns:a16="http://schemas.microsoft.com/office/drawing/2014/main" id="{D1DE9E7D-34D7-E69A-60E0-2A1A2E83AC4E}"/>
+            </a:ext>
+          </a:extLst>
+        </p:cNvPr>
+        <p:cNvGrpSpPr/>
+        <p:nvPr/>
+      </p:nvGrpSpPr>
+      <p:grpSpPr>
+        <a:xfrm>
+          <a:off x="0" y="0"/>
+          <a:ext cx="0" cy="0"/>
+          <a:chOff x="0" y="0"/>
+          <a:chExt cx="0" cy="0"/>
+        </a:xfrm>
+      </p:grpSpPr>
+      <p:sp>
+        <p:nvSpPr>
+          <p:cNvPr id="2" name="Title 1">
+            <a:extLst>
+              <a:ext uri="{FF2B5EF4-FFF2-40B4-BE49-F238E27FC236}">
+                <a16:creationId xmlns:a16="http://schemas.microsoft.com/office/drawing/2014/main" id="{0C97E257-5254-58A5-D134-275D22ABB3ED}"/>
+              </a:ext>
+            </a:extLst>
+          </p:cNvPr>
+          <p:cNvSpPr>
+            <a:spLocks noGrp="1"/>
+          </p:cNvSpPr>
+          <p:nvPr>
+            <p:ph type="title"/>
+          </p:nvPr>
+        </p:nvSpPr>
+        <p:spPr/>
+        <p:txBody>
+          <a:bodyPr/>
+          <a:lstStyle/>
+          <a:p>
+            <a:r>
+              <a:rPr lang="en-US" dirty="0" err="1"/>
+              <a:t>Nextflow</a:t>
+            </a:r>
+            <a:r>
+              <a:rPr lang="en-US" dirty="0"/>
+              <a:t> components: </a:t>
+            </a:r>
+            <a:r>
+              <a:rPr lang="en-US" b="1" dirty="0"/>
+              <a:t>processes</a:t>
+            </a:r>
+          </a:p>
+        </p:txBody>
+      </p:sp>
+      <p:sp>
+        <p:nvSpPr>
+          <p:cNvPr id="3" name="Content Placeholder 2">
+            <a:extLst>
+              <a:ext uri="{FF2B5EF4-FFF2-40B4-BE49-F238E27FC236}">
+                <a16:creationId xmlns:a16="http://schemas.microsoft.com/office/drawing/2014/main" id="{1CC895E0-3F1B-B147-6FFB-19BA5C8C1CD7}"/>
+              </a:ext>
+            </a:extLst>
+          </p:cNvPr>
+          <p:cNvSpPr>
+            <a:spLocks noGrp="1"/>
+          </p:cNvSpPr>
+          <p:nvPr>
+            <p:ph idx="1"/>
+          </p:nvPr>
+        </p:nvSpPr>
+        <p:spPr/>
+        <p:txBody>
+          <a:bodyPr/>
+          <a:lstStyle/>
+          <a:p>
+            <a:pPr marL="0" indent="0">
+              <a:buNone/>
+            </a:pPr>
+            <a:r>
+              <a:rPr lang="en-US" b="1" dirty="0">
+                <a:solidFill>
+                  <a:schemeClr val="accent2"/>
+                </a:solidFill>
+              </a:rPr>
+              <a:t>Processes</a:t>
+            </a:r>
+            <a:r>
+              <a:rPr lang="en-US" dirty="0"/>
+              <a:t> are the basic computing units in </a:t>
+            </a:r>
+            <a:r>
+              <a:rPr lang="en-US" dirty="0" err="1"/>
+              <a:t>Nextflow</a:t>
+            </a:r>
+            <a:r>
+              <a:rPr lang="en-US" dirty="0"/>
+              <a:t>. Each process defines:</a:t>
+            </a:r>
+          </a:p>
+          <a:p>
+            <a:r>
+              <a:rPr lang="en-US" b="1" dirty="0"/>
+              <a:t>Inputs and outputs</a:t>
+            </a:r>
+            <a:r>
+              <a:rPr lang="en-US" dirty="0"/>
+              <a:t>: Data consumed and produced</a:t>
+            </a:r>
+          </a:p>
+          <a:p>
+            <a:r>
+              <a:rPr lang="en-US" b="1" dirty="0"/>
+              <a:t>Script</a:t>
+            </a:r>
+            <a:r>
+              <a:rPr lang="en-US" dirty="0"/>
+              <a:t>: The actual command or code to execute</a:t>
+            </a:r>
+          </a:p>
+          <a:p>
+            <a:r>
+              <a:rPr lang="en-US" b="1" dirty="0"/>
+              <a:t>Directives</a:t>
+            </a:r>
+            <a:r>
+              <a:rPr lang="en-US" dirty="0"/>
+              <a:t>: Resource requirements (CPU, memory, time)</a:t>
+            </a:r>
+          </a:p>
+          <a:p>
+            <a:pPr marL="0" indent="0">
+              <a:buNone/>
+            </a:pPr>
+            <a:endParaRPr lang="en-US" dirty="0"/>
+          </a:p>
+          <a:p>
+            <a:pPr marL="0" indent="0">
+              <a:buNone/>
+            </a:pPr>
+            <a:r>
+              <a:rPr lang="en-US" dirty="0"/>
+              <a:t>Think of a process as a single step in your pipeline, like "align reads" or ”run inference tool”. Processes are isolated (</a:t>
+            </a:r>
+            <a:r>
+              <a:rPr lang="en-US" b="1" dirty="0">
+                <a:solidFill>
+                  <a:schemeClr val="accent2"/>
+                </a:solidFill>
+              </a:rPr>
+              <a:t>modules</a:t>
+            </a:r>
+            <a:r>
+              <a:rPr lang="en-US" dirty="0"/>
+              <a:t>)and can be executed independently, enabling parallelization. </a:t>
+            </a:r>
+          </a:p>
+        </p:txBody>
+      </p:sp>
+      <p:pic>
+        <p:nvPicPr>
+          <p:cNvPr id="4098" name="Picture 2" descr="Manufacturing Factory Tool Icons - Free SVG &amp; PNG Manufacturing Factory Tool  Images - Noun Project">
+            <a:extLst>
+              <a:ext uri="{FF2B5EF4-FFF2-40B4-BE49-F238E27FC236}">
+                <a16:creationId xmlns:a16="http://schemas.microsoft.com/office/drawing/2014/main" id="{CF13FCC3-795D-264A-652A-5CE31D964342}"/>
+              </a:ext>
+            </a:extLst>
+          </p:cNvPr>
+          <p:cNvPicPr>
+            <a:picLocks noChangeAspect="1" noChangeArrowheads="1"/>
+          </p:cNvPicPr>
+          <p:nvPr/>
+        </p:nvPicPr>
+        <p:blipFill>
+          <a:blip r:embed="rId2">
+            <a:extLst>
+              <a:ext uri="{28A0092B-C50C-407E-A947-70E740481C1C}">
+                <a14:useLocalDpi xmlns:a14="http://schemas.microsoft.com/office/drawing/2010/main" val="0"/>
+              </a:ext>
+            </a:extLst>
+          </a:blip>
+          <a:srcRect/>
+          <a:stretch>
+            <a:fillRect/>
+          </a:stretch>
+        </p:blipFill>
+        <p:spPr bwMode="auto">
+          <a:xfrm>
+            <a:off x="9004461" y="585043"/>
+            <a:ext cx="834020" cy="834020"/>
+          </a:xfrm>
+          <a:prstGeom prst="rect">
+            <a:avLst/>
+          </a:prstGeom>
+          <a:noFill/>
+          <a:extLst>
+            <a:ext uri="{909E8E84-426E-40DD-AFC4-6F175D3DCCD1}">
+              <a14:hiddenFill xmlns:a14="http://schemas.microsoft.com/office/drawing/2010/main">
+                <a:solidFill>
+                  <a:srgbClr val="FFFFFF"/>
+                </a:solidFill>
+              </a14:hiddenFill>
+            </a:ext>
+          </a:extLst>
+        </p:spPr>
+      </p:pic>
+    </p:spTree>
+    <p:extLst>
+      <p:ext uri="{BB962C8B-B14F-4D97-AF65-F5344CB8AC3E}">
+        <p14:creationId xmlns:p14="http://schemas.microsoft.com/office/powerpoint/2010/main" val="3903298263"/>
+      </p:ext>
+    </p:extLst>
+  </p:cSld>
+  <p:clrMapOvr>
+    <a:masterClrMapping/>
+  </p:clrMapOvr>
+</p:sld>
+</file>
+
+<file path=ppt/slides/slide11.xml><?xml version="1.0" encoding="utf-8"?>
+<p:sld xmlns:a="http://schemas.openxmlformats.org/drawingml/2006/main" xmlns:r="http://schemas.openxmlformats.org/officeDocument/2006/relationships" xmlns:p="http://schemas.openxmlformats.org/presentationml/2006/main">
+  <p:cSld>
+    <p:spTree>
+      <p:nvGrpSpPr>
+        <p:cNvPr id="1" name="">
+          <a:extLst>
+            <a:ext uri="{FF2B5EF4-FFF2-40B4-BE49-F238E27FC236}">
               <a16:creationId xmlns:a16="http://schemas.microsoft.com/office/drawing/2014/main" id="{E3AD97CB-B8A2-C139-67D1-19D621A2F549}"/>
             </a:ext>
           </a:extLst>
@@ -4784,7 +5116,7 @@
 </p:sld>
 </file>
 
-<file path=ppt/slides/slide11.xml><?xml version="1.0" encoding="utf-8"?>
+<file path=ppt/slides/slide12.xml><?xml version="1.0" encoding="utf-8"?>
 <p:sld xmlns:a="http://schemas.openxmlformats.org/drawingml/2006/main" xmlns:r="http://schemas.openxmlformats.org/officeDocument/2006/relationships" xmlns:p="http://schemas.openxmlformats.org/presentationml/2006/main">
   <p:cSld>
     <p:spTree>
@@ -4987,7 +5319,7 @@
 </p:sld>
 </file>
 
-<file path=ppt/slides/slide12.xml><?xml version="1.0" encoding="utf-8"?>
+<file path=ppt/slides/slide13.xml><?xml version="1.0" encoding="utf-8"?>
 <p:sld xmlns:a="http://schemas.openxmlformats.org/drawingml/2006/main" xmlns:r="http://schemas.openxmlformats.org/officeDocument/2006/relationships" xmlns:p="http://schemas.openxmlformats.org/presentationml/2006/main">
   <p:cSld>
     <p:spTree>
@@ -5982,7 +6314,7 @@
 </p:sld>
 </file>
 
-<file path=ppt/slides/slide13.xml><?xml version="1.0" encoding="utf-8"?>
+<file path=ppt/slides/slide14.xml><?xml version="1.0" encoding="utf-8"?>
 <p:sld xmlns:a="http://schemas.openxmlformats.org/drawingml/2006/main" xmlns:r="http://schemas.openxmlformats.org/officeDocument/2006/relationships" xmlns:p="http://schemas.openxmlformats.org/presentationml/2006/main">
   <p:cSld>
     <p:spTree>
@@ -6482,7 +6814,7 @@
 </p:sld>
 </file>
 
-<file path=ppt/slides/slide14.xml><?xml version="1.0" encoding="utf-8"?>
+<file path=ppt/slides/slide15.xml><?xml version="1.0" encoding="utf-8"?>
 <p:sld xmlns:a="http://schemas.openxmlformats.org/drawingml/2006/main" xmlns:r="http://schemas.openxmlformats.org/officeDocument/2006/relationships" xmlns:p="http://schemas.openxmlformats.org/presentationml/2006/main">
   <p:cSld>
     <p:spTree>
@@ -6713,7 +7045,7 @@
 </p:sld>
 </file>
 
-<file path=ppt/slides/slide15.xml><?xml version="1.0" encoding="utf-8"?>
+<file path=ppt/slides/slide16.xml><?xml version="1.0" encoding="utf-8"?>
 <p:sld xmlns:a="http://schemas.openxmlformats.org/drawingml/2006/main" xmlns:r="http://schemas.openxmlformats.org/officeDocument/2006/relationships" xmlns:p="http://schemas.openxmlformats.org/presentationml/2006/main">
   <p:cSld>
     <p:spTree>
@@ -7720,7 +8052,7 @@
 </p:sld>
 </file>
 
-<file path=ppt/slides/slide16.xml><?xml version="1.0" encoding="utf-8"?>
+<file path=ppt/slides/slide17.xml><?xml version="1.0" encoding="utf-8"?>
 <p:sld xmlns:a="http://schemas.openxmlformats.org/drawingml/2006/main" xmlns:r="http://schemas.openxmlformats.org/officeDocument/2006/relationships" xmlns:p="http://schemas.openxmlformats.org/presentationml/2006/main">
   <p:cSld>
     <p:spTree>
@@ -8622,7 +8954,7 @@
 </p:sld>
 </file>
 
-<file path=ppt/slides/slide17.xml><?xml version="1.0" encoding="utf-8"?>
+<file path=ppt/slides/slide18.xml><?xml version="1.0" encoding="utf-8"?>
 <p:sld xmlns:a="http://schemas.openxmlformats.org/drawingml/2006/main" xmlns:r="http://schemas.openxmlformats.org/officeDocument/2006/relationships" xmlns:p="http://schemas.openxmlformats.org/presentationml/2006/main">
   <p:cSld>
     <p:spTree>
@@ -9419,7 +9751,7 @@
 </p:sld>
 </file>
 
-<file path=ppt/slides/slide18.xml><?xml version="1.0" encoding="utf-8"?>
+<file path=ppt/slides/slide19.xml><?xml version="1.0" encoding="utf-8"?>
 <p:sld xmlns:a="http://schemas.openxmlformats.org/drawingml/2006/main" xmlns:r="http://schemas.openxmlformats.org/officeDocument/2006/relationships" xmlns:p="http://schemas.openxmlformats.org/presentationml/2006/main">
   <p:cSld>
     <p:spTree>
@@ -9810,7 +10142,90 @@
 </p:sld>
 </file>
 
-<file path=ppt/slides/slide19.xml><?xml version="1.0" encoding="utf-8"?>
+<file path=ppt/slides/slide2.xml><?xml version="1.0" encoding="utf-8"?>
+<p:sld xmlns:a="http://schemas.openxmlformats.org/drawingml/2006/main" xmlns:r="http://schemas.openxmlformats.org/officeDocument/2006/relationships" xmlns:p="http://schemas.openxmlformats.org/presentationml/2006/main">
+  <p:cSld>
+    <p:spTree>
+      <p:nvGrpSpPr>
+        <p:cNvPr id="1" name=""/>
+        <p:cNvGrpSpPr/>
+        <p:nvPr/>
+      </p:nvGrpSpPr>
+      <p:grpSpPr>
+        <a:xfrm>
+          <a:off x="0" y="0"/>
+          <a:ext cx="0" cy="0"/>
+          <a:chOff x="0" y="0"/>
+          <a:chExt cx="0" cy="0"/>
+        </a:xfrm>
+      </p:grpSpPr>
+      <p:sp>
+        <p:nvSpPr>
+          <p:cNvPr id="2" name="Title 1">
+            <a:extLst>
+              <a:ext uri="{FF2B5EF4-FFF2-40B4-BE49-F238E27FC236}">
+                <a16:creationId xmlns:a16="http://schemas.microsoft.com/office/drawing/2014/main" id="{C8439672-E7F5-1723-B190-A3D07B73B95A}"/>
+              </a:ext>
+            </a:extLst>
+          </p:cNvPr>
+          <p:cNvSpPr>
+            <a:spLocks noGrp="1"/>
+          </p:cNvSpPr>
+          <p:nvPr>
+            <p:ph type="title"/>
+          </p:nvPr>
+        </p:nvSpPr>
+        <p:spPr/>
+        <p:txBody>
+          <a:bodyPr/>
+          <a:lstStyle/>
+          <a:p>
+            <a:r>
+              <a:rPr lang="en-US" dirty="0"/>
+              <a:t>Plan</a:t>
+            </a:r>
+          </a:p>
+        </p:txBody>
+      </p:sp>
+      <p:sp>
+        <p:nvSpPr>
+          <p:cNvPr id="3" name="Content Placeholder 2">
+            <a:extLst>
+              <a:ext uri="{FF2B5EF4-FFF2-40B4-BE49-F238E27FC236}">
+                <a16:creationId xmlns:a16="http://schemas.microsoft.com/office/drawing/2014/main" id="{588B3222-58DD-375B-1D58-C6FD304DA78A}"/>
+              </a:ext>
+            </a:extLst>
+          </p:cNvPr>
+          <p:cNvSpPr>
+            <a:spLocks noGrp="1"/>
+          </p:cNvSpPr>
+          <p:nvPr>
+            <p:ph idx="1"/>
+          </p:nvPr>
+        </p:nvSpPr>
+        <p:spPr/>
+        <p:txBody>
+          <a:bodyPr/>
+          <a:lstStyle/>
+          <a:p>
+            <a:endParaRPr lang="en-US"/>
+          </a:p>
+        </p:txBody>
+      </p:sp>
+    </p:spTree>
+    <p:extLst>
+      <p:ext uri="{BB962C8B-B14F-4D97-AF65-F5344CB8AC3E}">
+        <p14:creationId xmlns:p14="http://schemas.microsoft.com/office/powerpoint/2010/main" val="1157480680"/>
+      </p:ext>
+    </p:extLst>
+  </p:cSld>
+  <p:clrMapOvr>
+    <a:masterClrMapping/>
+  </p:clrMapOvr>
+</p:sld>
+</file>
+
+<file path=ppt/slides/slide20.xml><?xml version="1.0" encoding="utf-8"?>
 <p:sld xmlns:a="http://schemas.openxmlformats.org/drawingml/2006/main" xmlns:r="http://schemas.openxmlformats.org/officeDocument/2006/relationships" xmlns:p="http://schemas.openxmlformats.org/presentationml/2006/main">
   <p:cSld>
     <p:spTree>
@@ -10491,89 +10906,6 @@
 </p:sld>
 </file>
 
-<file path=ppt/slides/slide2.xml><?xml version="1.0" encoding="utf-8"?>
-<p:sld xmlns:a="http://schemas.openxmlformats.org/drawingml/2006/main" xmlns:r="http://schemas.openxmlformats.org/officeDocument/2006/relationships" xmlns:p="http://schemas.openxmlformats.org/presentationml/2006/main">
-  <p:cSld>
-    <p:spTree>
-      <p:nvGrpSpPr>
-        <p:cNvPr id="1" name=""/>
-        <p:cNvGrpSpPr/>
-        <p:nvPr/>
-      </p:nvGrpSpPr>
-      <p:grpSpPr>
-        <a:xfrm>
-          <a:off x="0" y="0"/>
-          <a:ext cx="0" cy="0"/>
-          <a:chOff x="0" y="0"/>
-          <a:chExt cx="0" cy="0"/>
-        </a:xfrm>
-      </p:grpSpPr>
-      <p:sp>
-        <p:nvSpPr>
-          <p:cNvPr id="2" name="Title 1">
-            <a:extLst>
-              <a:ext uri="{FF2B5EF4-FFF2-40B4-BE49-F238E27FC236}">
-                <a16:creationId xmlns:a16="http://schemas.microsoft.com/office/drawing/2014/main" id="{C8439672-E7F5-1723-B190-A3D07B73B95A}"/>
-              </a:ext>
-            </a:extLst>
-          </p:cNvPr>
-          <p:cNvSpPr>
-            <a:spLocks noGrp="1"/>
-          </p:cNvSpPr>
-          <p:nvPr>
-            <p:ph type="title"/>
-          </p:nvPr>
-        </p:nvSpPr>
-        <p:spPr/>
-        <p:txBody>
-          <a:bodyPr/>
-          <a:lstStyle/>
-          <a:p>
-            <a:r>
-              <a:rPr lang="en-US" dirty="0"/>
-              <a:t>Plan</a:t>
-            </a:r>
-          </a:p>
-        </p:txBody>
-      </p:sp>
-      <p:sp>
-        <p:nvSpPr>
-          <p:cNvPr id="3" name="Content Placeholder 2">
-            <a:extLst>
-              <a:ext uri="{FF2B5EF4-FFF2-40B4-BE49-F238E27FC236}">
-                <a16:creationId xmlns:a16="http://schemas.microsoft.com/office/drawing/2014/main" id="{588B3222-58DD-375B-1D58-C6FD304DA78A}"/>
-              </a:ext>
-            </a:extLst>
-          </p:cNvPr>
-          <p:cNvSpPr>
-            <a:spLocks noGrp="1"/>
-          </p:cNvSpPr>
-          <p:nvPr>
-            <p:ph idx="1"/>
-          </p:nvPr>
-        </p:nvSpPr>
-        <p:spPr/>
-        <p:txBody>
-          <a:bodyPr/>
-          <a:lstStyle/>
-          <a:p>
-            <a:endParaRPr lang="en-US"/>
-          </a:p>
-        </p:txBody>
-      </p:sp>
-    </p:spTree>
-    <p:extLst>
-      <p:ext uri="{BB962C8B-B14F-4D97-AF65-F5344CB8AC3E}">
-        <p14:creationId xmlns:p14="http://schemas.microsoft.com/office/powerpoint/2010/main" val="1157480680"/>
-      </p:ext>
-    </p:extLst>
-  </p:cSld>
-  <p:clrMapOvr>
-    <a:masterClrMapping/>
-  </p:clrMapOvr>
-</p:sld>
-</file>
-
 <file path=ppt/slides/slide3.xml><?xml version="1.0" encoding="utf-8"?>
 <p:sld xmlns:a="http://schemas.openxmlformats.org/drawingml/2006/main" xmlns:r="http://schemas.openxmlformats.org/officeDocument/2006/relationships" xmlns:p="http://schemas.openxmlformats.org/presentationml/2006/main">
   <p:cSld>
@@ -11454,6 +11786,219 @@
         <p:cNvPr id="1" name="">
           <a:extLst>
             <a:ext uri="{FF2B5EF4-FFF2-40B4-BE49-F238E27FC236}">
+              <a16:creationId xmlns:a16="http://schemas.microsoft.com/office/drawing/2014/main" id="{4E792DE2-F5EE-A8DC-8013-71399FC5A50D}"/>
+            </a:ext>
+          </a:extLst>
+        </p:cNvPr>
+        <p:cNvGrpSpPr/>
+        <p:nvPr/>
+      </p:nvGrpSpPr>
+      <p:grpSpPr>
+        <a:xfrm>
+          <a:off x="0" y="0"/>
+          <a:ext cx="0" cy="0"/>
+          <a:chOff x="0" y="0"/>
+          <a:chExt cx="0" cy="0"/>
+        </a:xfrm>
+      </p:grpSpPr>
+      <p:sp>
+        <p:nvSpPr>
+          <p:cNvPr id="2" name="Title 1">
+            <a:extLst>
+              <a:ext uri="{FF2B5EF4-FFF2-40B4-BE49-F238E27FC236}">
+                <a16:creationId xmlns:a16="http://schemas.microsoft.com/office/drawing/2014/main" id="{E6D837CE-B9A8-081E-B030-A1B26AB7527B}"/>
+              </a:ext>
+            </a:extLst>
+          </p:cNvPr>
+          <p:cNvSpPr>
+            <a:spLocks noGrp="1"/>
+          </p:cNvSpPr>
+          <p:nvPr>
+            <p:ph type="title"/>
+          </p:nvPr>
+        </p:nvSpPr>
+        <p:spPr/>
+        <p:txBody>
+          <a:bodyPr/>
+          <a:lstStyle/>
+          <a:p>
+            <a:r>
+              <a:rPr lang="en-US" dirty="0"/>
+              <a:t>Why pipeline managers?</a:t>
+            </a:r>
+          </a:p>
+        </p:txBody>
+      </p:sp>
+      <p:sp>
+        <p:nvSpPr>
+          <p:cNvPr id="14" name="TextBox 13">
+            <a:extLst>
+              <a:ext uri="{FF2B5EF4-FFF2-40B4-BE49-F238E27FC236}">
+                <a16:creationId xmlns:a16="http://schemas.microsoft.com/office/drawing/2014/main" id="{0B7244FC-66C5-6BA3-F78B-D5C8EC1C259C}"/>
+              </a:ext>
+            </a:extLst>
+          </p:cNvPr>
+          <p:cNvSpPr txBox="1"/>
+          <p:nvPr/>
+        </p:nvSpPr>
+        <p:spPr>
+          <a:xfrm>
+            <a:off x="950319" y="1533957"/>
+            <a:ext cx="2101281" cy="1323439"/>
+          </a:xfrm>
+          <a:prstGeom prst="rect">
+            <a:avLst/>
+          </a:prstGeom>
+          <a:noFill/>
+        </p:spPr>
+        <p:txBody>
+          <a:bodyPr wrap="none" rtlCol="0">
+            <a:spAutoFit/>
+          </a:bodyPr>
+          <a:lstStyle/>
+          <a:p>
+            <a:pPr marL="342900" indent="-342900">
+              <a:buFont typeface="Arial" panose="020B0604020202020204" pitchFamily="34" charset="0"/>
+              <a:buChar char="•"/>
+            </a:pPr>
+            <a:r>
+              <a:rPr lang="en-US" sz="2000" dirty="0">
+                <a:solidFill>
+                  <a:srgbClr val="05BE99"/>
+                </a:solidFill>
+              </a:rPr>
+              <a:t>Reproducibility</a:t>
+            </a:r>
+          </a:p>
+          <a:p>
+            <a:pPr marL="342900" indent="-342900">
+              <a:buFont typeface="Arial" panose="020B0604020202020204" pitchFamily="34" charset="0"/>
+              <a:buChar char="•"/>
+            </a:pPr>
+            <a:r>
+              <a:rPr lang="en-US" sz="2000" dirty="0">
+                <a:solidFill>
+                  <a:srgbClr val="05BE99"/>
+                </a:solidFill>
+              </a:rPr>
+              <a:t>Scalability</a:t>
+            </a:r>
+          </a:p>
+          <a:p>
+            <a:pPr marL="342900" indent="-342900">
+              <a:buFont typeface="Arial" panose="020B0604020202020204" pitchFamily="34" charset="0"/>
+              <a:buChar char="•"/>
+            </a:pPr>
+            <a:r>
+              <a:rPr lang="en-US" sz="2000" dirty="0">
+                <a:solidFill>
+                  <a:srgbClr val="05BE99"/>
+                </a:solidFill>
+              </a:rPr>
+              <a:t>Resumability</a:t>
+            </a:r>
+          </a:p>
+          <a:p>
+            <a:pPr marL="342900" indent="-342900">
+              <a:buFont typeface="Arial" panose="020B0604020202020204" pitchFamily="34" charset="0"/>
+              <a:buChar char="•"/>
+            </a:pPr>
+            <a:r>
+              <a:rPr lang="en-US" sz="2000" dirty="0">
+                <a:solidFill>
+                  <a:srgbClr val="05BE99"/>
+                </a:solidFill>
+              </a:rPr>
+              <a:t>Portability</a:t>
+            </a:r>
+          </a:p>
+        </p:txBody>
+      </p:sp>
+      <p:sp>
+        <p:nvSpPr>
+          <p:cNvPr id="12" name="TextBox 11">
+            <a:extLst>
+              <a:ext uri="{FF2B5EF4-FFF2-40B4-BE49-F238E27FC236}">
+                <a16:creationId xmlns:a16="http://schemas.microsoft.com/office/drawing/2014/main" id="{169864BF-15EE-EE46-47A5-B636525E77CF}"/>
+              </a:ext>
+            </a:extLst>
+          </p:cNvPr>
+          <p:cNvSpPr txBox="1"/>
+          <p:nvPr/>
+        </p:nvSpPr>
+        <p:spPr>
+          <a:xfrm>
+            <a:off x="4478482" y="1695080"/>
+            <a:ext cx="6095010" cy="1200329"/>
+          </a:xfrm>
+          <a:prstGeom prst="rect">
+            <a:avLst/>
+          </a:prstGeom>
+          <a:noFill/>
+        </p:spPr>
+        <p:txBody>
+          <a:bodyPr wrap="square">
+            <a:spAutoFit/>
+          </a:bodyPr>
+          <a:lstStyle/>
+          <a:p>
+            <a:r>
+              <a:rPr lang="en-US" sz="1800" b="0" i="0" dirty="0">
+                <a:solidFill>
+                  <a:schemeClr val="tx1"/>
+                </a:solidFill>
+                <a:effectLst/>
+                <a:latin typeface="+mn-lt"/>
+              </a:rPr>
+              <a:t>In order to </a:t>
+            </a:r>
+            <a:r>
+              <a:rPr lang="en-US" sz="1800" b="1" i="0" dirty="0">
+                <a:solidFill>
+                  <a:schemeClr val="tx1"/>
+                </a:solidFill>
+                <a:effectLst/>
+                <a:latin typeface="+mn-lt"/>
+              </a:rPr>
+              <a:t>minimize the number of manual steps </a:t>
+            </a:r>
+            <a:r>
+              <a:rPr lang="en-US" sz="1800" b="0" i="0" dirty="0">
+                <a:solidFill>
+                  <a:schemeClr val="tx1"/>
+                </a:solidFill>
+                <a:effectLst/>
+                <a:latin typeface="+mn-lt"/>
+              </a:rPr>
+              <a:t>that are required to execute an analysis workflow, computational pipelines automatically chain together multiple tools. </a:t>
+            </a:r>
+          </a:p>
+          <a:p>
+            <a:endParaRPr lang="en-US" dirty="0"/>
+          </a:p>
+        </p:txBody>
+      </p:sp>
+    </p:spTree>
+    <p:extLst>
+      <p:ext uri="{BB962C8B-B14F-4D97-AF65-F5344CB8AC3E}">
+        <p14:creationId xmlns:p14="http://schemas.microsoft.com/office/powerpoint/2010/main" val="3424635678"/>
+      </p:ext>
+    </p:extLst>
+  </p:cSld>
+  <p:clrMapOvr>
+    <a:masterClrMapping/>
+  </p:clrMapOvr>
+</p:sld>
+</file>
+
+<file path=ppt/slides/slide6.xml><?xml version="1.0" encoding="utf-8"?>
+<p:sld xmlns:a="http://schemas.openxmlformats.org/drawingml/2006/main" xmlns:r="http://schemas.openxmlformats.org/officeDocument/2006/relationships" xmlns:p="http://schemas.openxmlformats.org/presentationml/2006/main">
+  <p:cSld>
+    <p:spTree>
+      <p:nvGrpSpPr>
+        <p:cNvPr id="1" name="">
+          <a:extLst>
+            <a:ext uri="{FF2B5EF4-FFF2-40B4-BE49-F238E27FC236}">
               <a16:creationId xmlns:a16="http://schemas.microsoft.com/office/drawing/2014/main" id="{644F7E96-FE70-D22B-728F-D70B24A20394}"/>
             </a:ext>
           </a:extLst>
@@ -11570,7 +12115,7 @@
 </p:sld>
 </file>
 
-<file path=ppt/slides/slide6.xml><?xml version="1.0" encoding="utf-8"?>
+<file path=ppt/slides/slide7.xml><?xml version="1.0" encoding="utf-8"?>
 <p:sld xmlns:a="http://schemas.openxmlformats.org/drawingml/2006/main" xmlns:r="http://schemas.openxmlformats.org/officeDocument/2006/relationships" xmlns:p="http://schemas.openxmlformats.org/presentationml/2006/main">
   <p:cSld>
     <p:spTree>
@@ -11666,7 +12211,7 @@
 </p:sld>
 </file>
 
-<file path=ppt/slides/slide7.xml><?xml version="1.0" encoding="utf-8"?>
+<file path=ppt/slides/slide8.xml><?xml version="1.0" encoding="utf-8"?>
 <p:sld xmlns:a="http://schemas.openxmlformats.org/drawingml/2006/main" xmlns:r="http://schemas.openxmlformats.org/officeDocument/2006/relationships" xmlns:p="http://schemas.openxmlformats.org/presentationml/2006/main">
   <p:cSld>
     <p:spTree>
@@ -11735,7 +12280,7 @@
 </p:sld>
 </file>
 
-<file path=ppt/slides/slide8.xml><?xml version="1.0" encoding="utf-8"?>
+<file path=ppt/slides/slide9.xml><?xml version="1.0" encoding="utf-8"?>
 <p:sld xmlns:a="http://schemas.openxmlformats.org/drawingml/2006/main" xmlns:r="http://schemas.openxmlformats.org/officeDocument/2006/relationships" xmlns:p="http://schemas.openxmlformats.org/presentationml/2006/main">
   <p:cSld>
     <p:spTree>
@@ -12869,229 +13414,6 @@
       <p:bldP spid="23" grpId="0" animBg="1"/>
     </p:bldLst>
   </p:timing>
-</p:sld>
-</file>
-
-<file path=ppt/slides/slide9.xml><?xml version="1.0" encoding="utf-8"?>
-<p:sld xmlns:a="http://schemas.openxmlformats.org/drawingml/2006/main" xmlns:r="http://schemas.openxmlformats.org/officeDocument/2006/relationships" xmlns:p="http://schemas.openxmlformats.org/presentationml/2006/main">
-  <p:cSld>
-    <p:spTree>
-      <p:nvGrpSpPr>
-        <p:cNvPr id="1" name="">
-          <a:extLst>
-            <a:ext uri="{FF2B5EF4-FFF2-40B4-BE49-F238E27FC236}">
-              <a16:creationId xmlns:a16="http://schemas.microsoft.com/office/drawing/2014/main" id="{D1DE9E7D-34D7-E69A-60E0-2A1A2E83AC4E}"/>
-            </a:ext>
-          </a:extLst>
-        </p:cNvPr>
-        <p:cNvGrpSpPr/>
-        <p:nvPr/>
-      </p:nvGrpSpPr>
-      <p:grpSpPr>
-        <a:xfrm>
-          <a:off x="0" y="0"/>
-          <a:ext cx="0" cy="0"/>
-          <a:chOff x="0" y="0"/>
-          <a:chExt cx="0" cy="0"/>
-        </a:xfrm>
-      </p:grpSpPr>
-      <p:sp>
-        <p:nvSpPr>
-          <p:cNvPr id="2" name="Title 1">
-            <a:extLst>
-              <a:ext uri="{FF2B5EF4-FFF2-40B4-BE49-F238E27FC236}">
-                <a16:creationId xmlns:a16="http://schemas.microsoft.com/office/drawing/2014/main" id="{0C97E257-5254-58A5-D134-275D22ABB3ED}"/>
-              </a:ext>
-            </a:extLst>
-          </p:cNvPr>
-          <p:cNvSpPr>
-            <a:spLocks noGrp="1"/>
-          </p:cNvSpPr>
-          <p:nvPr>
-            <p:ph type="title"/>
-          </p:nvPr>
-        </p:nvSpPr>
-        <p:spPr/>
-        <p:txBody>
-          <a:bodyPr/>
-          <a:lstStyle/>
-          <a:p>
-            <a:r>
-              <a:rPr lang="en-US" dirty="0" err="1"/>
-              <a:t>Nextflow</a:t>
-            </a:r>
-            <a:r>
-              <a:rPr lang="en-US" dirty="0"/>
-              <a:t> components: </a:t>
-            </a:r>
-            <a:r>
-              <a:rPr lang="en-US" b="1" dirty="0"/>
-              <a:t>processes</a:t>
-            </a:r>
-          </a:p>
-        </p:txBody>
-      </p:sp>
-      <p:sp>
-        <p:nvSpPr>
-          <p:cNvPr id="3" name="Content Placeholder 2">
-            <a:extLst>
-              <a:ext uri="{FF2B5EF4-FFF2-40B4-BE49-F238E27FC236}">
-                <a16:creationId xmlns:a16="http://schemas.microsoft.com/office/drawing/2014/main" id="{1CC895E0-3F1B-B147-6FFB-19BA5C8C1CD7}"/>
-              </a:ext>
-            </a:extLst>
-          </p:cNvPr>
-          <p:cNvSpPr>
-            <a:spLocks noGrp="1"/>
-          </p:cNvSpPr>
-          <p:nvPr>
-            <p:ph idx="1"/>
-          </p:nvPr>
-        </p:nvSpPr>
-        <p:spPr/>
-        <p:txBody>
-          <a:bodyPr/>
-          <a:lstStyle/>
-          <a:p>
-            <a:pPr marL="0" indent="0">
-              <a:buNone/>
-            </a:pPr>
-            <a:r>
-              <a:rPr lang="en-US" b="1" dirty="0">
-                <a:solidFill>
-                  <a:schemeClr val="accent2"/>
-                </a:solidFill>
-              </a:rPr>
-              <a:t>Processes</a:t>
-            </a:r>
-            <a:r>
-              <a:rPr lang="en-US" dirty="0"/>
-              <a:t> are the basic computing units in </a:t>
-            </a:r>
-            <a:r>
-              <a:rPr lang="en-US" dirty="0" err="1"/>
-              <a:t>Nextflow</a:t>
-            </a:r>
-            <a:r>
-              <a:rPr lang="en-US" dirty="0"/>
-              <a:t>. Each process defines:</a:t>
-            </a:r>
-          </a:p>
-          <a:p>
-            <a:r>
-              <a:rPr lang="en-US" b="1" dirty="0"/>
-              <a:t>Inputs and outputs</a:t>
-            </a:r>
-            <a:r>
-              <a:rPr lang="en-US" dirty="0"/>
-              <a:t>: Data consumed and produced</a:t>
-            </a:r>
-          </a:p>
-          <a:p>
-            <a:r>
-              <a:rPr lang="en-US" b="1" dirty="0"/>
-              <a:t>Script</a:t>
-            </a:r>
-            <a:r>
-              <a:rPr lang="en-US" dirty="0"/>
-              <a:t>: The actual command or code to execute</a:t>
-            </a:r>
-          </a:p>
-          <a:p>
-            <a:r>
-              <a:rPr lang="en-US" b="1" dirty="0"/>
-              <a:t>Directives</a:t>
-            </a:r>
-            <a:r>
-              <a:rPr lang="en-US" dirty="0"/>
-              <a:t>: Resource requirements (CPU, memory, time)</a:t>
-            </a:r>
-          </a:p>
-          <a:p>
-            <a:pPr marL="0" indent="0">
-              <a:buNone/>
-            </a:pPr>
-            <a:endParaRPr lang="en-US" dirty="0"/>
-          </a:p>
-          <a:p>
-            <a:pPr marL="0" indent="0">
-              <a:buNone/>
-            </a:pPr>
-            <a:r>
-              <a:rPr lang="en-US" dirty="0"/>
-              <a:t>Think of a process as a single step in your pipeline, like "align reads" or ”run inference tool”. Processes are isolated (</a:t>
-            </a:r>
-            <a:r>
-              <a:rPr lang="en-US" b="1" dirty="0">
-                <a:solidFill>
-                  <a:schemeClr val="accent2"/>
-                </a:solidFill>
-              </a:rPr>
-              <a:t>modules</a:t>
-            </a:r>
-            <a:r>
-              <a:rPr lang="en-US" dirty="0"/>
-              <a:t>)and can be executed independently, enabling parallelization. </a:t>
-            </a:r>
-          </a:p>
-        </p:txBody>
-      </p:sp>
-      <p:pic>
-        <p:nvPicPr>
-          <p:cNvPr id="4098" name="Picture 2" descr="Manufacturing Factory Tool Icons - Free SVG &amp; PNG Manufacturing Factory Tool  Images - Noun Project">
-            <a:extLst>
-              <a:ext uri="{FF2B5EF4-FFF2-40B4-BE49-F238E27FC236}">
-                <a16:creationId xmlns:a16="http://schemas.microsoft.com/office/drawing/2014/main" id="{CF13FCC3-795D-264A-652A-5CE31D964342}"/>
-              </a:ext>
-            </a:extLst>
-          </p:cNvPr>
-          <p:cNvPicPr>
-            <a:picLocks noChangeAspect="1" noChangeArrowheads="1"/>
-          </p:cNvPicPr>
-          <p:nvPr/>
-        </p:nvPicPr>
-        <p:blipFill>
-          <a:blip r:embed="rId2">
-            <a:extLst>
-              <a:ext uri="{28A0092B-C50C-407E-A947-70E740481C1C}">
-                <a14:useLocalDpi xmlns:a14="http://schemas.microsoft.com/office/drawing/2010/main" val="0"/>
-              </a:ext>
-            </a:extLst>
-          </a:blip>
-          <a:srcRect/>
-          <a:stretch>
-            <a:fillRect/>
-          </a:stretch>
-        </p:blipFill>
-        <p:spPr bwMode="auto">
-          <a:xfrm>
-            <a:off x="9004461" y="585043"/>
-            <a:ext cx="834020" cy="834020"/>
-          </a:xfrm>
-          <a:prstGeom prst="rect">
-            <a:avLst/>
-          </a:prstGeom>
-          <a:noFill/>
-          <a:extLst>
-            <a:ext uri="{909E8E84-426E-40DD-AFC4-6F175D3DCCD1}">
-              <a14:hiddenFill xmlns:a14="http://schemas.microsoft.com/office/drawing/2010/main">
-                <a:solidFill>
-                  <a:srgbClr val="FFFFFF"/>
-                </a:solidFill>
-              </a14:hiddenFill>
-            </a:ext>
-          </a:extLst>
-        </p:spPr>
-      </p:pic>
-    </p:spTree>
-    <p:extLst>
-      <p:ext uri="{BB962C8B-B14F-4D97-AF65-F5344CB8AC3E}">
-        <p14:creationId xmlns:p14="http://schemas.microsoft.com/office/powerpoint/2010/main" val="3903298263"/>
-      </p:ext>
-    </p:extLst>
-  </p:cSld>
-  <p:clrMapOvr>
-    <a:masterClrMapping/>
-  </p:clrMapOvr>
 </p:sld>
 </file>
 

</xml_diff>